<commit_message>
swapping with original master deck, naming convention, case study crated using ai adding to existing excel, editing downloaded file
</commit_message>
<xml_diff>
--- a/data/templates/skills_templates.pptx
+++ b/data/templates/skills_templates.pptx
@@ -8,6 +8,7 @@
     <p:sldId id="256" r:id="rId7"/>
     <p:sldId id="257" r:id="rId9"/>
     <p:sldId id="258" r:id="rId10"/>
+    <p:sldId id="259" r:id="rId11"/>
   </p:sldIdLst>
   <p:sldSz cx="12188952" cy="6858000" type="screen4x3"/>
   <p:notesSz cx="6858000" cy="9144000"/>
@@ -645,6 +646,76 @@
           <a:p>
             <a:r>
               <a:t>J2W_TEMPLATE: company_footprint</a:t>
+            </a:r>
+          </a:p>
+        </p:txBody>
+      </p:sp>
+      <p:sp>
+        <p:nvSpPr>
+          <p:cNvPr id="4" name="Slide Number Placeholder 3"/>
+          <p:cNvSpPr>
+            <a:spLocks noGrp="1"/>
+          </p:cNvSpPr>
+          <p:nvPr>
+            <p:ph type="sldNum" idx="5" sz="quarter"/>
+          </p:nvPr>
+        </p:nvSpPr>
+        <p:spPr/>
+      </p:sp>
+    </p:spTree>
+  </p:cSld>
+  <p:clrMapOvr>
+    <a:masterClrMapping/>
+  </p:clrMapOvr>
+</p:notes>
+</file>
+
+<file path=ppt/notesSlides/notesSlide4.xml><?xml version="1.0" encoding="utf-8"?>
+<p:notes xmlns:a="http://schemas.openxmlformats.org/drawingml/2006/main" xmlns:p="http://schemas.openxmlformats.org/presentationml/2006/main" xmlns:r="http://schemas.openxmlformats.org/officeDocument/2006/relationships">
+  <p:cSld>
+    <p:spTree>
+      <p:nvGrpSpPr>
+        <p:cNvPr id="1" name=""/>
+        <p:cNvGrpSpPr/>
+        <p:nvPr/>
+      </p:nvGrpSpPr>
+      <p:grpSpPr>
+        <a:xfrm>
+          <a:off x="0" y="0"/>
+          <a:ext cx="0" cy="0"/>
+          <a:chOff x="0" y="0"/>
+          <a:chExt cx="0" cy="0"/>
+        </a:xfrm>
+      </p:grpSpPr>
+      <p:sp>
+        <p:nvSpPr>
+          <p:cNvPr id="2" name="Slide Image Placeholder 1"/>
+          <p:cNvSpPr>
+            <a:spLocks noGrp="1"/>
+          </p:cNvSpPr>
+          <p:nvPr>
+            <p:ph type="sldImg" idx="2"/>
+          </p:nvPr>
+        </p:nvSpPr>
+        <p:spPr/>
+      </p:sp>
+      <p:sp>
+        <p:nvSpPr>
+          <p:cNvPr id="3" name="Notes Placeholder 2"/>
+          <p:cNvSpPr>
+            <a:spLocks noGrp="1"/>
+          </p:cNvSpPr>
+          <p:nvPr>
+            <p:ph type="body" idx="3" sz="quarter"/>
+          </p:nvPr>
+        </p:nvSpPr>
+        <p:spPr/>
+        <p:txBody>
+          <a:bodyPr/>
+          <a:lstStyle/>
+          <a:p>
+            <a:r>
+              <a:t>J2W_TEMPLATE: target_skill_profile</a:t>
             </a:r>
           </a:p>
         </p:txBody>
@@ -7369,6 +7440,2595 @@
                 <a:latin typeface="Calibri"/>
               </a:rPr>
               <a:t>{{CHART}}</a:t>
+            </a:r>
+          </a:p>
+        </p:txBody>
+      </p:sp>
+    </p:spTree>
+  </p:cSld>
+  <p:clrMapOvr>
+    <a:masterClrMapping/>
+  </p:clrMapOvr>
+</p:sld>
+</file>
+
+<file path=ppt/slides/slide4.xml><?xml version="1.0" encoding="utf-8"?>
+<p:sld xmlns:a="http://schemas.openxmlformats.org/drawingml/2006/main" xmlns:p="http://schemas.openxmlformats.org/presentationml/2006/main" xmlns:r="http://schemas.openxmlformats.org/officeDocument/2006/relationships">
+  <p:cSld>
+    <p:spTree>
+      <p:nvGrpSpPr>
+        <p:cNvPr id="1" name=""/>
+        <p:cNvGrpSpPr/>
+        <p:nvPr/>
+      </p:nvGrpSpPr>
+      <p:grpSpPr/>
+      <p:sp>
+        <p:nvSpPr>
+          <p:cNvPr id="2" name="Rectangle 1"/>
+          <p:cNvSpPr/>
+          <p:nvPr/>
+        </p:nvSpPr>
+        <p:spPr>
+          <a:xfrm>
+            <a:off x="0" y="0"/>
+            <a:ext cx="5852160" cy="91440"/>
+          </a:xfrm>
+          <a:prstGeom prst="rect">
+            <a:avLst/>
+          </a:prstGeom>
+          <a:solidFill>
+            <a:srgbClr val="C02026"/>
+          </a:solidFill>
+          <a:ln>
+            <a:noFill/>
+          </a:ln>
+          <a:effectLst/>
+        </p:spPr>
+        <p:style>
+          <a:lnRef idx="1">
+            <a:schemeClr val="accent1"/>
+          </a:lnRef>
+          <a:fillRef idx="3">
+            <a:schemeClr val="accent1"/>
+          </a:fillRef>
+          <a:effectRef idx="2">
+            <a:schemeClr val="accent1"/>
+          </a:effectRef>
+          <a:fontRef idx="minor">
+            <a:schemeClr val="lt1"/>
+          </a:fontRef>
+        </p:style>
+        <p:txBody>
+          <a:bodyPr rtlCol="0" anchor="ctr"/>
+          <a:lstStyle/>
+          <a:p>
+            <a:pPr algn="ctr"/>
+          </a:p>
+        </p:txBody>
+      </p:sp>
+      <p:sp>
+        <p:nvSpPr>
+          <p:cNvPr id="3" name="Rectangle 2"/>
+          <p:cNvSpPr/>
+          <p:nvPr/>
+        </p:nvSpPr>
+        <p:spPr>
+          <a:xfrm>
+            <a:off x="5852160" y="0"/>
+            <a:ext cx="6336792" cy="91440"/>
+          </a:xfrm>
+          <a:prstGeom prst="rect">
+            <a:avLst/>
+          </a:prstGeom>
+          <a:solidFill>
+            <a:srgbClr val="3A8B82"/>
+          </a:solidFill>
+          <a:ln>
+            <a:noFill/>
+          </a:ln>
+          <a:effectLst/>
+        </p:spPr>
+        <p:style>
+          <a:lnRef idx="1">
+            <a:schemeClr val="accent1"/>
+          </a:lnRef>
+          <a:fillRef idx="3">
+            <a:schemeClr val="accent1"/>
+          </a:fillRef>
+          <a:effectRef idx="2">
+            <a:schemeClr val="accent1"/>
+          </a:effectRef>
+          <a:fontRef idx="minor">
+            <a:schemeClr val="lt1"/>
+          </a:fontRef>
+        </p:style>
+        <p:txBody>
+          <a:bodyPr rtlCol="0" anchor="ctr"/>
+          <a:lstStyle/>
+          <a:p>
+            <a:pPr algn="ctr"/>
+          </a:p>
+        </p:txBody>
+      </p:sp>
+      <p:sp>
+        <p:nvSpPr>
+          <p:cNvPr id="4" name="Rectangle 3"/>
+          <p:cNvSpPr/>
+          <p:nvPr/>
+        </p:nvSpPr>
+        <p:spPr>
+          <a:xfrm>
+            <a:off x="228600" y="274320"/>
+            <a:ext cx="59436" cy="475488"/>
+          </a:xfrm>
+          <a:prstGeom prst="rect">
+            <a:avLst/>
+          </a:prstGeom>
+          <a:solidFill>
+            <a:srgbClr val="C02026"/>
+          </a:solidFill>
+          <a:ln>
+            <a:noFill/>
+          </a:ln>
+          <a:effectLst/>
+        </p:spPr>
+        <p:style>
+          <a:lnRef idx="1">
+            <a:schemeClr val="accent1"/>
+          </a:lnRef>
+          <a:fillRef idx="3">
+            <a:schemeClr val="accent1"/>
+          </a:fillRef>
+          <a:effectRef idx="2">
+            <a:schemeClr val="accent1"/>
+          </a:effectRef>
+          <a:fontRef idx="minor">
+            <a:schemeClr val="lt1"/>
+          </a:fontRef>
+        </p:style>
+        <p:txBody>
+          <a:bodyPr rtlCol="0" anchor="ctr"/>
+          <a:lstStyle/>
+          <a:p>
+            <a:pPr algn="ctr"/>
+          </a:p>
+        </p:txBody>
+      </p:sp>
+      <p:sp>
+        <p:nvSpPr>
+          <p:cNvPr id="5" name="TextBox 4"/>
+          <p:cNvSpPr txBox="1"/>
+          <p:nvPr/>
+        </p:nvSpPr>
+        <p:spPr>
+          <a:xfrm>
+            <a:off x="402336" y="237744"/>
+            <a:ext cx="11338560" cy="475488"/>
+          </a:xfrm>
+          <a:prstGeom prst="rect">
+            <a:avLst/>
+          </a:prstGeom>
+          <a:noFill/>
+        </p:spPr>
+        <p:txBody>
+          <a:bodyPr wrap="square" anchor="t" tIns="0" bIns="0">
+            <a:spAutoFit/>
+          </a:bodyPr>
+          <a:lstStyle/>
+          <a:p>
+            <a:pPr algn="l"/>
+            <a:r>
+              <a:rPr sz="2400" b="1" i="0">
+                <a:solidFill>
+                  <a:srgbClr val="111110"/>
+                </a:solidFill>
+                <a:latin typeface="Oswald"/>
+              </a:rPr>
+              <a:t>TARGET SKILL PROFILE</a:t>
+            </a:r>
+          </a:p>
+        </p:txBody>
+      </p:sp>
+      <p:sp>
+        <p:nvSpPr>
+          <p:cNvPr id="6" name="TextBox 5"/>
+          <p:cNvSpPr txBox="1"/>
+          <p:nvPr/>
+        </p:nvSpPr>
+        <p:spPr>
+          <a:xfrm>
+            <a:off x="402336" y="731520"/>
+            <a:ext cx="11521440" cy="310896"/>
+          </a:xfrm>
+          <a:prstGeom prst="rect">
+            <a:avLst/>
+          </a:prstGeom>
+          <a:noFill/>
+        </p:spPr>
+        <p:txBody>
+          <a:bodyPr wrap="square" anchor="t" tIns="0" bIns="0">
+            <a:spAutoFit/>
+          </a:bodyPr>
+          <a:lstStyle/>
+          <a:p>
+            <a:pPr algn="l"/>
+            <a:r>
+              <a:rPr sz="1500" b="1" i="0">
+                <a:solidFill>
+                  <a:srgbClr val="3A8B82"/>
+                </a:solidFill>
+                <a:latin typeface="Roboto Condensed"/>
+              </a:rPr>
+              <a:t>Domain Knowledge, Technical Stack And Background We're Hiring Against</a:t>
+            </a:r>
+          </a:p>
+        </p:txBody>
+      </p:sp>
+      <p:sp>
+        <p:nvSpPr>
+          <p:cNvPr id="7" name="Rectangle 6"/>
+          <p:cNvSpPr/>
+          <p:nvPr/>
+        </p:nvSpPr>
+        <p:spPr>
+          <a:xfrm>
+            <a:off x="0" y="6766560"/>
+            <a:ext cx="12188952" cy="91440"/>
+          </a:xfrm>
+          <a:prstGeom prst="rect">
+            <a:avLst/>
+          </a:prstGeom>
+          <a:solidFill>
+            <a:srgbClr val="3A8B82"/>
+          </a:solidFill>
+          <a:ln>
+            <a:noFill/>
+          </a:ln>
+          <a:effectLst/>
+        </p:spPr>
+        <p:style>
+          <a:lnRef idx="1">
+            <a:schemeClr val="accent1"/>
+          </a:lnRef>
+          <a:fillRef idx="3">
+            <a:schemeClr val="accent1"/>
+          </a:fillRef>
+          <a:effectRef idx="2">
+            <a:schemeClr val="accent1"/>
+          </a:effectRef>
+          <a:fontRef idx="minor">
+            <a:schemeClr val="lt1"/>
+          </a:fontRef>
+        </p:style>
+        <p:txBody>
+          <a:bodyPr rtlCol="0" anchor="ctr"/>
+          <a:lstStyle/>
+          <a:p>
+            <a:pPr algn="ctr"/>
+          </a:p>
+        </p:txBody>
+      </p:sp>
+      <p:sp>
+        <p:nvSpPr>
+          <p:cNvPr id="8" name="Rectangle 7"/>
+          <p:cNvSpPr/>
+          <p:nvPr/>
+        </p:nvSpPr>
+        <p:spPr>
+          <a:xfrm>
+            <a:off x="274320" y="1234440"/>
+            <a:ext cx="3758184" cy="438912"/>
+          </a:xfrm>
+          <a:prstGeom prst="rect">
+            <a:avLst/>
+          </a:prstGeom>
+          <a:solidFill>
+            <a:srgbClr val="3A8B82"/>
+          </a:solidFill>
+          <a:ln>
+            <a:noFill/>
+          </a:ln>
+          <a:effectLst/>
+        </p:spPr>
+        <p:style>
+          <a:lnRef idx="1">
+            <a:schemeClr val="accent1"/>
+          </a:lnRef>
+          <a:fillRef idx="3">
+            <a:schemeClr val="accent1"/>
+          </a:fillRef>
+          <a:effectRef idx="2">
+            <a:schemeClr val="accent1"/>
+          </a:effectRef>
+          <a:fontRef idx="minor">
+            <a:schemeClr val="lt1"/>
+          </a:fontRef>
+        </p:style>
+        <p:txBody>
+          <a:bodyPr rtlCol="0" anchor="ctr"/>
+          <a:lstStyle/>
+          <a:p>
+            <a:pPr algn="ctr"/>
+          </a:p>
+        </p:txBody>
+      </p:sp>
+      <p:sp>
+        <p:nvSpPr>
+          <p:cNvPr id="9" name="TextBox 8"/>
+          <p:cNvSpPr txBox="1"/>
+          <p:nvPr/>
+        </p:nvSpPr>
+        <p:spPr>
+          <a:xfrm>
+            <a:off x="274320" y="1234440"/>
+            <a:ext cx="3758184" cy="438912"/>
+          </a:xfrm>
+          <a:prstGeom prst="rect">
+            <a:avLst/>
+          </a:prstGeom>
+          <a:noFill/>
+        </p:spPr>
+        <p:txBody>
+          <a:bodyPr wrap="square" anchor="ctr" tIns="0" bIns="0">
+            <a:spAutoFit/>
+          </a:bodyPr>
+          <a:lstStyle/>
+          <a:p>
+            <a:pPr algn="ctr"/>
+            <a:r>
+              <a:rPr sz="1300" b="1" i="0">
+                <a:solidFill>
+                  <a:srgbClr val="FFFFFF"/>
+                </a:solidFill>
+                <a:latin typeface="Calibri"/>
+              </a:rPr>
+              <a:t>DOMAIN EXPERTISE</a:t>
+            </a:r>
+          </a:p>
+        </p:txBody>
+      </p:sp>
+      <p:sp>
+        <p:nvSpPr>
+          <p:cNvPr id="10" name="Rectangle 9"/>
+          <p:cNvSpPr/>
+          <p:nvPr/>
+        </p:nvSpPr>
+        <p:spPr>
+          <a:xfrm>
+            <a:off x="274320" y="1801368"/>
+            <a:ext cx="3758184" cy="737615"/>
+          </a:xfrm>
+          <a:prstGeom prst="rect">
+            <a:avLst/>
+          </a:prstGeom>
+          <a:solidFill>
+            <a:srgbClr val="E9F4F2"/>
+          </a:solidFill>
+          <a:ln w="6350">
+            <a:solidFill>
+              <a:srgbClr val="DEDEDE"/>
+            </a:solidFill>
+          </a:ln>
+          <a:effectLst/>
+        </p:spPr>
+        <p:style>
+          <a:lnRef idx="1">
+            <a:schemeClr val="accent1"/>
+          </a:lnRef>
+          <a:fillRef idx="3">
+            <a:schemeClr val="accent1"/>
+          </a:fillRef>
+          <a:effectRef idx="2">
+            <a:schemeClr val="accent1"/>
+          </a:effectRef>
+          <a:fontRef idx="minor">
+            <a:schemeClr val="lt1"/>
+          </a:fontRef>
+        </p:style>
+        <p:txBody>
+          <a:bodyPr rtlCol="0" anchor="ctr"/>
+          <a:lstStyle/>
+          <a:p>
+            <a:pPr algn="ctr"/>
+          </a:p>
+        </p:txBody>
+      </p:sp>
+      <p:sp>
+        <p:nvSpPr>
+          <p:cNvPr id="11" name="TextBox 10"/>
+          <p:cNvSpPr txBox="1"/>
+          <p:nvPr/>
+        </p:nvSpPr>
+        <p:spPr>
+          <a:xfrm>
+            <a:off x="402336" y="1874520"/>
+            <a:ext cx="3502152" cy="368807"/>
+          </a:xfrm>
+          <a:prstGeom prst="rect">
+            <a:avLst/>
+          </a:prstGeom>
+          <a:noFill/>
+        </p:spPr>
+        <p:txBody>
+          <a:bodyPr wrap="square" anchor="t" tIns="0" bIns="0">
+            <a:spAutoFit/>
+          </a:bodyPr>
+          <a:lstStyle/>
+          <a:p>
+            <a:pPr algn="l"/>
+            <a:r>
+              <a:rPr sz="1200" b="1" i="0">
+                <a:solidFill>
+                  <a:srgbClr val="3A8B82"/>
+                </a:solidFill>
+                <a:latin typeface="Raleway"/>
+              </a:rPr>
+              <a:t>{{DOM_1_T}}</a:t>
+            </a:r>
+          </a:p>
+        </p:txBody>
+      </p:sp>
+      <p:sp>
+        <p:nvSpPr>
+          <p:cNvPr id="12" name="TextBox 11"/>
+          <p:cNvSpPr txBox="1"/>
+          <p:nvPr/>
+        </p:nvSpPr>
+        <p:spPr>
+          <a:xfrm>
+            <a:off x="402336" y="2170176"/>
+            <a:ext cx="3502152" cy="295655"/>
+          </a:xfrm>
+          <a:prstGeom prst="rect">
+            <a:avLst/>
+          </a:prstGeom>
+          <a:noFill/>
+        </p:spPr>
+        <p:txBody>
+          <a:bodyPr wrap="square" anchor="t" tIns="0" bIns="0">
+            <a:normAutofit/>
+          </a:bodyPr>
+          <a:lstStyle/>
+          <a:p>
+            <a:pPr algn="l"/>
+            <a:r>
+              <a:rPr sz="1200" b="0" i="0">
+                <a:solidFill>
+                  <a:srgbClr val="6E6E69"/>
+                </a:solidFill>
+                <a:latin typeface="Raleway"/>
+              </a:rPr>
+              <a:t>{{DOM_1_D}}</a:t>
+            </a:r>
+          </a:p>
+        </p:txBody>
+      </p:sp>
+      <p:sp>
+        <p:nvSpPr>
+          <p:cNvPr id="13" name="Rectangle 12"/>
+          <p:cNvSpPr/>
+          <p:nvPr/>
+        </p:nvSpPr>
+        <p:spPr>
+          <a:xfrm>
+            <a:off x="274320" y="2621280"/>
+            <a:ext cx="3758184" cy="737615"/>
+          </a:xfrm>
+          <a:prstGeom prst="rect">
+            <a:avLst/>
+          </a:prstGeom>
+          <a:solidFill>
+            <a:srgbClr val="E9F4F2"/>
+          </a:solidFill>
+          <a:ln w="6350">
+            <a:solidFill>
+              <a:srgbClr val="DEDEDE"/>
+            </a:solidFill>
+          </a:ln>
+          <a:effectLst/>
+        </p:spPr>
+        <p:style>
+          <a:lnRef idx="1">
+            <a:schemeClr val="accent1"/>
+          </a:lnRef>
+          <a:fillRef idx="3">
+            <a:schemeClr val="accent1"/>
+          </a:fillRef>
+          <a:effectRef idx="2">
+            <a:schemeClr val="accent1"/>
+          </a:effectRef>
+          <a:fontRef idx="minor">
+            <a:schemeClr val="lt1"/>
+          </a:fontRef>
+        </p:style>
+        <p:txBody>
+          <a:bodyPr rtlCol="0" anchor="ctr"/>
+          <a:lstStyle/>
+          <a:p>
+            <a:pPr algn="ctr"/>
+          </a:p>
+        </p:txBody>
+      </p:sp>
+      <p:sp>
+        <p:nvSpPr>
+          <p:cNvPr id="14" name="TextBox 13"/>
+          <p:cNvSpPr txBox="1"/>
+          <p:nvPr/>
+        </p:nvSpPr>
+        <p:spPr>
+          <a:xfrm>
+            <a:off x="402336" y="2694432"/>
+            <a:ext cx="3502152" cy="368807"/>
+          </a:xfrm>
+          <a:prstGeom prst="rect">
+            <a:avLst/>
+          </a:prstGeom>
+          <a:noFill/>
+        </p:spPr>
+        <p:txBody>
+          <a:bodyPr wrap="square" anchor="t" tIns="0" bIns="0">
+            <a:spAutoFit/>
+          </a:bodyPr>
+          <a:lstStyle/>
+          <a:p>
+            <a:pPr algn="l"/>
+            <a:r>
+              <a:rPr sz="1200" b="1" i="0">
+                <a:solidFill>
+                  <a:srgbClr val="3A8B82"/>
+                </a:solidFill>
+                <a:latin typeface="Raleway"/>
+              </a:rPr>
+              <a:t>{{DOM_2_T}}</a:t>
+            </a:r>
+          </a:p>
+        </p:txBody>
+      </p:sp>
+      <p:sp>
+        <p:nvSpPr>
+          <p:cNvPr id="15" name="TextBox 14"/>
+          <p:cNvSpPr txBox="1"/>
+          <p:nvPr/>
+        </p:nvSpPr>
+        <p:spPr>
+          <a:xfrm>
+            <a:off x="402336" y="2990088"/>
+            <a:ext cx="3502152" cy="295655"/>
+          </a:xfrm>
+          <a:prstGeom prst="rect">
+            <a:avLst/>
+          </a:prstGeom>
+          <a:noFill/>
+        </p:spPr>
+        <p:txBody>
+          <a:bodyPr wrap="square" anchor="t" tIns="0" bIns="0">
+            <a:normAutofit/>
+          </a:bodyPr>
+          <a:lstStyle/>
+          <a:p>
+            <a:pPr algn="l"/>
+            <a:r>
+              <a:rPr sz="1200" b="0" i="0">
+                <a:solidFill>
+                  <a:srgbClr val="6E6E69"/>
+                </a:solidFill>
+                <a:latin typeface="Raleway"/>
+              </a:rPr>
+              <a:t>{{DOM_2_D}}</a:t>
+            </a:r>
+          </a:p>
+        </p:txBody>
+      </p:sp>
+      <p:sp>
+        <p:nvSpPr>
+          <p:cNvPr id="16" name="Rectangle 15"/>
+          <p:cNvSpPr/>
+          <p:nvPr/>
+        </p:nvSpPr>
+        <p:spPr>
+          <a:xfrm>
+            <a:off x="274320" y="3441192"/>
+            <a:ext cx="3758184" cy="737615"/>
+          </a:xfrm>
+          <a:prstGeom prst="rect">
+            <a:avLst/>
+          </a:prstGeom>
+          <a:solidFill>
+            <a:srgbClr val="E9F4F2"/>
+          </a:solidFill>
+          <a:ln w="6350">
+            <a:solidFill>
+              <a:srgbClr val="DEDEDE"/>
+            </a:solidFill>
+          </a:ln>
+          <a:effectLst/>
+        </p:spPr>
+        <p:style>
+          <a:lnRef idx="1">
+            <a:schemeClr val="accent1"/>
+          </a:lnRef>
+          <a:fillRef idx="3">
+            <a:schemeClr val="accent1"/>
+          </a:fillRef>
+          <a:effectRef idx="2">
+            <a:schemeClr val="accent1"/>
+          </a:effectRef>
+          <a:fontRef idx="minor">
+            <a:schemeClr val="lt1"/>
+          </a:fontRef>
+        </p:style>
+        <p:txBody>
+          <a:bodyPr rtlCol="0" anchor="ctr"/>
+          <a:lstStyle/>
+          <a:p>
+            <a:pPr algn="ctr"/>
+          </a:p>
+        </p:txBody>
+      </p:sp>
+      <p:sp>
+        <p:nvSpPr>
+          <p:cNvPr id="17" name="TextBox 16"/>
+          <p:cNvSpPr txBox="1"/>
+          <p:nvPr/>
+        </p:nvSpPr>
+        <p:spPr>
+          <a:xfrm>
+            <a:off x="402336" y="3514344"/>
+            <a:ext cx="3502152" cy="368807"/>
+          </a:xfrm>
+          <a:prstGeom prst="rect">
+            <a:avLst/>
+          </a:prstGeom>
+          <a:noFill/>
+        </p:spPr>
+        <p:txBody>
+          <a:bodyPr wrap="square" anchor="t" tIns="0" bIns="0">
+            <a:spAutoFit/>
+          </a:bodyPr>
+          <a:lstStyle/>
+          <a:p>
+            <a:pPr algn="l"/>
+            <a:r>
+              <a:rPr sz="1200" b="1" i="0">
+                <a:solidFill>
+                  <a:srgbClr val="3A8B82"/>
+                </a:solidFill>
+                <a:latin typeface="Raleway"/>
+              </a:rPr>
+              <a:t>{{DOM_3_T}}</a:t>
+            </a:r>
+          </a:p>
+        </p:txBody>
+      </p:sp>
+      <p:sp>
+        <p:nvSpPr>
+          <p:cNvPr id="18" name="TextBox 17"/>
+          <p:cNvSpPr txBox="1"/>
+          <p:nvPr/>
+        </p:nvSpPr>
+        <p:spPr>
+          <a:xfrm>
+            <a:off x="402336" y="3809999"/>
+            <a:ext cx="3502152" cy="295655"/>
+          </a:xfrm>
+          <a:prstGeom prst="rect">
+            <a:avLst/>
+          </a:prstGeom>
+          <a:noFill/>
+        </p:spPr>
+        <p:txBody>
+          <a:bodyPr wrap="square" anchor="t" tIns="0" bIns="0">
+            <a:normAutofit/>
+          </a:bodyPr>
+          <a:lstStyle/>
+          <a:p>
+            <a:pPr algn="l"/>
+            <a:r>
+              <a:rPr sz="1200" b="0" i="0">
+                <a:solidFill>
+                  <a:srgbClr val="6E6E69"/>
+                </a:solidFill>
+                <a:latin typeface="Raleway"/>
+              </a:rPr>
+              <a:t>{{DOM_3_D}}</a:t>
+            </a:r>
+          </a:p>
+        </p:txBody>
+      </p:sp>
+      <p:sp>
+        <p:nvSpPr>
+          <p:cNvPr id="19" name="Rectangle 18"/>
+          <p:cNvSpPr/>
+          <p:nvPr/>
+        </p:nvSpPr>
+        <p:spPr>
+          <a:xfrm>
+            <a:off x="274320" y="4261104"/>
+            <a:ext cx="3758184" cy="737615"/>
+          </a:xfrm>
+          <a:prstGeom prst="rect">
+            <a:avLst/>
+          </a:prstGeom>
+          <a:solidFill>
+            <a:srgbClr val="E9F4F2"/>
+          </a:solidFill>
+          <a:ln w="6350">
+            <a:solidFill>
+              <a:srgbClr val="DEDEDE"/>
+            </a:solidFill>
+          </a:ln>
+          <a:effectLst/>
+        </p:spPr>
+        <p:style>
+          <a:lnRef idx="1">
+            <a:schemeClr val="accent1"/>
+          </a:lnRef>
+          <a:fillRef idx="3">
+            <a:schemeClr val="accent1"/>
+          </a:fillRef>
+          <a:effectRef idx="2">
+            <a:schemeClr val="accent1"/>
+          </a:effectRef>
+          <a:fontRef idx="minor">
+            <a:schemeClr val="lt1"/>
+          </a:fontRef>
+        </p:style>
+        <p:txBody>
+          <a:bodyPr rtlCol="0" anchor="ctr"/>
+          <a:lstStyle/>
+          <a:p>
+            <a:pPr algn="ctr"/>
+          </a:p>
+        </p:txBody>
+      </p:sp>
+      <p:sp>
+        <p:nvSpPr>
+          <p:cNvPr id="20" name="TextBox 19"/>
+          <p:cNvSpPr txBox="1"/>
+          <p:nvPr/>
+        </p:nvSpPr>
+        <p:spPr>
+          <a:xfrm>
+            <a:off x="402336" y="4334256"/>
+            <a:ext cx="3502152" cy="368807"/>
+          </a:xfrm>
+          <a:prstGeom prst="rect">
+            <a:avLst/>
+          </a:prstGeom>
+          <a:noFill/>
+        </p:spPr>
+        <p:txBody>
+          <a:bodyPr wrap="square" anchor="t" tIns="0" bIns="0">
+            <a:spAutoFit/>
+          </a:bodyPr>
+          <a:lstStyle/>
+          <a:p>
+            <a:pPr algn="l"/>
+            <a:r>
+              <a:rPr sz="1200" b="1" i="0">
+                <a:solidFill>
+                  <a:srgbClr val="3A8B82"/>
+                </a:solidFill>
+                <a:latin typeface="Raleway"/>
+              </a:rPr>
+              <a:t>{{DOM_4_T}}</a:t>
+            </a:r>
+          </a:p>
+        </p:txBody>
+      </p:sp>
+      <p:sp>
+        <p:nvSpPr>
+          <p:cNvPr id="21" name="TextBox 20"/>
+          <p:cNvSpPr txBox="1"/>
+          <p:nvPr/>
+        </p:nvSpPr>
+        <p:spPr>
+          <a:xfrm>
+            <a:off x="402336" y="4629912"/>
+            <a:ext cx="3502152" cy="295655"/>
+          </a:xfrm>
+          <a:prstGeom prst="rect">
+            <a:avLst/>
+          </a:prstGeom>
+          <a:noFill/>
+        </p:spPr>
+        <p:txBody>
+          <a:bodyPr wrap="square" anchor="t" tIns="0" bIns="0">
+            <a:normAutofit/>
+          </a:bodyPr>
+          <a:lstStyle/>
+          <a:p>
+            <a:pPr algn="l"/>
+            <a:r>
+              <a:rPr sz="1200" b="0" i="0">
+                <a:solidFill>
+                  <a:srgbClr val="6E6E69"/>
+                </a:solidFill>
+                <a:latin typeface="Raleway"/>
+              </a:rPr>
+              <a:t>{{DOM_4_D}}</a:t>
+            </a:r>
+          </a:p>
+        </p:txBody>
+      </p:sp>
+      <p:sp>
+        <p:nvSpPr>
+          <p:cNvPr id="22" name="Rectangle 21"/>
+          <p:cNvSpPr/>
+          <p:nvPr/>
+        </p:nvSpPr>
+        <p:spPr>
+          <a:xfrm>
+            <a:off x="274320" y="5081016"/>
+            <a:ext cx="3758184" cy="737615"/>
+          </a:xfrm>
+          <a:prstGeom prst="rect">
+            <a:avLst/>
+          </a:prstGeom>
+          <a:solidFill>
+            <a:srgbClr val="E9F4F2"/>
+          </a:solidFill>
+          <a:ln w="6350">
+            <a:solidFill>
+              <a:srgbClr val="DEDEDE"/>
+            </a:solidFill>
+          </a:ln>
+          <a:effectLst/>
+        </p:spPr>
+        <p:style>
+          <a:lnRef idx="1">
+            <a:schemeClr val="accent1"/>
+          </a:lnRef>
+          <a:fillRef idx="3">
+            <a:schemeClr val="accent1"/>
+          </a:fillRef>
+          <a:effectRef idx="2">
+            <a:schemeClr val="accent1"/>
+          </a:effectRef>
+          <a:fontRef idx="minor">
+            <a:schemeClr val="lt1"/>
+          </a:fontRef>
+        </p:style>
+        <p:txBody>
+          <a:bodyPr rtlCol="0" anchor="ctr"/>
+          <a:lstStyle/>
+          <a:p>
+            <a:pPr algn="ctr"/>
+          </a:p>
+        </p:txBody>
+      </p:sp>
+      <p:sp>
+        <p:nvSpPr>
+          <p:cNvPr id="23" name="TextBox 22"/>
+          <p:cNvSpPr txBox="1"/>
+          <p:nvPr/>
+        </p:nvSpPr>
+        <p:spPr>
+          <a:xfrm>
+            <a:off x="402336" y="5154168"/>
+            <a:ext cx="3502152" cy="368807"/>
+          </a:xfrm>
+          <a:prstGeom prst="rect">
+            <a:avLst/>
+          </a:prstGeom>
+          <a:noFill/>
+        </p:spPr>
+        <p:txBody>
+          <a:bodyPr wrap="square" anchor="t" tIns="0" bIns="0">
+            <a:spAutoFit/>
+          </a:bodyPr>
+          <a:lstStyle/>
+          <a:p>
+            <a:pPr algn="l"/>
+            <a:r>
+              <a:rPr sz="1200" b="1" i="0">
+                <a:solidFill>
+                  <a:srgbClr val="3A8B82"/>
+                </a:solidFill>
+                <a:latin typeface="Raleway"/>
+              </a:rPr>
+              <a:t>{{DOM_5_T}}</a:t>
+            </a:r>
+          </a:p>
+        </p:txBody>
+      </p:sp>
+      <p:sp>
+        <p:nvSpPr>
+          <p:cNvPr id="24" name="TextBox 23"/>
+          <p:cNvSpPr txBox="1"/>
+          <p:nvPr/>
+        </p:nvSpPr>
+        <p:spPr>
+          <a:xfrm>
+            <a:off x="402336" y="5449824"/>
+            <a:ext cx="3502152" cy="295655"/>
+          </a:xfrm>
+          <a:prstGeom prst="rect">
+            <a:avLst/>
+          </a:prstGeom>
+          <a:noFill/>
+        </p:spPr>
+        <p:txBody>
+          <a:bodyPr wrap="square" anchor="t" tIns="0" bIns="0">
+            <a:normAutofit/>
+          </a:bodyPr>
+          <a:lstStyle/>
+          <a:p>
+            <a:pPr algn="l"/>
+            <a:r>
+              <a:rPr sz="1200" b="0" i="0">
+                <a:solidFill>
+                  <a:srgbClr val="6E6E69"/>
+                </a:solidFill>
+                <a:latin typeface="Raleway"/>
+              </a:rPr>
+              <a:t>{{DOM_5_D}}</a:t>
+            </a:r>
+          </a:p>
+        </p:txBody>
+      </p:sp>
+      <p:sp>
+        <p:nvSpPr>
+          <p:cNvPr id="25" name="Rectangle 24"/>
+          <p:cNvSpPr/>
+          <p:nvPr/>
+        </p:nvSpPr>
+        <p:spPr>
+          <a:xfrm>
+            <a:off x="274320" y="5900928"/>
+            <a:ext cx="3758184" cy="737615"/>
+          </a:xfrm>
+          <a:prstGeom prst="rect">
+            <a:avLst/>
+          </a:prstGeom>
+          <a:solidFill>
+            <a:srgbClr val="E9F4F2"/>
+          </a:solidFill>
+          <a:ln w="6350">
+            <a:solidFill>
+              <a:srgbClr val="DEDEDE"/>
+            </a:solidFill>
+          </a:ln>
+          <a:effectLst/>
+        </p:spPr>
+        <p:style>
+          <a:lnRef idx="1">
+            <a:schemeClr val="accent1"/>
+          </a:lnRef>
+          <a:fillRef idx="3">
+            <a:schemeClr val="accent1"/>
+          </a:fillRef>
+          <a:effectRef idx="2">
+            <a:schemeClr val="accent1"/>
+          </a:effectRef>
+          <a:fontRef idx="minor">
+            <a:schemeClr val="lt1"/>
+          </a:fontRef>
+        </p:style>
+        <p:txBody>
+          <a:bodyPr rtlCol="0" anchor="ctr"/>
+          <a:lstStyle/>
+          <a:p>
+            <a:pPr algn="ctr"/>
+          </a:p>
+        </p:txBody>
+      </p:sp>
+      <p:sp>
+        <p:nvSpPr>
+          <p:cNvPr id="26" name="TextBox 25"/>
+          <p:cNvSpPr txBox="1"/>
+          <p:nvPr/>
+        </p:nvSpPr>
+        <p:spPr>
+          <a:xfrm>
+            <a:off x="402336" y="5974080"/>
+            <a:ext cx="3502152" cy="368807"/>
+          </a:xfrm>
+          <a:prstGeom prst="rect">
+            <a:avLst/>
+          </a:prstGeom>
+          <a:noFill/>
+        </p:spPr>
+        <p:txBody>
+          <a:bodyPr wrap="square" anchor="t" tIns="0" bIns="0">
+            <a:spAutoFit/>
+          </a:bodyPr>
+          <a:lstStyle/>
+          <a:p>
+            <a:pPr algn="l"/>
+            <a:r>
+              <a:rPr sz="1200" b="1" i="0">
+                <a:solidFill>
+                  <a:srgbClr val="3A8B82"/>
+                </a:solidFill>
+                <a:latin typeface="Raleway"/>
+              </a:rPr>
+              <a:t>{{DOM_6_T}}</a:t>
+            </a:r>
+          </a:p>
+        </p:txBody>
+      </p:sp>
+      <p:sp>
+        <p:nvSpPr>
+          <p:cNvPr id="27" name="TextBox 26"/>
+          <p:cNvSpPr txBox="1"/>
+          <p:nvPr/>
+        </p:nvSpPr>
+        <p:spPr>
+          <a:xfrm>
+            <a:off x="402336" y="6269736"/>
+            <a:ext cx="3502152" cy="295655"/>
+          </a:xfrm>
+          <a:prstGeom prst="rect">
+            <a:avLst/>
+          </a:prstGeom>
+          <a:noFill/>
+        </p:spPr>
+        <p:txBody>
+          <a:bodyPr wrap="square" anchor="t" tIns="0" bIns="0">
+            <a:normAutofit/>
+          </a:bodyPr>
+          <a:lstStyle/>
+          <a:p>
+            <a:pPr algn="l"/>
+            <a:r>
+              <a:rPr sz="1200" b="0" i="0">
+                <a:solidFill>
+                  <a:srgbClr val="6E6E69"/>
+                </a:solidFill>
+                <a:latin typeface="Raleway"/>
+              </a:rPr>
+              <a:t>{{DOM_6_D}}</a:t>
+            </a:r>
+          </a:p>
+        </p:txBody>
+      </p:sp>
+      <p:sp>
+        <p:nvSpPr>
+          <p:cNvPr id="28" name="Rectangle 27"/>
+          <p:cNvSpPr/>
+          <p:nvPr/>
+        </p:nvSpPr>
+        <p:spPr>
+          <a:xfrm>
+            <a:off x="4215384" y="1234440"/>
+            <a:ext cx="3758184" cy="438912"/>
+          </a:xfrm>
+          <a:prstGeom prst="rect">
+            <a:avLst/>
+          </a:prstGeom>
+          <a:solidFill>
+            <a:srgbClr val="C02026"/>
+          </a:solidFill>
+          <a:ln>
+            <a:noFill/>
+          </a:ln>
+          <a:effectLst/>
+        </p:spPr>
+        <p:style>
+          <a:lnRef idx="1">
+            <a:schemeClr val="accent1"/>
+          </a:lnRef>
+          <a:fillRef idx="3">
+            <a:schemeClr val="accent1"/>
+          </a:fillRef>
+          <a:effectRef idx="2">
+            <a:schemeClr val="accent1"/>
+          </a:effectRef>
+          <a:fontRef idx="minor">
+            <a:schemeClr val="lt1"/>
+          </a:fontRef>
+        </p:style>
+        <p:txBody>
+          <a:bodyPr rtlCol="0" anchor="ctr"/>
+          <a:lstStyle/>
+          <a:p>
+            <a:pPr algn="ctr"/>
+          </a:p>
+        </p:txBody>
+      </p:sp>
+      <p:sp>
+        <p:nvSpPr>
+          <p:cNvPr id="29" name="TextBox 28"/>
+          <p:cNvSpPr txBox="1"/>
+          <p:nvPr/>
+        </p:nvSpPr>
+        <p:spPr>
+          <a:xfrm>
+            <a:off x="4215384" y="1234440"/>
+            <a:ext cx="3758184" cy="438912"/>
+          </a:xfrm>
+          <a:prstGeom prst="rect">
+            <a:avLst/>
+          </a:prstGeom>
+          <a:noFill/>
+        </p:spPr>
+        <p:txBody>
+          <a:bodyPr wrap="square" anchor="ctr" tIns="0" bIns="0">
+            <a:spAutoFit/>
+          </a:bodyPr>
+          <a:lstStyle/>
+          <a:p>
+            <a:pPr algn="ctr"/>
+            <a:r>
+              <a:rPr sz="1300" b="1" i="0">
+                <a:solidFill>
+                  <a:srgbClr val="FFFFFF"/>
+                </a:solidFill>
+                <a:latin typeface="Calibri"/>
+              </a:rPr>
+              <a:t>TECHNICAL STACK</a:t>
+            </a:r>
+          </a:p>
+        </p:txBody>
+      </p:sp>
+      <p:sp>
+        <p:nvSpPr>
+          <p:cNvPr id="30" name="Rectangle 29"/>
+          <p:cNvSpPr/>
+          <p:nvPr/>
+        </p:nvSpPr>
+        <p:spPr>
+          <a:xfrm>
+            <a:off x="4215384" y="1801368"/>
+            <a:ext cx="3758184" cy="737615"/>
+          </a:xfrm>
+          <a:prstGeom prst="rect">
+            <a:avLst/>
+          </a:prstGeom>
+          <a:solidFill>
+            <a:srgbClr val="FCEFEF"/>
+          </a:solidFill>
+          <a:ln w="6350">
+            <a:solidFill>
+              <a:srgbClr val="DEDEDE"/>
+            </a:solidFill>
+          </a:ln>
+          <a:effectLst/>
+        </p:spPr>
+        <p:style>
+          <a:lnRef idx="1">
+            <a:schemeClr val="accent1"/>
+          </a:lnRef>
+          <a:fillRef idx="3">
+            <a:schemeClr val="accent1"/>
+          </a:fillRef>
+          <a:effectRef idx="2">
+            <a:schemeClr val="accent1"/>
+          </a:effectRef>
+          <a:fontRef idx="minor">
+            <a:schemeClr val="lt1"/>
+          </a:fontRef>
+        </p:style>
+        <p:txBody>
+          <a:bodyPr rtlCol="0" anchor="ctr"/>
+          <a:lstStyle/>
+          <a:p>
+            <a:pPr algn="ctr"/>
+          </a:p>
+        </p:txBody>
+      </p:sp>
+      <p:sp>
+        <p:nvSpPr>
+          <p:cNvPr id="31" name="TextBox 30"/>
+          <p:cNvSpPr txBox="1"/>
+          <p:nvPr/>
+        </p:nvSpPr>
+        <p:spPr>
+          <a:xfrm>
+            <a:off x="4343400" y="1874520"/>
+            <a:ext cx="3502152" cy="368807"/>
+          </a:xfrm>
+          <a:prstGeom prst="rect">
+            <a:avLst/>
+          </a:prstGeom>
+          <a:noFill/>
+        </p:spPr>
+        <p:txBody>
+          <a:bodyPr wrap="square" anchor="t" tIns="0" bIns="0">
+            <a:spAutoFit/>
+          </a:bodyPr>
+          <a:lstStyle/>
+          <a:p>
+            <a:pPr algn="l"/>
+            <a:r>
+              <a:rPr sz="1200" b="1" i="0">
+                <a:solidFill>
+                  <a:srgbClr val="C02026"/>
+                </a:solidFill>
+                <a:latin typeface="Raleway"/>
+              </a:rPr>
+              <a:t>{{TEC_1_T}}</a:t>
+            </a:r>
+          </a:p>
+        </p:txBody>
+      </p:sp>
+      <p:sp>
+        <p:nvSpPr>
+          <p:cNvPr id="32" name="TextBox 31"/>
+          <p:cNvSpPr txBox="1"/>
+          <p:nvPr/>
+        </p:nvSpPr>
+        <p:spPr>
+          <a:xfrm>
+            <a:off x="4343400" y="2170176"/>
+            <a:ext cx="3502152" cy="295655"/>
+          </a:xfrm>
+          <a:prstGeom prst="rect">
+            <a:avLst/>
+          </a:prstGeom>
+          <a:noFill/>
+        </p:spPr>
+        <p:txBody>
+          <a:bodyPr wrap="square" anchor="t" tIns="0" bIns="0">
+            <a:normAutofit/>
+          </a:bodyPr>
+          <a:lstStyle/>
+          <a:p>
+            <a:pPr algn="l"/>
+            <a:r>
+              <a:rPr sz="1200" b="0" i="0">
+                <a:solidFill>
+                  <a:srgbClr val="6E6E69"/>
+                </a:solidFill>
+                <a:latin typeface="Raleway"/>
+              </a:rPr>
+              <a:t>{{TEC_1_D}}</a:t>
+            </a:r>
+          </a:p>
+        </p:txBody>
+      </p:sp>
+      <p:sp>
+        <p:nvSpPr>
+          <p:cNvPr id="33" name="Rectangle 32"/>
+          <p:cNvSpPr/>
+          <p:nvPr/>
+        </p:nvSpPr>
+        <p:spPr>
+          <a:xfrm>
+            <a:off x="4215384" y="2621280"/>
+            <a:ext cx="3758184" cy="737615"/>
+          </a:xfrm>
+          <a:prstGeom prst="rect">
+            <a:avLst/>
+          </a:prstGeom>
+          <a:solidFill>
+            <a:srgbClr val="FCEFEF"/>
+          </a:solidFill>
+          <a:ln w="6350">
+            <a:solidFill>
+              <a:srgbClr val="DEDEDE"/>
+            </a:solidFill>
+          </a:ln>
+          <a:effectLst/>
+        </p:spPr>
+        <p:style>
+          <a:lnRef idx="1">
+            <a:schemeClr val="accent1"/>
+          </a:lnRef>
+          <a:fillRef idx="3">
+            <a:schemeClr val="accent1"/>
+          </a:fillRef>
+          <a:effectRef idx="2">
+            <a:schemeClr val="accent1"/>
+          </a:effectRef>
+          <a:fontRef idx="minor">
+            <a:schemeClr val="lt1"/>
+          </a:fontRef>
+        </p:style>
+        <p:txBody>
+          <a:bodyPr rtlCol="0" anchor="ctr"/>
+          <a:lstStyle/>
+          <a:p>
+            <a:pPr algn="ctr"/>
+          </a:p>
+        </p:txBody>
+      </p:sp>
+      <p:sp>
+        <p:nvSpPr>
+          <p:cNvPr id="34" name="TextBox 33"/>
+          <p:cNvSpPr txBox="1"/>
+          <p:nvPr/>
+        </p:nvSpPr>
+        <p:spPr>
+          <a:xfrm>
+            <a:off x="4343400" y="2694432"/>
+            <a:ext cx="3502152" cy="368807"/>
+          </a:xfrm>
+          <a:prstGeom prst="rect">
+            <a:avLst/>
+          </a:prstGeom>
+          <a:noFill/>
+        </p:spPr>
+        <p:txBody>
+          <a:bodyPr wrap="square" anchor="t" tIns="0" bIns="0">
+            <a:spAutoFit/>
+          </a:bodyPr>
+          <a:lstStyle/>
+          <a:p>
+            <a:pPr algn="l"/>
+            <a:r>
+              <a:rPr sz="1200" b="1" i="0">
+                <a:solidFill>
+                  <a:srgbClr val="C02026"/>
+                </a:solidFill>
+                <a:latin typeface="Raleway"/>
+              </a:rPr>
+              <a:t>{{TEC_2_T}}</a:t>
+            </a:r>
+          </a:p>
+        </p:txBody>
+      </p:sp>
+      <p:sp>
+        <p:nvSpPr>
+          <p:cNvPr id="35" name="TextBox 34"/>
+          <p:cNvSpPr txBox="1"/>
+          <p:nvPr/>
+        </p:nvSpPr>
+        <p:spPr>
+          <a:xfrm>
+            <a:off x="4343400" y="2990088"/>
+            <a:ext cx="3502152" cy="295655"/>
+          </a:xfrm>
+          <a:prstGeom prst="rect">
+            <a:avLst/>
+          </a:prstGeom>
+          <a:noFill/>
+        </p:spPr>
+        <p:txBody>
+          <a:bodyPr wrap="square" anchor="t" tIns="0" bIns="0">
+            <a:normAutofit/>
+          </a:bodyPr>
+          <a:lstStyle/>
+          <a:p>
+            <a:pPr algn="l"/>
+            <a:r>
+              <a:rPr sz="1200" b="0" i="0">
+                <a:solidFill>
+                  <a:srgbClr val="6E6E69"/>
+                </a:solidFill>
+                <a:latin typeface="Raleway"/>
+              </a:rPr>
+              <a:t>{{TEC_2_D}}</a:t>
+            </a:r>
+          </a:p>
+        </p:txBody>
+      </p:sp>
+      <p:sp>
+        <p:nvSpPr>
+          <p:cNvPr id="36" name="Rectangle 35"/>
+          <p:cNvSpPr/>
+          <p:nvPr/>
+        </p:nvSpPr>
+        <p:spPr>
+          <a:xfrm>
+            <a:off x="4215384" y="3441192"/>
+            <a:ext cx="3758184" cy="737615"/>
+          </a:xfrm>
+          <a:prstGeom prst="rect">
+            <a:avLst/>
+          </a:prstGeom>
+          <a:solidFill>
+            <a:srgbClr val="FCEFEF"/>
+          </a:solidFill>
+          <a:ln w="6350">
+            <a:solidFill>
+              <a:srgbClr val="DEDEDE"/>
+            </a:solidFill>
+          </a:ln>
+          <a:effectLst/>
+        </p:spPr>
+        <p:style>
+          <a:lnRef idx="1">
+            <a:schemeClr val="accent1"/>
+          </a:lnRef>
+          <a:fillRef idx="3">
+            <a:schemeClr val="accent1"/>
+          </a:fillRef>
+          <a:effectRef idx="2">
+            <a:schemeClr val="accent1"/>
+          </a:effectRef>
+          <a:fontRef idx="minor">
+            <a:schemeClr val="lt1"/>
+          </a:fontRef>
+        </p:style>
+        <p:txBody>
+          <a:bodyPr rtlCol="0" anchor="ctr"/>
+          <a:lstStyle/>
+          <a:p>
+            <a:pPr algn="ctr"/>
+          </a:p>
+        </p:txBody>
+      </p:sp>
+      <p:sp>
+        <p:nvSpPr>
+          <p:cNvPr id="37" name="TextBox 36"/>
+          <p:cNvSpPr txBox="1"/>
+          <p:nvPr/>
+        </p:nvSpPr>
+        <p:spPr>
+          <a:xfrm>
+            <a:off x="4343400" y="3514344"/>
+            <a:ext cx="3502152" cy="368807"/>
+          </a:xfrm>
+          <a:prstGeom prst="rect">
+            <a:avLst/>
+          </a:prstGeom>
+          <a:noFill/>
+        </p:spPr>
+        <p:txBody>
+          <a:bodyPr wrap="square" anchor="t" tIns="0" bIns="0">
+            <a:spAutoFit/>
+          </a:bodyPr>
+          <a:lstStyle/>
+          <a:p>
+            <a:pPr algn="l"/>
+            <a:r>
+              <a:rPr sz="1200" b="1" i="0">
+                <a:solidFill>
+                  <a:srgbClr val="C02026"/>
+                </a:solidFill>
+                <a:latin typeface="Raleway"/>
+              </a:rPr>
+              <a:t>{{TEC_3_T}}</a:t>
+            </a:r>
+          </a:p>
+        </p:txBody>
+      </p:sp>
+      <p:sp>
+        <p:nvSpPr>
+          <p:cNvPr id="38" name="TextBox 37"/>
+          <p:cNvSpPr txBox="1"/>
+          <p:nvPr/>
+        </p:nvSpPr>
+        <p:spPr>
+          <a:xfrm>
+            <a:off x="4343400" y="3809999"/>
+            <a:ext cx="3502152" cy="295655"/>
+          </a:xfrm>
+          <a:prstGeom prst="rect">
+            <a:avLst/>
+          </a:prstGeom>
+          <a:noFill/>
+        </p:spPr>
+        <p:txBody>
+          <a:bodyPr wrap="square" anchor="t" tIns="0" bIns="0">
+            <a:normAutofit/>
+          </a:bodyPr>
+          <a:lstStyle/>
+          <a:p>
+            <a:pPr algn="l"/>
+            <a:r>
+              <a:rPr sz="1200" b="0" i="0">
+                <a:solidFill>
+                  <a:srgbClr val="6E6E69"/>
+                </a:solidFill>
+                <a:latin typeface="Raleway"/>
+              </a:rPr>
+              <a:t>{{TEC_3_D}}</a:t>
+            </a:r>
+          </a:p>
+        </p:txBody>
+      </p:sp>
+      <p:sp>
+        <p:nvSpPr>
+          <p:cNvPr id="39" name="Rectangle 38"/>
+          <p:cNvSpPr/>
+          <p:nvPr/>
+        </p:nvSpPr>
+        <p:spPr>
+          <a:xfrm>
+            <a:off x="4215384" y="4261104"/>
+            <a:ext cx="3758184" cy="737615"/>
+          </a:xfrm>
+          <a:prstGeom prst="rect">
+            <a:avLst/>
+          </a:prstGeom>
+          <a:solidFill>
+            <a:srgbClr val="FCEFEF"/>
+          </a:solidFill>
+          <a:ln w="6350">
+            <a:solidFill>
+              <a:srgbClr val="DEDEDE"/>
+            </a:solidFill>
+          </a:ln>
+          <a:effectLst/>
+        </p:spPr>
+        <p:style>
+          <a:lnRef idx="1">
+            <a:schemeClr val="accent1"/>
+          </a:lnRef>
+          <a:fillRef idx="3">
+            <a:schemeClr val="accent1"/>
+          </a:fillRef>
+          <a:effectRef idx="2">
+            <a:schemeClr val="accent1"/>
+          </a:effectRef>
+          <a:fontRef idx="minor">
+            <a:schemeClr val="lt1"/>
+          </a:fontRef>
+        </p:style>
+        <p:txBody>
+          <a:bodyPr rtlCol="0" anchor="ctr"/>
+          <a:lstStyle/>
+          <a:p>
+            <a:pPr algn="ctr"/>
+          </a:p>
+        </p:txBody>
+      </p:sp>
+      <p:sp>
+        <p:nvSpPr>
+          <p:cNvPr id="40" name="TextBox 39"/>
+          <p:cNvSpPr txBox="1"/>
+          <p:nvPr/>
+        </p:nvSpPr>
+        <p:spPr>
+          <a:xfrm>
+            <a:off x="4343400" y="4334256"/>
+            <a:ext cx="3502152" cy="368807"/>
+          </a:xfrm>
+          <a:prstGeom prst="rect">
+            <a:avLst/>
+          </a:prstGeom>
+          <a:noFill/>
+        </p:spPr>
+        <p:txBody>
+          <a:bodyPr wrap="square" anchor="t" tIns="0" bIns="0">
+            <a:spAutoFit/>
+          </a:bodyPr>
+          <a:lstStyle/>
+          <a:p>
+            <a:pPr algn="l"/>
+            <a:r>
+              <a:rPr sz="1200" b="1" i="0">
+                <a:solidFill>
+                  <a:srgbClr val="C02026"/>
+                </a:solidFill>
+                <a:latin typeface="Raleway"/>
+              </a:rPr>
+              <a:t>{{TEC_4_T}}</a:t>
+            </a:r>
+          </a:p>
+        </p:txBody>
+      </p:sp>
+      <p:sp>
+        <p:nvSpPr>
+          <p:cNvPr id="41" name="TextBox 40"/>
+          <p:cNvSpPr txBox="1"/>
+          <p:nvPr/>
+        </p:nvSpPr>
+        <p:spPr>
+          <a:xfrm>
+            <a:off x="4343400" y="4629912"/>
+            <a:ext cx="3502152" cy="295655"/>
+          </a:xfrm>
+          <a:prstGeom prst="rect">
+            <a:avLst/>
+          </a:prstGeom>
+          <a:noFill/>
+        </p:spPr>
+        <p:txBody>
+          <a:bodyPr wrap="square" anchor="t" tIns="0" bIns="0">
+            <a:normAutofit/>
+          </a:bodyPr>
+          <a:lstStyle/>
+          <a:p>
+            <a:pPr algn="l"/>
+            <a:r>
+              <a:rPr sz="1200" b="0" i="0">
+                <a:solidFill>
+                  <a:srgbClr val="6E6E69"/>
+                </a:solidFill>
+                <a:latin typeface="Raleway"/>
+              </a:rPr>
+              <a:t>{{TEC_4_D}}</a:t>
+            </a:r>
+          </a:p>
+        </p:txBody>
+      </p:sp>
+      <p:sp>
+        <p:nvSpPr>
+          <p:cNvPr id="42" name="Rectangle 41"/>
+          <p:cNvSpPr/>
+          <p:nvPr/>
+        </p:nvSpPr>
+        <p:spPr>
+          <a:xfrm>
+            <a:off x="4215384" y="5081016"/>
+            <a:ext cx="3758184" cy="737615"/>
+          </a:xfrm>
+          <a:prstGeom prst="rect">
+            <a:avLst/>
+          </a:prstGeom>
+          <a:solidFill>
+            <a:srgbClr val="FCEFEF"/>
+          </a:solidFill>
+          <a:ln w="6350">
+            <a:solidFill>
+              <a:srgbClr val="DEDEDE"/>
+            </a:solidFill>
+          </a:ln>
+          <a:effectLst/>
+        </p:spPr>
+        <p:style>
+          <a:lnRef idx="1">
+            <a:schemeClr val="accent1"/>
+          </a:lnRef>
+          <a:fillRef idx="3">
+            <a:schemeClr val="accent1"/>
+          </a:fillRef>
+          <a:effectRef idx="2">
+            <a:schemeClr val="accent1"/>
+          </a:effectRef>
+          <a:fontRef idx="minor">
+            <a:schemeClr val="lt1"/>
+          </a:fontRef>
+        </p:style>
+        <p:txBody>
+          <a:bodyPr rtlCol="0" anchor="ctr"/>
+          <a:lstStyle/>
+          <a:p>
+            <a:pPr algn="ctr"/>
+          </a:p>
+        </p:txBody>
+      </p:sp>
+      <p:sp>
+        <p:nvSpPr>
+          <p:cNvPr id="43" name="TextBox 42"/>
+          <p:cNvSpPr txBox="1"/>
+          <p:nvPr/>
+        </p:nvSpPr>
+        <p:spPr>
+          <a:xfrm>
+            <a:off x="4343400" y="5154168"/>
+            <a:ext cx="3502152" cy="368807"/>
+          </a:xfrm>
+          <a:prstGeom prst="rect">
+            <a:avLst/>
+          </a:prstGeom>
+          <a:noFill/>
+        </p:spPr>
+        <p:txBody>
+          <a:bodyPr wrap="square" anchor="t" tIns="0" bIns="0">
+            <a:spAutoFit/>
+          </a:bodyPr>
+          <a:lstStyle/>
+          <a:p>
+            <a:pPr algn="l"/>
+            <a:r>
+              <a:rPr sz="1200" b="1" i="0">
+                <a:solidFill>
+                  <a:srgbClr val="C02026"/>
+                </a:solidFill>
+                <a:latin typeface="Raleway"/>
+              </a:rPr>
+              <a:t>{{TEC_5_T}}</a:t>
+            </a:r>
+          </a:p>
+        </p:txBody>
+      </p:sp>
+      <p:sp>
+        <p:nvSpPr>
+          <p:cNvPr id="44" name="TextBox 43"/>
+          <p:cNvSpPr txBox="1"/>
+          <p:nvPr/>
+        </p:nvSpPr>
+        <p:spPr>
+          <a:xfrm>
+            <a:off x="4343400" y="5449824"/>
+            <a:ext cx="3502152" cy="295655"/>
+          </a:xfrm>
+          <a:prstGeom prst="rect">
+            <a:avLst/>
+          </a:prstGeom>
+          <a:noFill/>
+        </p:spPr>
+        <p:txBody>
+          <a:bodyPr wrap="square" anchor="t" tIns="0" bIns="0">
+            <a:normAutofit/>
+          </a:bodyPr>
+          <a:lstStyle/>
+          <a:p>
+            <a:pPr algn="l"/>
+            <a:r>
+              <a:rPr sz="1200" b="0" i="0">
+                <a:solidFill>
+                  <a:srgbClr val="6E6E69"/>
+                </a:solidFill>
+                <a:latin typeface="Raleway"/>
+              </a:rPr>
+              <a:t>{{TEC_5_D}}</a:t>
+            </a:r>
+          </a:p>
+        </p:txBody>
+      </p:sp>
+      <p:sp>
+        <p:nvSpPr>
+          <p:cNvPr id="45" name="Rectangle 44"/>
+          <p:cNvSpPr/>
+          <p:nvPr/>
+        </p:nvSpPr>
+        <p:spPr>
+          <a:xfrm>
+            <a:off x="4215384" y="5900928"/>
+            <a:ext cx="3758184" cy="737615"/>
+          </a:xfrm>
+          <a:prstGeom prst="rect">
+            <a:avLst/>
+          </a:prstGeom>
+          <a:solidFill>
+            <a:srgbClr val="FCEFEF"/>
+          </a:solidFill>
+          <a:ln w="6350">
+            <a:solidFill>
+              <a:srgbClr val="DEDEDE"/>
+            </a:solidFill>
+          </a:ln>
+          <a:effectLst/>
+        </p:spPr>
+        <p:style>
+          <a:lnRef idx="1">
+            <a:schemeClr val="accent1"/>
+          </a:lnRef>
+          <a:fillRef idx="3">
+            <a:schemeClr val="accent1"/>
+          </a:fillRef>
+          <a:effectRef idx="2">
+            <a:schemeClr val="accent1"/>
+          </a:effectRef>
+          <a:fontRef idx="minor">
+            <a:schemeClr val="lt1"/>
+          </a:fontRef>
+        </p:style>
+        <p:txBody>
+          <a:bodyPr rtlCol="0" anchor="ctr"/>
+          <a:lstStyle/>
+          <a:p>
+            <a:pPr algn="ctr"/>
+          </a:p>
+        </p:txBody>
+      </p:sp>
+      <p:sp>
+        <p:nvSpPr>
+          <p:cNvPr id="46" name="TextBox 45"/>
+          <p:cNvSpPr txBox="1"/>
+          <p:nvPr/>
+        </p:nvSpPr>
+        <p:spPr>
+          <a:xfrm>
+            <a:off x="4343400" y="5974080"/>
+            <a:ext cx="3502152" cy="368807"/>
+          </a:xfrm>
+          <a:prstGeom prst="rect">
+            <a:avLst/>
+          </a:prstGeom>
+          <a:noFill/>
+        </p:spPr>
+        <p:txBody>
+          <a:bodyPr wrap="square" anchor="t" tIns="0" bIns="0">
+            <a:spAutoFit/>
+          </a:bodyPr>
+          <a:lstStyle/>
+          <a:p>
+            <a:pPr algn="l"/>
+            <a:r>
+              <a:rPr sz="1200" b="1" i="0">
+                <a:solidFill>
+                  <a:srgbClr val="C02026"/>
+                </a:solidFill>
+                <a:latin typeface="Raleway"/>
+              </a:rPr>
+              <a:t>{{TEC_6_T}}</a:t>
+            </a:r>
+          </a:p>
+        </p:txBody>
+      </p:sp>
+      <p:sp>
+        <p:nvSpPr>
+          <p:cNvPr id="47" name="TextBox 46"/>
+          <p:cNvSpPr txBox="1"/>
+          <p:nvPr/>
+        </p:nvSpPr>
+        <p:spPr>
+          <a:xfrm>
+            <a:off x="4343400" y="6269736"/>
+            <a:ext cx="3502152" cy="295655"/>
+          </a:xfrm>
+          <a:prstGeom prst="rect">
+            <a:avLst/>
+          </a:prstGeom>
+          <a:noFill/>
+        </p:spPr>
+        <p:txBody>
+          <a:bodyPr wrap="square" anchor="t" tIns="0" bIns="0">
+            <a:normAutofit/>
+          </a:bodyPr>
+          <a:lstStyle/>
+          <a:p>
+            <a:pPr algn="l"/>
+            <a:r>
+              <a:rPr sz="1200" b="0" i="0">
+                <a:solidFill>
+                  <a:srgbClr val="6E6E69"/>
+                </a:solidFill>
+                <a:latin typeface="Raleway"/>
+              </a:rPr>
+              <a:t>{{TEC_6_D}}</a:t>
+            </a:r>
+          </a:p>
+        </p:txBody>
+      </p:sp>
+      <p:sp>
+        <p:nvSpPr>
+          <p:cNvPr id="48" name="Rectangle 47"/>
+          <p:cNvSpPr/>
+          <p:nvPr/>
+        </p:nvSpPr>
+        <p:spPr>
+          <a:xfrm>
+            <a:off x="8156448" y="1234440"/>
+            <a:ext cx="3758184" cy="438912"/>
+          </a:xfrm>
+          <a:prstGeom prst="rect">
+            <a:avLst/>
+          </a:prstGeom>
+          <a:solidFill>
+            <a:srgbClr val="6E6E69"/>
+          </a:solidFill>
+          <a:ln>
+            <a:noFill/>
+          </a:ln>
+          <a:effectLst/>
+        </p:spPr>
+        <p:style>
+          <a:lnRef idx="1">
+            <a:schemeClr val="accent1"/>
+          </a:lnRef>
+          <a:fillRef idx="3">
+            <a:schemeClr val="accent1"/>
+          </a:fillRef>
+          <a:effectRef idx="2">
+            <a:schemeClr val="accent1"/>
+          </a:effectRef>
+          <a:fontRef idx="minor">
+            <a:schemeClr val="lt1"/>
+          </a:fontRef>
+        </p:style>
+        <p:txBody>
+          <a:bodyPr rtlCol="0" anchor="ctr"/>
+          <a:lstStyle/>
+          <a:p>
+            <a:pPr algn="ctr"/>
+          </a:p>
+        </p:txBody>
+      </p:sp>
+      <p:sp>
+        <p:nvSpPr>
+          <p:cNvPr id="49" name="TextBox 48"/>
+          <p:cNvSpPr txBox="1"/>
+          <p:nvPr/>
+        </p:nvSpPr>
+        <p:spPr>
+          <a:xfrm>
+            <a:off x="8156448" y="1234440"/>
+            <a:ext cx="3758184" cy="438912"/>
+          </a:xfrm>
+          <a:prstGeom prst="rect">
+            <a:avLst/>
+          </a:prstGeom>
+          <a:noFill/>
+        </p:spPr>
+        <p:txBody>
+          <a:bodyPr wrap="square" anchor="ctr" tIns="0" bIns="0">
+            <a:spAutoFit/>
+          </a:bodyPr>
+          <a:lstStyle/>
+          <a:p>
+            <a:pPr algn="ctr"/>
+            <a:r>
+              <a:rPr sz="1300" b="1" i="0">
+                <a:solidFill>
+                  <a:srgbClr val="FFFFFF"/>
+                </a:solidFill>
+                <a:latin typeface="Calibri"/>
+              </a:rPr>
+              <a:t>ACADEMIC &amp; PROFESSIONAL</a:t>
+            </a:r>
+          </a:p>
+        </p:txBody>
+      </p:sp>
+      <p:sp>
+        <p:nvSpPr>
+          <p:cNvPr id="50" name="Rectangle 49"/>
+          <p:cNvSpPr/>
+          <p:nvPr/>
+        </p:nvSpPr>
+        <p:spPr>
+          <a:xfrm>
+            <a:off x="8156448" y="1801368"/>
+            <a:ext cx="3758184" cy="737615"/>
+          </a:xfrm>
+          <a:prstGeom prst="rect">
+            <a:avLst/>
+          </a:prstGeom>
+          <a:solidFill>
+            <a:srgbClr val="F2F2F1"/>
+          </a:solidFill>
+          <a:ln w="6350">
+            <a:solidFill>
+              <a:srgbClr val="DEDEDE"/>
+            </a:solidFill>
+          </a:ln>
+          <a:effectLst/>
+        </p:spPr>
+        <p:style>
+          <a:lnRef idx="1">
+            <a:schemeClr val="accent1"/>
+          </a:lnRef>
+          <a:fillRef idx="3">
+            <a:schemeClr val="accent1"/>
+          </a:fillRef>
+          <a:effectRef idx="2">
+            <a:schemeClr val="accent1"/>
+          </a:effectRef>
+          <a:fontRef idx="minor">
+            <a:schemeClr val="lt1"/>
+          </a:fontRef>
+        </p:style>
+        <p:txBody>
+          <a:bodyPr rtlCol="0" anchor="ctr"/>
+          <a:lstStyle/>
+          <a:p>
+            <a:pPr algn="ctr"/>
+          </a:p>
+        </p:txBody>
+      </p:sp>
+      <p:sp>
+        <p:nvSpPr>
+          <p:cNvPr id="51" name="TextBox 50"/>
+          <p:cNvSpPr txBox="1"/>
+          <p:nvPr/>
+        </p:nvSpPr>
+        <p:spPr>
+          <a:xfrm>
+            <a:off x="8284464" y="1874520"/>
+            <a:ext cx="3502152" cy="368807"/>
+          </a:xfrm>
+          <a:prstGeom prst="rect">
+            <a:avLst/>
+          </a:prstGeom>
+          <a:noFill/>
+        </p:spPr>
+        <p:txBody>
+          <a:bodyPr wrap="square" anchor="t" tIns="0" bIns="0">
+            <a:spAutoFit/>
+          </a:bodyPr>
+          <a:lstStyle/>
+          <a:p>
+            <a:pPr algn="l"/>
+            <a:r>
+              <a:rPr sz="1200" b="1" i="0">
+                <a:solidFill>
+                  <a:srgbClr val="111110"/>
+                </a:solidFill>
+                <a:latin typeface="Raleway"/>
+              </a:rPr>
+              <a:t>{{ACA_1_T}}</a:t>
+            </a:r>
+          </a:p>
+        </p:txBody>
+      </p:sp>
+      <p:sp>
+        <p:nvSpPr>
+          <p:cNvPr id="52" name="TextBox 51"/>
+          <p:cNvSpPr txBox="1"/>
+          <p:nvPr/>
+        </p:nvSpPr>
+        <p:spPr>
+          <a:xfrm>
+            <a:off x="8284464" y="2170176"/>
+            <a:ext cx="3502152" cy="295655"/>
+          </a:xfrm>
+          <a:prstGeom prst="rect">
+            <a:avLst/>
+          </a:prstGeom>
+          <a:noFill/>
+        </p:spPr>
+        <p:txBody>
+          <a:bodyPr wrap="square" anchor="t" tIns="0" bIns="0">
+            <a:normAutofit/>
+          </a:bodyPr>
+          <a:lstStyle/>
+          <a:p>
+            <a:pPr algn="l"/>
+            <a:r>
+              <a:rPr sz="1200" b="0" i="0">
+                <a:solidFill>
+                  <a:srgbClr val="6E6E69"/>
+                </a:solidFill>
+                <a:latin typeface="Raleway"/>
+              </a:rPr>
+              <a:t>{{ACA_1_D}}</a:t>
+            </a:r>
+          </a:p>
+        </p:txBody>
+      </p:sp>
+      <p:sp>
+        <p:nvSpPr>
+          <p:cNvPr id="53" name="Rectangle 52"/>
+          <p:cNvSpPr/>
+          <p:nvPr/>
+        </p:nvSpPr>
+        <p:spPr>
+          <a:xfrm>
+            <a:off x="8156448" y="2621280"/>
+            <a:ext cx="3758184" cy="737615"/>
+          </a:xfrm>
+          <a:prstGeom prst="rect">
+            <a:avLst/>
+          </a:prstGeom>
+          <a:solidFill>
+            <a:srgbClr val="F2F2F1"/>
+          </a:solidFill>
+          <a:ln w="6350">
+            <a:solidFill>
+              <a:srgbClr val="DEDEDE"/>
+            </a:solidFill>
+          </a:ln>
+          <a:effectLst/>
+        </p:spPr>
+        <p:style>
+          <a:lnRef idx="1">
+            <a:schemeClr val="accent1"/>
+          </a:lnRef>
+          <a:fillRef idx="3">
+            <a:schemeClr val="accent1"/>
+          </a:fillRef>
+          <a:effectRef idx="2">
+            <a:schemeClr val="accent1"/>
+          </a:effectRef>
+          <a:fontRef idx="minor">
+            <a:schemeClr val="lt1"/>
+          </a:fontRef>
+        </p:style>
+        <p:txBody>
+          <a:bodyPr rtlCol="0" anchor="ctr"/>
+          <a:lstStyle/>
+          <a:p>
+            <a:pPr algn="ctr"/>
+          </a:p>
+        </p:txBody>
+      </p:sp>
+      <p:sp>
+        <p:nvSpPr>
+          <p:cNvPr id="54" name="TextBox 53"/>
+          <p:cNvSpPr txBox="1"/>
+          <p:nvPr/>
+        </p:nvSpPr>
+        <p:spPr>
+          <a:xfrm>
+            <a:off x="8284464" y="2694432"/>
+            <a:ext cx="3502152" cy="368807"/>
+          </a:xfrm>
+          <a:prstGeom prst="rect">
+            <a:avLst/>
+          </a:prstGeom>
+          <a:noFill/>
+        </p:spPr>
+        <p:txBody>
+          <a:bodyPr wrap="square" anchor="t" tIns="0" bIns="0">
+            <a:spAutoFit/>
+          </a:bodyPr>
+          <a:lstStyle/>
+          <a:p>
+            <a:pPr algn="l"/>
+            <a:r>
+              <a:rPr sz="1200" b="1" i="0">
+                <a:solidFill>
+                  <a:srgbClr val="111110"/>
+                </a:solidFill>
+                <a:latin typeface="Raleway"/>
+              </a:rPr>
+              <a:t>{{ACA_2_T}}</a:t>
+            </a:r>
+          </a:p>
+        </p:txBody>
+      </p:sp>
+      <p:sp>
+        <p:nvSpPr>
+          <p:cNvPr id="55" name="TextBox 54"/>
+          <p:cNvSpPr txBox="1"/>
+          <p:nvPr/>
+        </p:nvSpPr>
+        <p:spPr>
+          <a:xfrm>
+            <a:off x="8284464" y="2990088"/>
+            <a:ext cx="3502152" cy="295655"/>
+          </a:xfrm>
+          <a:prstGeom prst="rect">
+            <a:avLst/>
+          </a:prstGeom>
+          <a:noFill/>
+        </p:spPr>
+        <p:txBody>
+          <a:bodyPr wrap="square" anchor="t" tIns="0" bIns="0">
+            <a:normAutofit/>
+          </a:bodyPr>
+          <a:lstStyle/>
+          <a:p>
+            <a:pPr algn="l"/>
+            <a:r>
+              <a:rPr sz="1200" b="0" i="0">
+                <a:solidFill>
+                  <a:srgbClr val="6E6E69"/>
+                </a:solidFill>
+                <a:latin typeface="Raleway"/>
+              </a:rPr>
+              <a:t>{{ACA_2_D}}</a:t>
+            </a:r>
+          </a:p>
+        </p:txBody>
+      </p:sp>
+      <p:sp>
+        <p:nvSpPr>
+          <p:cNvPr id="56" name="Rectangle 55"/>
+          <p:cNvSpPr/>
+          <p:nvPr/>
+        </p:nvSpPr>
+        <p:spPr>
+          <a:xfrm>
+            <a:off x="8156448" y="3441192"/>
+            <a:ext cx="3758184" cy="737615"/>
+          </a:xfrm>
+          <a:prstGeom prst="rect">
+            <a:avLst/>
+          </a:prstGeom>
+          <a:solidFill>
+            <a:srgbClr val="F2F2F1"/>
+          </a:solidFill>
+          <a:ln w="6350">
+            <a:solidFill>
+              <a:srgbClr val="DEDEDE"/>
+            </a:solidFill>
+          </a:ln>
+          <a:effectLst/>
+        </p:spPr>
+        <p:style>
+          <a:lnRef idx="1">
+            <a:schemeClr val="accent1"/>
+          </a:lnRef>
+          <a:fillRef idx="3">
+            <a:schemeClr val="accent1"/>
+          </a:fillRef>
+          <a:effectRef idx="2">
+            <a:schemeClr val="accent1"/>
+          </a:effectRef>
+          <a:fontRef idx="minor">
+            <a:schemeClr val="lt1"/>
+          </a:fontRef>
+        </p:style>
+        <p:txBody>
+          <a:bodyPr rtlCol="0" anchor="ctr"/>
+          <a:lstStyle/>
+          <a:p>
+            <a:pPr algn="ctr"/>
+          </a:p>
+        </p:txBody>
+      </p:sp>
+      <p:sp>
+        <p:nvSpPr>
+          <p:cNvPr id="57" name="TextBox 56"/>
+          <p:cNvSpPr txBox="1"/>
+          <p:nvPr/>
+        </p:nvSpPr>
+        <p:spPr>
+          <a:xfrm>
+            <a:off x="8284464" y="3514344"/>
+            <a:ext cx="3502152" cy="368807"/>
+          </a:xfrm>
+          <a:prstGeom prst="rect">
+            <a:avLst/>
+          </a:prstGeom>
+          <a:noFill/>
+        </p:spPr>
+        <p:txBody>
+          <a:bodyPr wrap="square" anchor="t" tIns="0" bIns="0">
+            <a:spAutoFit/>
+          </a:bodyPr>
+          <a:lstStyle/>
+          <a:p>
+            <a:pPr algn="l"/>
+            <a:r>
+              <a:rPr sz="1200" b="1" i="0">
+                <a:solidFill>
+                  <a:srgbClr val="111110"/>
+                </a:solidFill>
+                <a:latin typeface="Raleway"/>
+              </a:rPr>
+              <a:t>{{ACA_3_T}}</a:t>
+            </a:r>
+          </a:p>
+        </p:txBody>
+      </p:sp>
+      <p:sp>
+        <p:nvSpPr>
+          <p:cNvPr id="58" name="TextBox 57"/>
+          <p:cNvSpPr txBox="1"/>
+          <p:nvPr/>
+        </p:nvSpPr>
+        <p:spPr>
+          <a:xfrm>
+            <a:off x="8284464" y="3809999"/>
+            <a:ext cx="3502152" cy="295655"/>
+          </a:xfrm>
+          <a:prstGeom prst="rect">
+            <a:avLst/>
+          </a:prstGeom>
+          <a:noFill/>
+        </p:spPr>
+        <p:txBody>
+          <a:bodyPr wrap="square" anchor="t" tIns="0" bIns="0">
+            <a:normAutofit/>
+          </a:bodyPr>
+          <a:lstStyle/>
+          <a:p>
+            <a:pPr algn="l"/>
+            <a:r>
+              <a:rPr sz="1200" b="0" i="0">
+                <a:solidFill>
+                  <a:srgbClr val="6E6E69"/>
+                </a:solidFill>
+                <a:latin typeface="Raleway"/>
+              </a:rPr>
+              <a:t>{{ACA_3_D}}</a:t>
+            </a:r>
+          </a:p>
+        </p:txBody>
+      </p:sp>
+      <p:sp>
+        <p:nvSpPr>
+          <p:cNvPr id="59" name="Rectangle 58"/>
+          <p:cNvSpPr/>
+          <p:nvPr/>
+        </p:nvSpPr>
+        <p:spPr>
+          <a:xfrm>
+            <a:off x="8156448" y="4261104"/>
+            <a:ext cx="3758184" cy="737615"/>
+          </a:xfrm>
+          <a:prstGeom prst="rect">
+            <a:avLst/>
+          </a:prstGeom>
+          <a:solidFill>
+            <a:srgbClr val="F2F2F1"/>
+          </a:solidFill>
+          <a:ln w="6350">
+            <a:solidFill>
+              <a:srgbClr val="DEDEDE"/>
+            </a:solidFill>
+          </a:ln>
+          <a:effectLst/>
+        </p:spPr>
+        <p:style>
+          <a:lnRef idx="1">
+            <a:schemeClr val="accent1"/>
+          </a:lnRef>
+          <a:fillRef idx="3">
+            <a:schemeClr val="accent1"/>
+          </a:fillRef>
+          <a:effectRef idx="2">
+            <a:schemeClr val="accent1"/>
+          </a:effectRef>
+          <a:fontRef idx="minor">
+            <a:schemeClr val="lt1"/>
+          </a:fontRef>
+        </p:style>
+        <p:txBody>
+          <a:bodyPr rtlCol="0" anchor="ctr"/>
+          <a:lstStyle/>
+          <a:p>
+            <a:pPr algn="ctr"/>
+          </a:p>
+        </p:txBody>
+      </p:sp>
+      <p:sp>
+        <p:nvSpPr>
+          <p:cNvPr id="60" name="TextBox 59"/>
+          <p:cNvSpPr txBox="1"/>
+          <p:nvPr/>
+        </p:nvSpPr>
+        <p:spPr>
+          <a:xfrm>
+            <a:off x="8284464" y="4334256"/>
+            <a:ext cx="3502152" cy="368807"/>
+          </a:xfrm>
+          <a:prstGeom prst="rect">
+            <a:avLst/>
+          </a:prstGeom>
+          <a:noFill/>
+        </p:spPr>
+        <p:txBody>
+          <a:bodyPr wrap="square" anchor="t" tIns="0" bIns="0">
+            <a:spAutoFit/>
+          </a:bodyPr>
+          <a:lstStyle/>
+          <a:p>
+            <a:pPr algn="l"/>
+            <a:r>
+              <a:rPr sz="1200" b="1" i="0">
+                <a:solidFill>
+                  <a:srgbClr val="111110"/>
+                </a:solidFill>
+                <a:latin typeface="Raleway"/>
+              </a:rPr>
+              <a:t>{{ACA_4_T}}</a:t>
+            </a:r>
+          </a:p>
+        </p:txBody>
+      </p:sp>
+      <p:sp>
+        <p:nvSpPr>
+          <p:cNvPr id="61" name="TextBox 60"/>
+          <p:cNvSpPr txBox="1"/>
+          <p:nvPr/>
+        </p:nvSpPr>
+        <p:spPr>
+          <a:xfrm>
+            <a:off x="8284464" y="4629912"/>
+            <a:ext cx="3502152" cy="295655"/>
+          </a:xfrm>
+          <a:prstGeom prst="rect">
+            <a:avLst/>
+          </a:prstGeom>
+          <a:noFill/>
+        </p:spPr>
+        <p:txBody>
+          <a:bodyPr wrap="square" anchor="t" tIns="0" bIns="0">
+            <a:normAutofit/>
+          </a:bodyPr>
+          <a:lstStyle/>
+          <a:p>
+            <a:pPr algn="l"/>
+            <a:r>
+              <a:rPr sz="1200" b="0" i="0">
+                <a:solidFill>
+                  <a:srgbClr val="6E6E69"/>
+                </a:solidFill>
+                <a:latin typeface="Raleway"/>
+              </a:rPr>
+              <a:t>{{ACA_4_D}}</a:t>
+            </a:r>
+          </a:p>
+        </p:txBody>
+      </p:sp>
+      <p:sp>
+        <p:nvSpPr>
+          <p:cNvPr id="62" name="Rectangle 61"/>
+          <p:cNvSpPr/>
+          <p:nvPr/>
+        </p:nvSpPr>
+        <p:spPr>
+          <a:xfrm>
+            <a:off x="8156448" y="5081016"/>
+            <a:ext cx="3758184" cy="737615"/>
+          </a:xfrm>
+          <a:prstGeom prst="rect">
+            <a:avLst/>
+          </a:prstGeom>
+          <a:solidFill>
+            <a:srgbClr val="F2F2F1"/>
+          </a:solidFill>
+          <a:ln w="6350">
+            <a:solidFill>
+              <a:srgbClr val="DEDEDE"/>
+            </a:solidFill>
+          </a:ln>
+          <a:effectLst/>
+        </p:spPr>
+        <p:style>
+          <a:lnRef idx="1">
+            <a:schemeClr val="accent1"/>
+          </a:lnRef>
+          <a:fillRef idx="3">
+            <a:schemeClr val="accent1"/>
+          </a:fillRef>
+          <a:effectRef idx="2">
+            <a:schemeClr val="accent1"/>
+          </a:effectRef>
+          <a:fontRef idx="minor">
+            <a:schemeClr val="lt1"/>
+          </a:fontRef>
+        </p:style>
+        <p:txBody>
+          <a:bodyPr rtlCol="0" anchor="ctr"/>
+          <a:lstStyle/>
+          <a:p>
+            <a:pPr algn="ctr"/>
+          </a:p>
+        </p:txBody>
+      </p:sp>
+      <p:sp>
+        <p:nvSpPr>
+          <p:cNvPr id="63" name="TextBox 62"/>
+          <p:cNvSpPr txBox="1"/>
+          <p:nvPr/>
+        </p:nvSpPr>
+        <p:spPr>
+          <a:xfrm>
+            <a:off x="8284464" y="5154168"/>
+            <a:ext cx="3502152" cy="368807"/>
+          </a:xfrm>
+          <a:prstGeom prst="rect">
+            <a:avLst/>
+          </a:prstGeom>
+          <a:noFill/>
+        </p:spPr>
+        <p:txBody>
+          <a:bodyPr wrap="square" anchor="t" tIns="0" bIns="0">
+            <a:spAutoFit/>
+          </a:bodyPr>
+          <a:lstStyle/>
+          <a:p>
+            <a:pPr algn="l"/>
+            <a:r>
+              <a:rPr sz="1200" b="1" i="0">
+                <a:solidFill>
+                  <a:srgbClr val="111110"/>
+                </a:solidFill>
+                <a:latin typeface="Raleway"/>
+              </a:rPr>
+              <a:t>{{ACA_5_T}}</a:t>
+            </a:r>
+          </a:p>
+        </p:txBody>
+      </p:sp>
+      <p:sp>
+        <p:nvSpPr>
+          <p:cNvPr id="64" name="TextBox 63"/>
+          <p:cNvSpPr txBox="1"/>
+          <p:nvPr/>
+        </p:nvSpPr>
+        <p:spPr>
+          <a:xfrm>
+            <a:off x="8284464" y="5449824"/>
+            <a:ext cx="3502152" cy="295655"/>
+          </a:xfrm>
+          <a:prstGeom prst="rect">
+            <a:avLst/>
+          </a:prstGeom>
+          <a:noFill/>
+        </p:spPr>
+        <p:txBody>
+          <a:bodyPr wrap="square" anchor="t" tIns="0" bIns="0">
+            <a:normAutofit/>
+          </a:bodyPr>
+          <a:lstStyle/>
+          <a:p>
+            <a:pPr algn="l"/>
+            <a:r>
+              <a:rPr sz="1200" b="0" i="0">
+                <a:solidFill>
+                  <a:srgbClr val="6E6E69"/>
+                </a:solidFill>
+                <a:latin typeface="Raleway"/>
+              </a:rPr>
+              <a:t>{{ACA_5_D}}</a:t>
+            </a:r>
+          </a:p>
+        </p:txBody>
+      </p:sp>
+      <p:sp>
+        <p:nvSpPr>
+          <p:cNvPr id="65" name="Rectangle 64"/>
+          <p:cNvSpPr/>
+          <p:nvPr/>
+        </p:nvSpPr>
+        <p:spPr>
+          <a:xfrm>
+            <a:off x="8156448" y="5900928"/>
+            <a:ext cx="3758184" cy="737615"/>
+          </a:xfrm>
+          <a:prstGeom prst="rect">
+            <a:avLst/>
+          </a:prstGeom>
+          <a:solidFill>
+            <a:srgbClr val="F2F2F1"/>
+          </a:solidFill>
+          <a:ln w="6350">
+            <a:solidFill>
+              <a:srgbClr val="DEDEDE"/>
+            </a:solidFill>
+          </a:ln>
+          <a:effectLst/>
+        </p:spPr>
+        <p:style>
+          <a:lnRef idx="1">
+            <a:schemeClr val="accent1"/>
+          </a:lnRef>
+          <a:fillRef idx="3">
+            <a:schemeClr val="accent1"/>
+          </a:fillRef>
+          <a:effectRef idx="2">
+            <a:schemeClr val="accent1"/>
+          </a:effectRef>
+          <a:fontRef idx="minor">
+            <a:schemeClr val="lt1"/>
+          </a:fontRef>
+        </p:style>
+        <p:txBody>
+          <a:bodyPr rtlCol="0" anchor="ctr"/>
+          <a:lstStyle/>
+          <a:p>
+            <a:pPr algn="ctr"/>
+          </a:p>
+        </p:txBody>
+      </p:sp>
+      <p:sp>
+        <p:nvSpPr>
+          <p:cNvPr id="66" name="TextBox 65"/>
+          <p:cNvSpPr txBox="1"/>
+          <p:nvPr/>
+        </p:nvSpPr>
+        <p:spPr>
+          <a:xfrm>
+            <a:off x="8284464" y="5974080"/>
+            <a:ext cx="3502152" cy="368807"/>
+          </a:xfrm>
+          <a:prstGeom prst="rect">
+            <a:avLst/>
+          </a:prstGeom>
+          <a:noFill/>
+        </p:spPr>
+        <p:txBody>
+          <a:bodyPr wrap="square" anchor="t" tIns="0" bIns="0">
+            <a:spAutoFit/>
+          </a:bodyPr>
+          <a:lstStyle/>
+          <a:p>
+            <a:pPr algn="l"/>
+            <a:r>
+              <a:rPr sz="1200" b="1" i="0">
+                <a:solidFill>
+                  <a:srgbClr val="111110"/>
+                </a:solidFill>
+                <a:latin typeface="Raleway"/>
+              </a:rPr>
+              <a:t>{{ACA_6_T}}</a:t>
+            </a:r>
+          </a:p>
+        </p:txBody>
+      </p:sp>
+      <p:sp>
+        <p:nvSpPr>
+          <p:cNvPr id="67" name="TextBox 66"/>
+          <p:cNvSpPr txBox="1"/>
+          <p:nvPr/>
+        </p:nvSpPr>
+        <p:spPr>
+          <a:xfrm>
+            <a:off x="8284464" y="6269736"/>
+            <a:ext cx="3502152" cy="295655"/>
+          </a:xfrm>
+          <a:prstGeom prst="rect">
+            <a:avLst/>
+          </a:prstGeom>
+          <a:noFill/>
+        </p:spPr>
+        <p:txBody>
+          <a:bodyPr wrap="square" anchor="t" tIns="0" bIns="0">
+            <a:normAutofit/>
+          </a:bodyPr>
+          <a:lstStyle/>
+          <a:p>
+            <a:pPr algn="l"/>
+            <a:r>
+              <a:rPr sz="1200" b="0" i="0">
+                <a:solidFill>
+                  <a:srgbClr val="6E6E69"/>
+                </a:solidFill>
+                <a:latin typeface="Raleway"/>
+              </a:rPr>
+              <a:t>{{ACA_6_D}}</a:t>
             </a:r>
           </a:p>
         </p:txBody>

</xml_diff>

<commit_message>
added new featurs and fix few bugs
</commit_message>
<xml_diff>
--- a/data/templates/skills_templates.pptx
+++ b/data/templates/skills_templates.pptx
@@ -16,6 +16,16 @@
     <p:sldId id="264" r:id="rId16"/>
     <p:sldId id="265" r:id="rId17"/>
     <p:sldId id="266" r:id="rId18"/>
+    <p:sldId id="267" r:id="rId19"/>
+    <p:sldId id="268" r:id="rId20"/>
+    <p:sldId id="269" r:id="rId21"/>
+    <p:sldId id="270" r:id="rId22"/>
+    <p:sldId id="271" r:id="rId23"/>
+    <p:sldId id="272" r:id="rId24"/>
+    <p:sldId id="273" r:id="rId25"/>
+    <p:sldId id="274" r:id="rId26"/>
+    <p:sldId id="275" r:id="rId27"/>
+    <p:sldId id="276" r:id="rId28"/>
   </p:sldIdLst>
   <p:sldSz cx="12188952" cy="6858000" type="screen4x3"/>
   <p:notesSz cx="6858000" cy="9144000"/>
@@ -677,6 +687,566 @@
 </p:notes>
 </file>
 
+<file path=ppt/notesSlides/notesSlide12.xml><?xml version="1.0" encoding="utf-8"?>
+<p:notes xmlns:a="http://schemas.openxmlformats.org/drawingml/2006/main" xmlns:p="http://schemas.openxmlformats.org/presentationml/2006/main" xmlns:r="http://schemas.openxmlformats.org/officeDocument/2006/relationships">
+  <p:cSld>
+    <p:spTree>
+      <p:nvGrpSpPr>
+        <p:cNvPr id="1" name=""/>
+        <p:cNvGrpSpPr/>
+        <p:nvPr/>
+      </p:nvGrpSpPr>
+      <p:grpSpPr>
+        <a:xfrm>
+          <a:off x="0" y="0"/>
+          <a:ext cx="0" cy="0"/>
+          <a:chOff x="0" y="0"/>
+          <a:chExt cx="0" cy="0"/>
+        </a:xfrm>
+      </p:grpSpPr>
+      <p:sp>
+        <p:nvSpPr>
+          <p:cNvPr id="2" name="Slide Image Placeholder 1"/>
+          <p:cNvSpPr>
+            <a:spLocks noGrp="1"/>
+          </p:cNvSpPr>
+          <p:nvPr>
+            <p:ph type="sldImg" idx="2"/>
+          </p:nvPr>
+        </p:nvSpPr>
+        <p:spPr/>
+      </p:sp>
+      <p:sp>
+        <p:nvSpPr>
+          <p:cNvPr id="3" name="Notes Placeholder 2"/>
+          <p:cNvSpPr>
+            <a:spLocks noGrp="1"/>
+          </p:cNvSpPr>
+          <p:nvPr>
+            <p:ph type="body" idx="3" sz="quarter"/>
+          </p:nvPr>
+        </p:nvSpPr>
+        <p:spPr/>
+        <p:txBody>
+          <a:bodyPr/>
+          <a:lstStyle/>
+          <a:p>
+            <a:r>
+              <a:t>J2W_TEMPLATE: pain_point_list</a:t>
+            </a:r>
+          </a:p>
+        </p:txBody>
+      </p:sp>
+      <p:sp>
+        <p:nvSpPr>
+          <p:cNvPr id="4" name="Slide Number Placeholder 3"/>
+          <p:cNvSpPr>
+            <a:spLocks noGrp="1"/>
+          </p:cNvSpPr>
+          <p:nvPr>
+            <p:ph type="sldNum" idx="5" sz="quarter"/>
+          </p:nvPr>
+        </p:nvSpPr>
+        <p:spPr/>
+      </p:sp>
+    </p:spTree>
+  </p:cSld>
+  <p:clrMapOvr>
+    <a:masterClrMapping/>
+  </p:clrMapOvr>
+</p:notes>
+</file>
+
+<file path=ppt/notesSlides/notesSlide13.xml><?xml version="1.0" encoding="utf-8"?>
+<p:notes xmlns:a="http://schemas.openxmlformats.org/drawingml/2006/main" xmlns:p="http://schemas.openxmlformats.org/presentationml/2006/main" xmlns:r="http://schemas.openxmlformats.org/officeDocument/2006/relationships">
+  <p:cSld>
+    <p:spTree>
+      <p:nvGrpSpPr>
+        <p:cNvPr id="1" name=""/>
+        <p:cNvGrpSpPr/>
+        <p:nvPr/>
+      </p:nvGrpSpPr>
+      <p:grpSpPr>
+        <a:xfrm>
+          <a:off x="0" y="0"/>
+          <a:ext cx="0" cy="0"/>
+          <a:chOff x="0" y="0"/>
+          <a:chExt cx="0" cy="0"/>
+        </a:xfrm>
+      </p:grpSpPr>
+      <p:sp>
+        <p:nvSpPr>
+          <p:cNvPr id="2" name="Slide Image Placeholder 1"/>
+          <p:cNvSpPr>
+            <a:spLocks noGrp="1"/>
+          </p:cNvSpPr>
+          <p:nvPr>
+            <p:ph type="sldImg" idx="2"/>
+          </p:nvPr>
+        </p:nvSpPr>
+        <p:spPr/>
+      </p:sp>
+      <p:sp>
+        <p:nvSpPr>
+          <p:cNvPr id="3" name="Notes Placeholder 2"/>
+          <p:cNvSpPr>
+            <a:spLocks noGrp="1"/>
+          </p:cNvSpPr>
+          <p:nvPr>
+            <p:ph type="body" idx="3" sz="quarter"/>
+          </p:nvPr>
+        </p:nvSpPr>
+        <p:spPr/>
+        <p:txBody>
+          <a:bodyPr/>
+          <a:lstStyle/>
+          <a:p>
+            <a:r>
+              <a:t>J2W_TEMPLATE: platform_overview</a:t>
+            </a:r>
+          </a:p>
+        </p:txBody>
+      </p:sp>
+      <p:sp>
+        <p:nvSpPr>
+          <p:cNvPr id="4" name="Slide Number Placeholder 3"/>
+          <p:cNvSpPr>
+            <a:spLocks noGrp="1"/>
+          </p:cNvSpPr>
+          <p:nvPr>
+            <p:ph type="sldNum" idx="5" sz="quarter"/>
+          </p:nvPr>
+        </p:nvSpPr>
+        <p:spPr/>
+      </p:sp>
+    </p:spTree>
+  </p:cSld>
+  <p:clrMapOvr>
+    <a:masterClrMapping/>
+  </p:clrMapOvr>
+</p:notes>
+</file>
+
+<file path=ppt/notesSlides/notesSlide14.xml><?xml version="1.0" encoding="utf-8"?>
+<p:notes xmlns:a="http://schemas.openxmlformats.org/drawingml/2006/main" xmlns:p="http://schemas.openxmlformats.org/presentationml/2006/main" xmlns:r="http://schemas.openxmlformats.org/officeDocument/2006/relationships">
+  <p:cSld>
+    <p:spTree>
+      <p:nvGrpSpPr>
+        <p:cNvPr id="1" name=""/>
+        <p:cNvGrpSpPr/>
+        <p:nvPr/>
+      </p:nvGrpSpPr>
+      <p:grpSpPr>
+        <a:xfrm>
+          <a:off x="0" y="0"/>
+          <a:ext cx="0" cy="0"/>
+          <a:chOff x="0" y="0"/>
+          <a:chExt cx="0" cy="0"/>
+        </a:xfrm>
+      </p:grpSpPr>
+      <p:sp>
+        <p:nvSpPr>
+          <p:cNvPr id="2" name="Slide Image Placeholder 1"/>
+          <p:cNvSpPr>
+            <a:spLocks noGrp="1"/>
+          </p:cNvSpPr>
+          <p:nvPr>
+            <p:ph type="sldImg" idx="2"/>
+          </p:nvPr>
+        </p:nvSpPr>
+        <p:spPr/>
+      </p:sp>
+      <p:sp>
+        <p:nvSpPr>
+          <p:cNvPr id="3" name="Notes Placeholder 2"/>
+          <p:cNvSpPr>
+            <a:spLocks noGrp="1"/>
+          </p:cNvSpPr>
+          <p:nvPr>
+            <p:ph type="body" idx="3" sz="quarter"/>
+          </p:nvPr>
+        </p:nvSpPr>
+        <p:spPr/>
+        <p:txBody>
+          <a:bodyPr/>
+          <a:lstStyle/>
+          <a:p>
+            <a:r>
+              <a:t>J2W_TEMPLATE: before_after_split</a:t>
+            </a:r>
+          </a:p>
+        </p:txBody>
+      </p:sp>
+      <p:sp>
+        <p:nvSpPr>
+          <p:cNvPr id="4" name="Slide Number Placeholder 3"/>
+          <p:cNvSpPr>
+            <a:spLocks noGrp="1"/>
+          </p:cNvSpPr>
+          <p:nvPr>
+            <p:ph type="sldNum" idx="5" sz="quarter"/>
+          </p:nvPr>
+        </p:nvSpPr>
+        <p:spPr/>
+      </p:sp>
+    </p:spTree>
+  </p:cSld>
+  <p:clrMapOvr>
+    <a:masterClrMapping/>
+  </p:clrMapOvr>
+</p:notes>
+</file>
+
+<file path=ppt/notesSlides/notesSlide15.xml><?xml version="1.0" encoding="utf-8"?>
+<p:notes xmlns:a="http://schemas.openxmlformats.org/drawingml/2006/main" xmlns:p="http://schemas.openxmlformats.org/presentationml/2006/main" xmlns:r="http://schemas.openxmlformats.org/officeDocument/2006/relationships">
+  <p:cSld>
+    <p:spTree>
+      <p:nvGrpSpPr>
+        <p:cNvPr id="1" name=""/>
+        <p:cNvGrpSpPr/>
+        <p:nvPr/>
+      </p:nvGrpSpPr>
+      <p:grpSpPr>
+        <a:xfrm>
+          <a:off x="0" y="0"/>
+          <a:ext cx="0" cy="0"/>
+          <a:chOff x="0" y="0"/>
+          <a:chExt cx="0" cy="0"/>
+        </a:xfrm>
+      </p:grpSpPr>
+      <p:sp>
+        <p:nvSpPr>
+          <p:cNvPr id="2" name="Slide Image Placeholder 1"/>
+          <p:cNvSpPr>
+            <a:spLocks noGrp="1"/>
+          </p:cNvSpPr>
+          <p:nvPr>
+            <p:ph type="sldImg" idx="2"/>
+          </p:nvPr>
+        </p:nvSpPr>
+        <p:spPr/>
+      </p:sp>
+      <p:sp>
+        <p:nvSpPr>
+          <p:cNvPr id="3" name="Notes Placeholder 2"/>
+          <p:cNvSpPr>
+            <a:spLocks noGrp="1"/>
+          </p:cNvSpPr>
+          <p:nvPr>
+            <p:ph type="body" idx="3" sz="quarter"/>
+          </p:nvPr>
+        </p:nvSpPr>
+        <p:spPr/>
+        <p:txBody>
+          <a:bodyPr/>
+          <a:lstStyle/>
+          <a:p>
+            <a:r>
+              <a:t>J2W_TEMPLATE: comparison_split</a:t>
+            </a:r>
+          </a:p>
+        </p:txBody>
+      </p:sp>
+      <p:sp>
+        <p:nvSpPr>
+          <p:cNvPr id="4" name="Slide Number Placeholder 3"/>
+          <p:cNvSpPr>
+            <a:spLocks noGrp="1"/>
+          </p:cNvSpPr>
+          <p:nvPr>
+            <p:ph type="sldNum" idx="5" sz="quarter"/>
+          </p:nvPr>
+        </p:nvSpPr>
+        <p:spPr/>
+      </p:sp>
+    </p:spTree>
+  </p:cSld>
+  <p:clrMapOvr>
+    <a:masterClrMapping/>
+  </p:clrMapOvr>
+</p:notes>
+</file>
+
+<file path=ppt/notesSlides/notesSlide16.xml><?xml version="1.0" encoding="utf-8"?>
+<p:notes xmlns:a="http://schemas.openxmlformats.org/drawingml/2006/main" xmlns:p="http://schemas.openxmlformats.org/presentationml/2006/main" xmlns:r="http://schemas.openxmlformats.org/officeDocument/2006/relationships">
+  <p:cSld>
+    <p:spTree>
+      <p:nvGrpSpPr>
+        <p:cNvPr id="1" name=""/>
+        <p:cNvGrpSpPr/>
+        <p:nvPr/>
+      </p:nvGrpSpPr>
+      <p:grpSpPr>
+        <a:xfrm>
+          <a:off x="0" y="0"/>
+          <a:ext cx="0" cy="0"/>
+          <a:chOff x="0" y="0"/>
+          <a:chExt cx="0" cy="0"/>
+        </a:xfrm>
+      </p:grpSpPr>
+      <p:sp>
+        <p:nvSpPr>
+          <p:cNvPr id="2" name="Slide Image Placeholder 1"/>
+          <p:cNvSpPr>
+            <a:spLocks noGrp="1"/>
+          </p:cNvSpPr>
+          <p:nvPr>
+            <p:ph type="sldImg" idx="2"/>
+          </p:nvPr>
+        </p:nvSpPr>
+        <p:spPr/>
+      </p:sp>
+      <p:sp>
+        <p:nvSpPr>
+          <p:cNvPr id="3" name="Notes Placeholder 2"/>
+          <p:cNvSpPr>
+            <a:spLocks noGrp="1"/>
+          </p:cNvSpPr>
+          <p:nvPr>
+            <p:ph type="body" idx="3" sz="quarter"/>
+          </p:nvPr>
+        </p:nvSpPr>
+        <p:spPr/>
+        <p:txBody>
+          <a:bodyPr/>
+          <a:lstStyle/>
+          <a:p>
+            <a:r>
+              <a:t>J2W_TEMPLATE: pillar_grid</a:t>
+            </a:r>
+          </a:p>
+        </p:txBody>
+      </p:sp>
+      <p:sp>
+        <p:nvSpPr>
+          <p:cNvPr id="4" name="Slide Number Placeholder 3"/>
+          <p:cNvSpPr>
+            <a:spLocks noGrp="1"/>
+          </p:cNvSpPr>
+          <p:nvPr>
+            <p:ph type="sldNum" idx="5" sz="quarter"/>
+          </p:nvPr>
+        </p:nvSpPr>
+        <p:spPr/>
+      </p:sp>
+    </p:spTree>
+  </p:cSld>
+  <p:clrMapOvr>
+    <a:masterClrMapping/>
+  </p:clrMapOvr>
+</p:notes>
+</file>
+
+<file path=ppt/notesSlides/notesSlide17.xml><?xml version="1.0" encoding="utf-8"?>
+<p:notes xmlns:a="http://schemas.openxmlformats.org/drawingml/2006/main" xmlns:p="http://schemas.openxmlformats.org/presentationml/2006/main" xmlns:r="http://schemas.openxmlformats.org/officeDocument/2006/relationships">
+  <p:cSld>
+    <p:spTree>
+      <p:nvGrpSpPr>
+        <p:cNvPr id="1" name=""/>
+        <p:cNvGrpSpPr/>
+        <p:nvPr/>
+      </p:nvGrpSpPr>
+      <p:grpSpPr>
+        <a:xfrm>
+          <a:off x="0" y="0"/>
+          <a:ext cx="0" cy="0"/>
+          <a:chOff x="0" y="0"/>
+          <a:chExt cx="0" cy="0"/>
+        </a:xfrm>
+      </p:grpSpPr>
+      <p:sp>
+        <p:nvSpPr>
+          <p:cNvPr id="2" name="Slide Image Placeholder 1"/>
+          <p:cNvSpPr>
+            <a:spLocks noGrp="1"/>
+          </p:cNvSpPr>
+          <p:nvPr>
+            <p:ph type="sldImg" idx="2"/>
+          </p:nvPr>
+        </p:nvSpPr>
+        <p:spPr/>
+      </p:sp>
+      <p:sp>
+        <p:nvSpPr>
+          <p:cNvPr id="3" name="Notes Placeholder 2"/>
+          <p:cNvSpPr>
+            <a:spLocks noGrp="1"/>
+          </p:cNvSpPr>
+          <p:nvPr>
+            <p:ph type="body" idx="3" sz="quarter"/>
+          </p:nvPr>
+        </p:nvSpPr>
+        <p:spPr/>
+        <p:txBody>
+          <a:bodyPr/>
+          <a:lstStyle/>
+          <a:p>
+            <a:r>
+              <a:t>J2W_TEMPLATE: option_columns</a:t>
+            </a:r>
+          </a:p>
+        </p:txBody>
+      </p:sp>
+      <p:sp>
+        <p:nvSpPr>
+          <p:cNvPr id="4" name="Slide Number Placeholder 3"/>
+          <p:cNvSpPr>
+            <a:spLocks noGrp="1"/>
+          </p:cNvSpPr>
+          <p:nvPr>
+            <p:ph type="sldNum" idx="5" sz="quarter"/>
+          </p:nvPr>
+        </p:nvSpPr>
+        <p:spPr/>
+      </p:sp>
+    </p:spTree>
+  </p:cSld>
+  <p:clrMapOvr>
+    <a:masterClrMapping/>
+  </p:clrMapOvr>
+</p:notes>
+</file>
+
+<file path=ppt/notesSlides/notesSlide18.xml><?xml version="1.0" encoding="utf-8"?>
+<p:notes xmlns:a="http://schemas.openxmlformats.org/drawingml/2006/main" xmlns:p="http://schemas.openxmlformats.org/presentationml/2006/main" xmlns:r="http://schemas.openxmlformats.org/officeDocument/2006/relationships">
+  <p:cSld>
+    <p:spTree>
+      <p:nvGrpSpPr>
+        <p:cNvPr id="1" name=""/>
+        <p:cNvGrpSpPr/>
+        <p:nvPr/>
+      </p:nvGrpSpPr>
+      <p:grpSpPr>
+        <a:xfrm>
+          <a:off x="0" y="0"/>
+          <a:ext cx="0" cy="0"/>
+          <a:chOff x="0" y="0"/>
+          <a:chExt cx="0" cy="0"/>
+        </a:xfrm>
+      </p:grpSpPr>
+      <p:sp>
+        <p:nvSpPr>
+          <p:cNvPr id="2" name="Slide Image Placeholder 1"/>
+          <p:cNvSpPr>
+            <a:spLocks noGrp="1"/>
+          </p:cNvSpPr>
+          <p:nvPr>
+            <p:ph type="sldImg" idx="2"/>
+          </p:nvPr>
+        </p:nvSpPr>
+        <p:spPr/>
+      </p:sp>
+      <p:sp>
+        <p:nvSpPr>
+          <p:cNvPr id="3" name="Notes Placeholder 2"/>
+          <p:cNvSpPr>
+            <a:spLocks noGrp="1"/>
+          </p:cNvSpPr>
+          <p:nvPr>
+            <p:ph type="body" idx="3" sz="quarter"/>
+          </p:nvPr>
+        </p:nvSpPr>
+        <p:spPr/>
+        <p:txBody>
+          <a:bodyPr/>
+          <a:lstStyle/>
+          <a:p>
+            <a:r>
+              <a:t>J2W_TEMPLATE: agent_architecture</a:t>
+            </a:r>
+          </a:p>
+        </p:txBody>
+      </p:sp>
+      <p:sp>
+        <p:nvSpPr>
+          <p:cNvPr id="4" name="Slide Number Placeholder 3"/>
+          <p:cNvSpPr>
+            <a:spLocks noGrp="1"/>
+          </p:cNvSpPr>
+          <p:nvPr>
+            <p:ph type="sldNum" idx="5" sz="quarter"/>
+          </p:nvPr>
+        </p:nvSpPr>
+        <p:spPr/>
+      </p:sp>
+    </p:spTree>
+  </p:cSld>
+  <p:clrMapOvr>
+    <a:masterClrMapping/>
+  </p:clrMapOvr>
+</p:notes>
+</file>
+
+<file path=ppt/notesSlides/notesSlide19.xml><?xml version="1.0" encoding="utf-8"?>
+<p:notes xmlns:a="http://schemas.openxmlformats.org/drawingml/2006/main" xmlns:p="http://schemas.openxmlformats.org/presentationml/2006/main" xmlns:r="http://schemas.openxmlformats.org/officeDocument/2006/relationships">
+  <p:cSld>
+    <p:spTree>
+      <p:nvGrpSpPr>
+        <p:cNvPr id="1" name=""/>
+        <p:cNvGrpSpPr/>
+        <p:nvPr/>
+      </p:nvGrpSpPr>
+      <p:grpSpPr>
+        <a:xfrm>
+          <a:off x="0" y="0"/>
+          <a:ext cx="0" cy="0"/>
+          <a:chOff x="0" y="0"/>
+          <a:chExt cx="0" cy="0"/>
+        </a:xfrm>
+      </p:grpSpPr>
+      <p:sp>
+        <p:nvSpPr>
+          <p:cNvPr id="2" name="Slide Image Placeholder 1"/>
+          <p:cNvSpPr>
+            <a:spLocks noGrp="1"/>
+          </p:cNvSpPr>
+          <p:nvPr>
+            <p:ph type="sldImg" idx="2"/>
+          </p:nvPr>
+        </p:nvSpPr>
+        <p:spPr/>
+      </p:sp>
+      <p:sp>
+        <p:nvSpPr>
+          <p:cNvPr id="3" name="Notes Placeholder 2"/>
+          <p:cNvSpPr>
+            <a:spLocks noGrp="1"/>
+          </p:cNvSpPr>
+          <p:nvPr>
+            <p:ph type="body" idx="3" sz="quarter"/>
+          </p:nvPr>
+        </p:nvSpPr>
+        <p:spPr/>
+        <p:txBody>
+          <a:bodyPr/>
+          <a:lstStyle/>
+          <a:p>
+            <a:r>
+              <a:t>J2W_TEMPLATE: governance_list</a:t>
+            </a:r>
+          </a:p>
+        </p:txBody>
+      </p:sp>
+      <p:sp>
+        <p:nvSpPr>
+          <p:cNvPr id="4" name="Slide Number Placeholder 3"/>
+          <p:cNvSpPr>
+            <a:spLocks noGrp="1"/>
+          </p:cNvSpPr>
+          <p:nvPr>
+            <p:ph type="sldNum" idx="5" sz="quarter"/>
+          </p:nvPr>
+        </p:nvSpPr>
+        <p:spPr/>
+      </p:sp>
+    </p:spTree>
+  </p:cSld>
+  <p:clrMapOvr>
+    <a:masterClrMapping/>
+  </p:clrMapOvr>
+</p:notes>
+</file>
+
 <file path=ppt/notesSlides/notesSlide2.xml><?xml version="1.0" encoding="utf-8"?>
 <p:notes xmlns:a="http://schemas.openxmlformats.org/drawingml/2006/main" xmlns:p="http://schemas.openxmlformats.org/presentationml/2006/main" xmlns:r="http://schemas.openxmlformats.org/officeDocument/2006/relationships">
   <p:cSld>
@@ -723,6 +1293,146 @@
           <a:p>
             <a:r>
               <a:t>J2W_TEMPLATE: industry_strength</a:t>
+            </a:r>
+          </a:p>
+        </p:txBody>
+      </p:sp>
+      <p:sp>
+        <p:nvSpPr>
+          <p:cNvPr id="4" name="Slide Number Placeholder 3"/>
+          <p:cNvSpPr>
+            <a:spLocks noGrp="1"/>
+          </p:cNvSpPr>
+          <p:nvPr>
+            <p:ph type="sldNum" idx="5" sz="quarter"/>
+          </p:nvPr>
+        </p:nvSpPr>
+        <p:spPr/>
+      </p:sp>
+    </p:spTree>
+  </p:cSld>
+  <p:clrMapOvr>
+    <a:masterClrMapping/>
+  </p:clrMapOvr>
+</p:notes>
+</file>
+
+<file path=ppt/notesSlides/notesSlide20.xml><?xml version="1.0" encoding="utf-8"?>
+<p:notes xmlns:a="http://schemas.openxmlformats.org/drawingml/2006/main" xmlns:p="http://schemas.openxmlformats.org/presentationml/2006/main" xmlns:r="http://schemas.openxmlformats.org/officeDocument/2006/relationships">
+  <p:cSld>
+    <p:spTree>
+      <p:nvGrpSpPr>
+        <p:cNvPr id="1" name=""/>
+        <p:cNvGrpSpPr/>
+        <p:nvPr/>
+      </p:nvGrpSpPr>
+      <p:grpSpPr>
+        <a:xfrm>
+          <a:off x="0" y="0"/>
+          <a:ext cx="0" cy="0"/>
+          <a:chOff x="0" y="0"/>
+          <a:chExt cx="0" cy="0"/>
+        </a:xfrm>
+      </p:grpSpPr>
+      <p:sp>
+        <p:nvSpPr>
+          <p:cNvPr id="2" name="Slide Image Placeholder 1"/>
+          <p:cNvSpPr>
+            <a:spLocks noGrp="1"/>
+          </p:cNvSpPr>
+          <p:nvPr>
+            <p:ph type="sldImg" idx="2"/>
+          </p:nvPr>
+        </p:nvSpPr>
+        <p:spPr/>
+      </p:sp>
+      <p:sp>
+        <p:nvSpPr>
+          <p:cNvPr id="3" name="Notes Placeholder 2"/>
+          <p:cNvSpPr>
+            <a:spLocks noGrp="1"/>
+          </p:cNvSpPr>
+          <p:nvPr>
+            <p:ph type="body" idx="3" sz="quarter"/>
+          </p:nvPr>
+        </p:nvSpPr>
+        <p:spPr/>
+        <p:txBody>
+          <a:bodyPr/>
+          <a:lstStyle/>
+          <a:p>
+            <a:r>
+              <a:t>J2W_TEMPLATE: guardrail_columns</a:t>
+            </a:r>
+          </a:p>
+        </p:txBody>
+      </p:sp>
+      <p:sp>
+        <p:nvSpPr>
+          <p:cNvPr id="4" name="Slide Number Placeholder 3"/>
+          <p:cNvSpPr>
+            <a:spLocks noGrp="1"/>
+          </p:cNvSpPr>
+          <p:nvPr>
+            <p:ph type="sldNum" idx="5" sz="quarter"/>
+          </p:nvPr>
+        </p:nvSpPr>
+        <p:spPr/>
+      </p:sp>
+    </p:spTree>
+  </p:cSld>
+  <p:clrMapOvr>
+    <a:masterClrMapping/>
+  </p:clrMapOvr>
+</p:notes>
+</file>
+
+<file path=ppt/notesSlides/notesSlide21.xml><?xml version="1.0" encoding="utf-8"?>
+<p:notes xmlns:a="http://schemas.openxmlformats.org/drawingml/2006/main" xmlns:p="http://schemas.openxmlformats.org/presentationml/2006/main" xmlns:r="http://schemas.openxmlformats.org/officeDocument/2006/relationships">
+  <p:cSld>
+    <p:spTree>
+      <p:nvGrpSpPr>
+        <p:cNvPr id="1" name=""/>
+        <p:cNvGrpSpPr/>
+        <p:nvPr/>
+      </p:nvGrpSpPr>
+      <p:grpSpPr>
+        <a:xfrm>
+          <a:off x="0" y="0"/>
+          <a:ext cx="0" cy="0"/>
+          <a:chOff x="0" y="0"/>
+          <a:chExt cx="0" cy="0"/>
+        </a:xfrm>
+      </p:grpSpPr>
+      <p:sp>
+        <p:nvSpPr>
+          <p:cNvPr id="2" name="Slide Image Placeholder 1"/>
+          <p:cNvSpPr>
+            <a:spLocks noGrp="1"/>
+          </p:cNvSpPr>
+          <p:nvPr>
+            <p:ph type="sldImg" idx="2"/>
+          </p:nvPr>
+        </p:nvSpPr>
+        <p:spPr/>
+      </p:sp>
+      <p:sp>
+        <p:nvSpPr>
+          <p:cNvPr id="3" name="Notes Placeholder 2"/>
+          <p:cNvSpPr>
+            <a:spLocks noGrp="1"/>
+          </p:cNvSpPr>
+          <p:nvPr>
+            <p:ph type="body" idx="3" sz="quarter"/>
+          </p:nvPr>
+        </p:nvSpPr>
+        <p:spPr/>
+        <p:txBody>
+          <a:bodyPr/>
+          <a:lstStyle/>
+          <a:p>
+            <a:r>
+              <a:t>J2W_TEMPLATE: opportunity_cards</a:t>
             </a:r>
           </a:p>
         </p:txBody>
@@ -5443,6 +6153,2118 @@
 </p:sld>
 </file>
 
+<file path=ppt/slides/slide12.xml><?xml version="1.0" encoding="utf-8"?>
+<p:sld xmlns:a="http://schemas.openxmlformats.org/drawingml/2006/main" xmlns:p="http://schemas.openxmlformats.org/presentationml/2006/main" xmlns:r="http://schemas.openxmlformats.org/officeDocument/2006/relationships">
+  <p:cSld>
+    <p:spTree>
+      <p:nvGrpSpPr>
+        <p:cNvPr id="1" name=""/>
+        <p:cNvGrpSpPr/>
+        <p:nvPr/>
+      </p:nvGrpSpPr>
+      <p:grpSpPr/>
+      <p:sp>
+        <p:nvSpPr>
+          <p:cNvPr id="2" name="Rectangle 1"/>
+          <p:cNvSpPr/>
+          <p:nvPr/>
+        </p:nvSpPr>
+        <p:spPr>
+          <a:xfrm>
+            <a:off x="0" y="0"/>
+            <a:ext cx="8129016" cy="75895"/>
+          </a:xfrm>
+          <a:prstGeom prst="rect">
+            <a:avLst/>
+          </a:prstGeom>
+          <a:solidFill>
+            <a:srgbClr val="D62839"/>
+          </a:solidFill>
+          <a:ln>
+            <a:noFill/>
+          </a:ln>
+          <a:effectLst/>
+        </p:spPr>
+        <p:style>
+          <a:lnRef idx="1">
+            <a:schemeClr val="accent1"/>
+          </a:lnRef>
+          <a:fillRef idx="3">
+            <a:schemeClr val="accent1"/>
+          </a:fillRef>
+          <a:effectRef idx="2">
+            <a:schemeClr val="accent1"/>
+          </a:effectRef>
+          <a:fontRef idx="minor">
+            <a:schemeClr val="lt1"/>
+          </a:fontRef>
+        </p:style>
+        <p:txBody>
+          <a:bodyPr rtlCol="0" anchor="ctr"/>
+          <a:lstStyle/>
+          <a:p>
+            <a:pPr algn="ctr"/>
+          </a:p>
+        </p:txBody>
+      </p:sp>
+      <p:sp>
+        <p:nvSpPr>
+          <p:cNvPr id="3" name="Rectangle 2"/>
+          <p:cNvSpPr/>
+          <p:nvPr/>
+        </p:nvSpPr>
+        <p:spPr>
+          <a:xfrm>
+            <a:off x="8129016" y="0"/>
+            <a:ext cx="4059935" cy="75895"/>
+          </a:xfrm>
+          <a:prstGeom prst="rect">
+            <a:avLst/>
+          </a:prstGeom>
+          <a:solidFill>
+            <a:srgbClr val="2A9D8F"/>
+          </a:solidFill>
+          <a:ln>
+            <a:noFill/>
+          </a:ln>
+          <a:effectLst/>
+        </p:spPr>
+        <p:style>
+          <a:lnRef idx="1">
+            <a:schemeClr val="accent1"/>
+          </a:lnRef>
+          <a:fillRef idx="3">
+            <a:schemeClr val="accent1"/>
+          </a:fillRef>
+          <a:effectRef idx="2">
+            <a:schemeClr val="accent1"/>
+          </a:effectRef>
+          <a:fontRef idx="minor">
+            <a:schemeClr val="lt1"/>
+          </a:fontRef>
+        </p:style>
+        <p:txBody>
+          <a:bodyPr rtlCol="0" anchor="ctr"/>
+          <a:lstStyle/>
+          <a:p>
+            <a:pPr algn="ctr"/>
+          </a:p>
+        </p:txBody>
+      </p:sp>
+      <p:sp>
+        <p:nvSpPr>
+          <p:cNvPr id="4" name="Rectangle 3"/>
+          <p:cNvSpPr/>
+          <p:nvPr/>
+        </p:nvSpPr>
+        <p:spPr>
+          <a:xfrm>
+            <a:off x="228600" y="274320"/>
+            <a:ext cx="59436" cy="475488"/>
+          </a:xfrm>
+          <a:prstGeom prst="rect">
+            <a:avLst/>
+          </a:prstGeom>
+          <a:solidFill>
+            <a:srgbClr val="D62839"/>
+          </a:solidFill>
+          <a:ln>
+            <a:noFill/>
+          </a:ln>
+          <a:effectLst/>
+        </p:spPr>
+        <p:style>
+          <a:lnRef idx="1">
+            <a:schemeClr val="accent1"/>
+          </a:lnRef>
+          <a:fillRef idx="3">
+            <a:schemeClr val="accent1"/>
+          </a:fillRef>
+          <a:effectRef idx="2">
+            <a:schemeClr val="accent1"/>
+          </a:effectRef>
+          <a:fontRef idx="minor">
+            <a:schemeClr val="lt1"/>
+          </a:fontRef>
+        </p:style>
+        <p:txBody>
+          <a:bodyPr rtlCol="0" anchor="ctr"/>
+          <a:lstStyle/>
+          <a:p>
+            <a:pPr algn="ctr"/>
+          </a:p>
+        </p:txBody>
+      </p:sp>
+      <p:sp>
+        <p:nvSpPr>
+          <p:cNvPr id="5" name="TextBox 4"/>
+          <p:cNvSpPr txBox="1"/>
+          <p:nvPr/>
+        </p:nvSpPr>
+        <p:spPr>
+          <a:xfrm>
+            <a:off x="402336" y="237744"/>
+            <a:ext cx="11338560" cy="475488"/>
+          </a:xfrm>
+          <a:prstGeom prst="rect">
+            <a:avLst/>
+          </a:prstGeom>
+          <a:noFill/>
+        </p:spPr>
+        <p:txBody>
+          <a:bodyPr wrap="square" anchor="t" tIns="0" bIns="0">
+            <a:spAutoFit/>
+          </a:bodyPr>
+          <a:lstStyle/>
+          <a:p>
+            <a:pPr algn="l"/>
+            <a:r>
+              <a:rPr sz="2400" b="1" i="0">
+                <a:solidFill>
+                  <a:srgbClr val="111110"/>
+                </a:solidFill>
+                <a:latin typeface="Oswald"/>
+              </a:rPr>
+              <a:t>{{TITLE}}</a:t>
+            </a:r>
+          </a:p>
+        </p:txBody>
+      </p:sp>
+      <p:sp>
+        <p:nvSpPr>
+          <p:cNvPr id="6" name="TextBox 5"/>
+          <p:cNvSpPr txBox="1"/>
+          <p:nvPr/>
+        </p:nvSpPr>
+        <p:spPr>
+          <a:xfrm>
+            <a:off x="402336" y="731520"/>
+            <a:ext cx="11521440" cy="310896"/>
+          </a:xfrm>
+          <a:prstGeom prst="rect">
+            <a:avLst/>
+          </a:prstGeom>
+          <a:noFill/>
+        </p:spPr>
+        <p:txBody>
+          <a:bodyPr wrap="square" anchor="t" tIns="0" bIns="0">
+            <a:spAutoFit/>
+          </a:bodyPr>
+          <a:lstStyle/>
+          <a:p>
+            <a:pPr algn="l"/>
+            <a:r>
+              <a:rPr sz="1500" b="1" i="0">
+                <a:solidFill>
+                  <a:srgbClr val="2A9D8F"/>
+                </a:solidFill>
+                <a:latin typeface="Roboto Condensed"/>
+              </a:rPr>
+              <a:t>{{SUBHEAD}}</a:t>
+            </a:r>
+          </a:p>
+        </p:txBody>
+      </p:sp>
+      <p:sp>
+        <p:nvSpPr>
+          <p:cNvPr id="7" name="Rectangle 6"/>
+          <p:cNvSpPr/>
+          <p:nvPr/>
+        </p:nvSpPr>
+        <p:spPr>
+          <a:xfrm>
+            <a:off x="0" y="6766560"/>
+            <a:ext cx="12188952" cy="91440"/>
+          </a:xfrm>
+          <a:prstGeom prst="rect">
+            <a:avLst/>
+          </a:prstGeom>
+          <a:solidFill>
+            <a:srgbClr val="2A9D8F"/>
+          </a:solidFill>
+          <a:ln>
+            <a:noFill/>
+          </a:ln>
+          <a:effectLst/>
+        </p:spPr>
+        <p:style>
+          <a:lnRef idx="1">
+            <a:schemeClr val="accent1"/>
+          </a:lnRef>
+          <a:fillRef idx="3">
+            <a:schemeClr val="accent1"/>
+          </a:fillRef>
+          <a:effectRef idx="2">
+            <a:schemeClr val="accent1"/>
+          </a:effectRef>
+          <a:fontRef idx="minor">
+            <a:schemeClr val="lt1"/>
+          </a:fontRef>
+        </p:style>
+        <p:txBody>
+          <a:bodyPr rtlCol="0" anchor="ctr"/>
+          <a:lstStyle/>
+          <a:p>
+            <a:pPr algn="ctr"/>
+          </a:p>
+        </p:txBody>
+      </p:sp>
+    </p:spTree>
+  </p:cSld>
+  <p:clrMapOvr>
+    <a:masterClrMapping/>
+  </p:clrMapOvr>
+</p:sld>
+</file>
+
+<file path=ppt/slides/slide13.xml><?xml version="1.0" encoding="utf-8"?>
+<p:sld xmlns:a="http://schemas.openxmlformats.org/drawingml/2006/main" xmlns:p="http://schemas.openxmlformats.org/presentationml/2006/main" xmlns:r="http://schemas.openxmlformats.org/officeDocument/2006/relationships">
+  <p:cSld>
+    <p:spTree>
+      <p:nvGrpSpPr>
+        <p:cNvPr id="1" name=""/>
+        <p:cNvGrpSpPr/>
+        <p:nvPr/>
+      </p:nvGrpSpPr>
+      <p:grpSpPr/>
+      <p:sp>
+        <p:nvSpPr>
+          <p:cNvPr id="2" name="Rectangle 1"/>
+          <p:cNvSpPr/>
+          <p:nvPr/>
+        </p:nvSpPr>
+        <p:spPr>
+          <a:xfrm>
+            <a:off x="0" y="0"/>
+            <a:ext cx="8129016" cy="75895"/>
+          </a:xfrm>
+          <a:prstGeom prst="rect">
+            <a:avLst/>
+          </a:prstGeom>
+          <a:solidFill>
+            <a:srgbClr val="D62839"/>
+          </a:solidFill>
+          <a:ln>
+            <a:noFill/>
+          </a:ln>
+          <a:effectLst/>
+        </p:spPr>
+        <p:style>
+          <a:lnRef idx="1">
+            <a:schemeClr val="accent1"/>
+          </a:lnRef>
+          <a:fillRef idx="3">
+            <a:schemeClr val="accent1"/>
+          </a:fillRef>
+          <a:effectRef idx="2">
+            <a:schemeClr val="accent1"/>
+          </a:effectRef>
+          <a:fontRef idx="minor">
+            <a:schemeClr val="lt1"/>
+          </a:fontRef>
+        </p:style>
+        <p:txBody>
+          <a:bodyPr rtlCol="0" anchor="ctr"/>
+          <a:lstStyle/>
+          <a:p>
+            <a:pPr algn="ctr"/>
+          </a:p>
+        </p:txBody>
+      </p:sp>
+      <p:sp>
+        <p:nvSpPr>
+          <p:cNvPr id="3" name="Rectangle 2"/>
+          <p:cNvSpPr/>
+          <p:nvPr/>
+        </p:nvSpPr>
+        <p:spPr>
+          <a:xfrm>
+            <a:off x="8129016" y="0"/>
+            <a:ext cx="4059935" cy="75895"/>
+          </a:xfrm>
+          <a:prstGeom prst="rect">
+            <a:avLst/>
+          </a:prstGeom>
+          <a:solidFill>
+            <a:srgbClr val="2A9D8F"/>
+          </a:solidFill>
+          <a:ln>
+            <a:noFill/>
+          </a:ln>
+          <a:effectLst/>
+        </p:spPr>
+        <p:style>
+          <a:lnRef idx="1">
+            <a:schemeClr val="accent1"/>
+          </a:lnRef>
+          <a:fillRef idx="3">
+            <a:schemeClr val="accent1"/>
+          </a:fillRef>
+          <a:effectRef idx="2">
+            <a:schemeClr val="accent1"/>
+          </a:effectRef>
+          <a:fontRef idx="minor">
+            <a:schemeClr val="lt1"/>
+          </a:fontRef>
+        </p:style>
+        <p:txBody>
+          <a:bodyPr rtlCol="0" anchor="ctr"/>
+          <a:lstStyle/>
+          <a:p>
+            <a:pPr algn="ctr"/>
+          </a:p>
+        </p:txBody>
+      </p:sp>
+      <p:sp>
+        <p:nvSpPr>
+          <p:cNvPr id="4" name="Rectangle 3"/>
+          <p:cNvSpPr/>
+          <p:nvPr/>
+        </p:nvSpPr>
+        <p:spPr>
+          <a:xfrm>
+            <a:off x="228600" y="274320"/>
+            <a:ext cx="59436" cy="475488"/>
+          </a:xfrm>
+          <a:prstGeom prst="rect">
+            <a:avLst/>
+          </a:prstGeom>
+          <a:solidFill>
+            <a:srgbClr val="D62839"/>
+          </a:solidFill>
+          <a:ln>
+            <a:noFill/>
+          </a:ln>
+          <a:effectLst/>
+        </p:spPr>
+        <p:style>
+          <a:lnRef idx="1">
+            <a:schemeClr val="accent1"/>
+          </a:lnRef>
+          <a:fillRef idx="3">
+            <a:schemeClr val="accent1"/>
+          </a:fillRef>
+          <a:effectRef idx="2">
+            <a:schemeClr val="accent1"/>
+          </a:effectRef>
+          <a:fontRef idx="minor">
+            <a:schemeClr val="lt1"/>
+          </a:fontRef>
+        </p:style>
+        <p:txBody>
+          <a:bodyPr rtlCol="0" anchor="ctr"/>
+          <a:lstStyle/>
+          <a:p>
+            <a:pPr algn="ctr"/>
+          </a:p>
+        </p:txBody>
+      </p:sp>
+      <p:sp>
+        <p:nvSpPr>
+          <p:cNvPr id="5" name="TextBox 4"/>
+          <p:cNvSpPr txBox="1"/>
+          <p:nvPr/>
+        </p:nvSpPr>
+        <p:spPr>
+          <a:xfrm>
+            <a:off x="402336" y="237744"/>
+            <a:ext cx="11338560" cy="475488"/>
+          </a:xfrm>
+          <a:prstGeom prst="rect">
+            <a:avLst/>
+          </a:prstGeom>
+          <a:noFill/>
+        </p:spPr>
+        <p:txBody>
+          <a:bodyPr wrap="square" anchor="t" tIns="0" bIns="0">
+            <a:spAutoFit/>
+          </a:bodyPr>
+          <a:lstStyle/>
+          <a:p>
+            <a:pPr algn="l"/>
+            <a:r>
+              <a:rPr sz="2400" b="1" i="0">
+                <a:solidFill>
+                  <a:srgbClr val="111110"/>
+                </a:solidFill>
+                <a:latin typeface="Oswald"/>
+              </a:rPr>
+              <a:t>{{TITLE}}</a:t>
+            </a:r>
+          </a:p>
+        </p:txBody>
+      </p:sp>
+      <p:sp>
+        <p:nvSpPr>
+          <p:cNvPr id="6" name="TextBox 5"/>
+          <p:cNvSpPr txBox="1"/>
+          <p:nvPr/>
+        </p:nvSpPr>
+        <p:spPr>
+          <a:xfrm>
+            <a:off x="402336" y="731520"/>
+            <a:ext cx="11521440" cy="310896"/>
+          </a:xfrm>
+          <a:prstGeom prst="rect">
+            <a:avLst/>
+          </a:prstGeom>
+          <a:noFill/>
+        </p:spPr>
+        <p:txBody>
+          <a:bodyPr wrap="square" anchor="t" tIns="0" bIns="0">
+            <a:spAutoFit/>
+          </a:bodyPr>
+          <a:lstStyle/>
+          <a:p>
+            <a:pPr algn="l"/>
+            <a:r>
+              <a:rPr sz="1500" b="1" i="0">
+                <a:solidFill>
+                  <a:srgbClr val="2A9D8F"/>
+                </a:solidFill>
+                <a:latin typeface="Roboto Condensed"/>
+              </a:rPr>
+              <a:t>{{SUBHEAD}}</a:t>
+            </a:r>
+          </a:p>
+        </p:txBody>
+      </p:sp>
+      <p:sp>
+        <p:nvSpPr>
+          <p:cNvPr id="7" name="Rectangle 6"/>
+          <p:cNvSpPr/>
+          <p:nvPr/>
+        </p:nvSpPr>
+        <p:spPr>
+          <a:xfrm>
+            <a:off x="0" y="6766560"/>
+            <a:ext cx="12188952" cy="91440"/>
+          </a:xfrm>
+          <a:prstGeom prst="rect">
+            <a:avLst/>
+          </a:prstGeom>
+          <a:solidFill>
+            <a:srgbClr val="2A9D8F"/>
+          </a:solidFill>
+          <a:ln>
+            <a:noFill/>
+          </a:ln>
+          <a:effectLst/>
+        </p:spPr>
+        <p:style>
+          <a:lnRef idx="1">
+            <a:schemeClr val="accent1"/>
+          </a:lnRef>
+          <a:fillRef idx="3">
+            <a:schemeClr val="accent1"/>
+          </a:fillRef>
+          <a:effectRef idx="2">
+            <a:schemeClr val="accent1"/>
+          </a:effectRef>
+          <a:fontRef idx="minor">
+            <a:schemeClr val="lt1"/>
+          </a:fontRef>
+        </p:style>
+        <p:txBody>
+          <a:bodyPr rtlCol="0" anchor="ctr"/>
+          <a:lstStyle/>
+          <a:p>
+            <a:pPr algn="ctr"/>
+          </a:p>
+        </p:txBody>
+      </p:sp>
+    </p:spTree>
+  </p:cSld>
+  <p:clrMapOvr>
+    <a:masterClrMapping/>
+  </p:clrMapOvr>
+</p:sld>
+</file>
+
+<file path=ppt/slides/slide14.xml><?xml version="1.0" encoding="utf-8"?>
+<p:sld xmlns:a="http://schemas.openxmlformats.org/drawingml/2006/main" xmlns:p="http://schemas.openxmlformats.org/presentationml/2006/main" xmlns:r="http://schemas.openxmlformats.org/officeDocument/2006/relationships">
+  <p:cSld>
+    <p:spTree>
+      <p:nvGrpSpPr>
+        <p:cNvPr id="1" name=""/>
+        <p:cNvGrpSpPr/>
+        <p:nvPr/>
+      </p:nvGrpSpPr>
+      <p:grpSpPr/>
+      <p:sp>
+        <p:nvSpPr>
+          <p:cNvPr id="2" name="Rectangle 1"/>
+          <p:cNvSpPr/>
+          <p:nvPr/>
+        </p:nvSpPr>
+        <p:spPr>
+          <a:xfrm>
+            <a:off x="0" y="0"/>
+            <a:ext cx="8129016" cy="75895"/>
+          </a:xfrm>
+          <a:prstGeom prst="rect">
+            <a:avLst/>
+          </a:prstGeom>
+          <a:solidFill>
+            <a:srgbClr val="D62839"/>
+          </a:solidFill>
+          <a:ln>
+            <a:noFill/>
+          </a:ln>
+          <a:effectLst/>
+        </p:spPr>
+        <p:style>
+          <a:lnRef idx="1">
+            <a:schemeClr val="accent1"/>
+          </a:lnRef>
+          <a:fillRef idx="3">
+            <a:schemeClr val="accent1"/>
+          </a:fillRef>
+          <a:effectRef idx="2">
+            <a:schemeClr val="accent1"/>
+          </a:effectRef>
+          <a:fontRef idx="minor">
+            <a:schemeClr val="lt1"/>
+          </a:fontRef>
+        </p:style>
+        <p:txBody>
+          <a:bodyPr rtlCol="0" anchor="ctr"/>
+          <a:lstStyle/>
+          <a:p>
+            <a:pPr algn="ctr"/>
+          </a:p>
+        </p:txBody>
+      </p:sp>
+      <p:sp>
+        <p:nvSpPr>
+          <p:cNvPr id="3" name="Rectangle 2"/>
+          <p:cNvSpPr/>
+          <p:nvPr/>
+        </p:nvSpPr>
+        <p:spPr>
+          <a:xfrm>
+            <a:off x="8129016" y="0"/>
+            <a:ext cx="4059935" cy="75895"/>
+          </a:xfrm>
+          <a:prstGeom prst="rect">
+            <a:avLst/>
+          </a:prstGeom>
+          <a:solidFill>
+            <a:srgbClr val="2A9D8F"/>
+          </a:solidFill>
+          <a:ln>
+            <a:noFill/>
+          </a:ln>
+          <a:effectLst/>
+        </p:spPr>
+        <p:style>
+          <a:lnRef idx="1">
+            <a:schemeClr val="accent1"/>
+          </a:lnRef>
+          <a:fillRef idx="3">
+            <a:schemeClr val="accent1"/>
+          </a:fillRef>
+          <a:effectRef idx="2">
+            <a:schemeClr val="accent1"/>
+          </a:effectRef>
+          <a:fontRef idx="minor">
+            <a:schemeClr val="lt1"/>
+          </a:fontRef>
+        </p:style>
+        <p:txBody>
+          <a:bodyPr rtlCol="0" anchor="ctr"/>
+          <a:lstStyle/>
+          <a:p>
+            <a:pPr algn="ctr"/>
+          </a:p>
+        </p:txBody>
+      </p:sp>
+      <p:sp>
+        <p:nvSpPr>
+          <p:cNvPr id="4" name="Rectangle 3"/>
+          <p:cNvSpPr/>
+          <p:nvPr/>
+        </p:nvSpPr>
+        <p:spPr>
+          <a:xfrm>
+            <a:off x="228600" y="274320"/>
+            <a:ext cx="59436" cy="475488"/>
+          </a:xfrm>
+          <a:prstGeom prst="rect">
+            <a:avLst/>
+          </a:prstGeom>
+          <a:solidFill>
+            <a:srgbClr val="D62839"/>
+          </a:solidFill>
+          <a:ln>
+            <a:noFill/>
+          </a:ln>
+          <a:effectLst/>
+        </p:spPr>
+        <p:style>
+          <a:lnRef idx="1">
+            <a:schemeClr val="accent1"/>
+          </a:lnRef>
+          <a:fillRef idx="3">
+            <a:schemeClr val="accent1"/>
+          </a:fillRef>
+          <a:effectRef idx="2">
+            <a:schemeClr val="accent1"/>
+          </a:effectRef>
+          <a:fontRef idx="minor">
+            <a:schemeClr val="lt1"/>
+          </a:fontRef>
+        </p:style>
+        <p:txBody>
+          <a:bodyPr rtlCol="0" anchor="ctr"/>
+          <a:lstStyle/>
+          <a:p>
+            <a:pPr algn="ctr"/>
+          </a:p>
+        </p:txBody>
+      </p:sp>
+      <p:sp>
+        <p:nvSpPr>
+          <p:cNvPr id="5" name="TextBox 4"/>
+          <p:cNvSpPr txBox="1"/>
+          <p:nvPr/>
+        </p:nvSpPr>
+        <p:spPr>
+          <a:xfrm>
+            <a:off x="402336" y="237744"/>
+            <a:ext cx="11338560" cy="475488"/>
+          </a:xfrm>
+          <a:prstGeom prst="rect">
+            <a:avLst/>
+          </a:prstGeom>
+          <a:noFill/>
+        </p:spPr>
+        <p:txBody>
+          <a:bodyPr wrap="square" anchor="t" tIns="0" bIns="0">
+            <a:spAutoFit/>
+          </a:bodyPr>
+          <a:lstStyle/>
+          <a:p>
+            <a:pPr algn="l"/>
+            <a:r>
+              <a:rPr sz="2400" b="1" i="0">
+                <a:solidFill>
+                  <a:srgbClr val="111110"/>
+                </a:solidFill>
+                <a:latin typeface="Oswald"/>
+              </a:rPr>
+              <a:t>{{TITLE}}</a:t>
+            </a:r>
+          </a:p>
+        </p:txBody>
+      </p:sp>
+      <p:sp>
+        <p:nvSpPr>
+          <p:cNvPr id="6" name="TextBox 5"/>
+          <p:cNvSpPr txBox="1"/>
+          <p:nvPr/>
+        </p:nvSpPr>
+        <p:spPr>
+          <a:xfrm>
+            <a:off x="402336" y="731520"/>
+            <a:ext cx="11521440" cy="310896"/>
+          </a:xfrm>
+          <a:prstGeom prst="rect">
+            <a:avLst/>
+          </a:prstGeom>
+          <a:noFill/>
+        </p:spPr>
+        <p:txBody>
+          <a:bodyPr wrap="square" anchor="t" tIns="0" bIns="0">
+            <a:spAutoFit/>
+          </a:bodyPr>
+          <a:lstStyle/>
+          <a:p>
+            <a:pPr algn="l"/>
+            <a:r>
+              <a:rPr sz="1500" b="1" i="0">
+                <a:solidFill>
+                  <a:srgbClr val="2A9D8F"/>
+                </a:solidFill>
+                <a:latin typeface="Roboto Condensed"/>
+              </a:rPr>
+              <a:t>{{SUBHEAD}}</a:t>
+            </a:r>
+          </a:p>
+        </p:txBody>
+      </p:sp>
+      <p:sp>
+        <p:nvSpPr>
+          <p:cNvPr id="7" name="Rectangle 6"/>
+          <p:cNvSpPr/>
+          <p:nvPr/>
+        </p:nvSpPr>
+        <p:spPr>
+          <a:xfrm>
+            <a:off x="0" y="6766560"/>
+            <a:ext cx="12188952" cy="91440"/>
+          </a:xfrm>
+          <a:prstGeom prst="rect">
+            <a:avLst/>
+          </a:prstGeom>
+          <a:solidFill>
+            <a:srgbClr val="2A9D8F"/>
+          </a:solidFill>
+          <a:ln>
+            <a:noFill/>
+          </a:ln>
+          <a:effectLst/>
+        </p:spPr>
+        <p:style>
+          <a:lnRef idx="1">
+            <a:schemeClr val="accent1"/>
+          </a:lnRef>
+          <a:fillRef idx="3">
+            <a:schemeClr val="accent1"/>
+          </a:fillRef>
+          <a:effectRef idx="2">
+            <a:schemeClr val="accent1"/>
+          </a:effectRef>
+          <a:fontRef idx="minor">
+            <a:schemeClr val="lt1"/>
+          </a:fontRef>
+        </p:style>
+        <p:txBody>
+          <a:bodyPr rtlCol="0" anchor="ctr"/>
+          <a:lstStyle/>
+          <a:p>
+            <a:pPr algn="ctr"/>
+          </a:p>
+        </p:txBody>
+      </p:sp>
+    </p:spTree>
+  </p:cSld>
+  <p:clrMapOvr>
+    <a:masterClrMapping/>
+  </p:clrMapOvr>
+</p:sld>
+</file>
+
+<file path=ppt/slides/slide15.xml><?xml version="1.0" encoding="utf-8"?>
+<p:sld xmlns:a="http://schemas.openxmlformats.org/drawingml/2006/main" xmlns:p="http://schemas.openxmlformats.org/presentationml/2006/main" xmlns:r="http://schemas.openxmlformats.org/officeDocument/2006/relationships">
+  <p:cSld>
+    <p:spTree>
+      <p:nvGrpSpPr>
+        <p:cNvPr id="1" name=""/>
+        <p:cNvGrpSpPr/>
+        <p:nvPr/>
+      </p:nvGrpSpPr>
+      <p:grpSpPr/>
+      <p:sp>
+        <p:nvSpPr>
+          <p:cNvPr id="2" name="Rectangle 1"/>
+          <p:cNvSpPr/>
+          <p:nvPr/>
+        </p:nvSpPr>
+        <p:spPr>
+          <a:xfrm>
+            <a:off x="0" y="0"/>
+            <a:ext cx="8129016" cy="75895"/>
+          </a:xfrm>
+          <a:prstGeom prst="rect">
+            <a:avLst/>
+          </a:prstGeom>
+          <a:solidFill>
+            <a:srgbClr val="D62839"/>
+          </a:solidFill>
+          <a:ln>
+            <a:noFill/>
+          </a:ln>
+          <a:effectLst/>
+        </p:spPr>
+        <p:style>
+          <a:lnRef idx="1">
+            <a:schemeClr val="accent1"/>
+          </a:lnRef>
+          <a:fillRef idx="3">
+            <a:schemeClr val="accent1"/>
+          </a:fillRef>
+          <a:effectRef idx="2">
+            <a:schemeClr val="accent1"/>
+          </a:effectRef>
+          <a:fontRef idx="minor">
+            <a:schemeClr val="lt1"/>
+          </a:fontRef>
+        </p:style>
+        <p:txBody>
+          <a:bodyPr rtlCol="0" anchor="ctr"/>
+          <a:lstStyle/>
+          <a:p>
+            <a:pPr algn="ctr"/>
+          </a:p>
+        </p:txBody>
+      </p:sp>
+      <p:sp>
+        <p:nvSpPr>
+          <p:cNvPr id="3" name="Rectangle 2"/>
+          <p:cNvSpPr/>
+          <p:nvPr/>
+        </p:nvSpPr>
+        <p:spPr>
+          <a:xfrm>
+            <a:off x="8129016" y="0"/>
+            <a:ext cx="4059935" cy="75895"/>
+          </a:xfrm>
+          <a:prstGeom prst="rect">
+            <a:avLst/>
+          </a:prstGeom>
+          <a:solidFill>
+            <a:srgbClr val="2A9D8F"/>
+          </a:solidFill>
+          <a:ln>
+            <a:noFill/>
+          </a:ln>
+          <a:effectLst/>
+        </p:spPr>
+        <p:style>
+          <a:lnRef idx="1">
+            <a:schemeClr val="accent1"/>
+          </a:lnRef>
+          <a:fillRef idx="3">
+            <a:schemeClr val="accent1"/>
+          </a:fillRef>
+          <a:effectRef idx="2">
+            <a:schemeClr val="accent1"/>
+          </a:effectRef>
+          <a:fontRef idx="minor">
+            <a:schemeClr val="lt1"/>
+          </a:fontRef>
+        </p:style>
+        <p:txBody>
+          <a:bodyPr rtlCol="0" anchor="ctr"/>
+          <a:lstStyle/>
+          <a:p>
+            <a:pPr algn="ctr"/>
+          </a:p>
+        </p:txBody>
+      </p:sp>
+      <p:sp>
+        <p:nvSpPr>
+          <p:cNvPr id="4" name="Rectangle 3"/>
+          <p:cNvSpPr/>
+          <p:nvPr/>
+        </p:nvSpPr>
+        <p:spPr>
+          <a:xfrm>
+            <a:off x="228600" y="274320"/>
+            <a:ext cx="59436" cy="475488"/>
+          </a:xfrm>
+          <a:prstGeom prst="rect">
+            <a:avLst/>
+          </a:prstGeom>
+          <a:solidFill>
+            <a:srgbClr val="D62839"/>
+          </a:solidFill>
+          <a:ln>
+            <a:noFill/>
+          </a:ln>
+          <a:effectLst/>
+        </p:spPr>
+        <p:style>
+          <a:lnRef idx="1">
+            <a:schemeClr val="accent1"/>
+          </a:lnRef>
+          <a:fillRef idx="3">
+            <a:schemeClr val="accent1"/>
+          </a:fillRef>
+          <a:effectRef idx="2">
+            <a:schemeClr val="accent1"/>
+          </a:effectRef>
+          <a:fontRef idx="minor">
+            <a:schemeClr val="lt1"/>
+          </a:fontRef>
+        </p:style>
+        <p:txBody>
+          <a:bodyPr rtlCol="0" anchor="ctr"/>
+          <a:lstStyle/>
+          <a:p>
+            <a:pPr algn="ctr"/>
+          </a:p>
+        </p:txBody>
+      </p:sp>
+      <p:sp>
+        <p:nvSpPr>
+          <p:cNvPr id="5" name="TextBox 4"/>
+          <p:cNvSpPr txBox="1"/>
+          <p:nvPr/>
+        </p:nvSpPr>
+        <p:spPr>
+          <a:xfrm>
+            <a:off x="402336" y="237744"/>
+            <a:ext cx="11338560" cy="475488"/>
+          </a:xfrm>
+          <a:prstGeom prst="rect">
+            <a:avLst/>
+          </a:prstGeom>
+          <a:noFill/>
+        </p:spPr>
+        <p:txBody>
+          <a:bodyPr wrap="square" anchor="t" tIns="0" bIns="0">
+            <a:spAutoFit/>
+          </a:bodyPr>
+          <a:lstStyle/>
+          <a:p>
+            <a:pPr algn="l"/>
+            <a:r>
+              <a:rPr sz="2400" b="1" i="0">
+                <a:solidFill>
+                  <a:srgbClr val="111110"/>
+                </a:solidFill>
+                <a:latin typeface="Oswald"/>
+              </a:rPr>
+              <a:t>{{TITLE}}</a:t>
+            </a:r>
+          </a:p>
+        </p:txBody>
+      </p:sp>
+      <p:sp>
+        <p:nvSpPr>
+          <p:cNvPr id="6" name="TextBox 5"/>
+          <p:cNvSpPr txBox="1"/>
+          <p:nvPr/>
+        </p:nvSpPr>
+        <p:spPr>
+          <a:xfrm>
+            <a:off x="402336" y="731520"/>
+            <a:ext cx="11521440" cy="310896"/>
+          </a:xfrm>
+          <a:prstGeom prst="rect">
+            <a:avLst/>
+          </a:prstGeom>
+          <a:noFill/>
+        </p:spPr>
+        <p:txBody>
+          <a:bodyPr wrap="square" anchor="t" tIns="0" bIns="0">
+            <a:spAutoFit/>
+          </a:bodyPr>
+          <a:lstStyle/>
+          <a:p>
+            <a:pPr algn="l"/>
+            <a:r>
+              <a:rPr sz="1500" b="1" i="0">
+                <a:solidFill>
+                  <a:srgbClr val="2A9D8F"/>
+                </a:solidFill>
+                <a:latin typeface="Roboto Condensed"/>
+              </a:rPr>
+              <a:t>{{SUBHEAD}}</a:t>
+            </a:r>
+          </a:p>
+        </p:txBody>
+      </p:sp>
+      <p:sp>
+        <p:nvSpPr>
+          <p:cNvPr id="7" name="Rectangle 6"/>
+          <p:cNvSpPr/>
+          <p:nvPr/>
+        </p:nvSpPr>
+        <p:spPr>
+          <a:xfrm>
+            <a:off x="0" y="6766560"/>
+            <a:ext cx="12188952" cy="91440"/>
+          </a:xfrm>
+          <a:prstGeom prst="rect">
+            <a:avLst/>
+          </a:prstGeom>
+          <a:solidFill>
+            <a:srgbClr val="2A9D8F"/>
+          </a:solidFill>
+          <a:ln>
+            <a:noFill/>
+          </a:ln>
+          <a:effectLst/>
+        </p:spPr>
+        <p:style>
+          <a:lnRef idx="1">
+            <a:schemeClr val="accent1"/>
+          </a:lnRef>
+          <a:fillRef idx="3">
+            <a:schemeClr val="accent1"/>
+          </a:fillRef>
+          <a:effectRef idx="2">
+            <a:schemeClr val="accent1"/>
+          </a:effectRef>
+          <a:fontRef idx="minor">
+            <a:schemeClr val="lt1"/>
+          </a:fontRef>
+        </p:style>
+        <p:txBody>
+          <a:bodyPr rtlCol="0" anchor="ctr"/>
+          <a:lstStyle/>
+          <a:p>
+            <a:pPr algn="ctr"/>
+          </a:p>
+        </p:txBody>
+      </p:sp>
+    </p:spTree>
+  </p:cSld>
+  <p:clrMapOvr>
+    <a:masterClrMapping/>
+  </p:clrMapOvr>
+</p:sld>
+</file>
+
+<file path=ppt/slides/slide16.xml><?xml version="1.0" encoding="utf-8"?>
+<p:sld xmlns:a="http://schemas.openxmlformats.org/drawingml/2006/main" xmlns:p="http://schemas.openxmlformats.org/presentationml/2006/main" xmlns:r="http://schemas.openxmlformats.org/officeDocument/2006/relationships">
+  <p:cSld>
+    <p:spTree>
+      <p:nvGrpSpPr>
+        <p:cNvPr id="1" name=""/>
+        <p:cNvGrpSpPr/>
+        <p:nvPr/>
+      </p:nvGrpSpPr>
+      <p:grpSpPr/>
+      <p:sp>
+        <p:nvSpPr>
+          <p:cNvPr id="2" name="Rectangle 1"/>
+          <p:cNvSpPr/>
+          <p:nvPr/>
+        </p:nvSpPr>
+        <p:spPr>
+          <a:xfrm>
+            <a:off x="0" y="0"/>
+            <a:ext cx="8129016" cy="75895"/>
+          </a:xfrm>
+          <a:prstGeom prst="rect">
+            <a:avLst/>
+          </a:prstGeom>
+          <a:solidFill>
+            <a:srgbClr val="D62839"/>
+          </a:solidFill>
+          <a:ln>
+            <a:noFill/>
+          </a:ln>
+          <a:effectLst/>
+        </p:spPr>
+        <p:style>
+          <a:lnRef idx="1">
+            <a:schemeClr val="accent1"/>
+          </a:lnRef>
+          <a:fillRef idx="3">
+            <a:schemeClr val="accent1"/>
+          </a:fillRef>
+          <a:effectRef idx="2">
+            <a:schemeClr val="accent1"/>
+          </a:effectRef>
+          <a:fontRef idx="minor">
+            <a:schemeClr val="lt1"/>
+          </a:fontRef>
+        </p:style>
+        <p:txBody>
+          <a:bodyPr rtlCol="0" anchor="ctr"/>
+          <a:lstStyle/>
+          <a:p>
+            <a:pPr algn="ctr"/>
+          </a:p>
+        </p:txBody>
+      </p:sp>
+      <p:sp>
+        <p:nvSpPr>
+          <p:cNvPr id="3" name="Rectangle 2"/>
+          <p:cNvSpPr/>
+          <p:nvPr/>
+        </p:nvSpPr>
+        <p:spPr>
+          <a:xfrm>
+            <a:off x="8129016" y="0"/>
+            <a:ext cx="4059935" cy="75895"/>
+          </a:xfrm>
+          <a:prstGeom prst="rect">
+            <a:avLst/>
+          </a:prstGeom>
+          <a:solidFill>
+            <a:srgbClr val="2A9D8F"/>
+          </a:solidFill>
+          <a:ln>
+            <a:noFill/>
+          </a:ln>
+          <a:effectLst/>
+        </p:spPr>
+        <p:style>
+          <a:lnRef idx="1">
+            <a:schemeClr val="accent1"/>
+          </a:lnRef>
+          <a:fillRef idx="3">
+            <a:schemeClr val="accent1"/>
+          </a:fillRef>
+          <a:effectRef idx="2">
+            <a:schemeClr val="accent1"/>
+          </a:effectRef>
+          <a:fontRef idx="minor">
+            <a:schemeClr val="lt1"/>
+          </a:fontRef>
+        </p:style>
+        <p:txBody>
+          <a:bodyPr rtlCol="0" anchor="ctr"/>
+          <a:lstStyle/>
+          <a:p>
+            <a:pPr algn="ctr"/>
+          </a:p>
+        </p:txBody>
+      </p:sp>
+      <p:sp>
+        <p:nvSpPr>
+          <p:cNvPr id="4" name="Rectangle 3"/>
+          <p:cNvSpPr/>
+          <p:nvPr/>
+        </p:nvSpPr>
+        <p:spPr>
+          <a:xfrm>
+            <a:off x="228600" y="274320"/>
+            <a:ext cx="59436" cy="475488"/>
+          </a:xfrm>
+          <a:prstGeom prst="rect">
+            <a:avLst/>
+          </a:prstGeom>
+          <a:solidFill>
+            <a:srgbClr val="D62839"/>
+          </a:solidFill>
+          <a:ln>
+            <a:noFill/>
+          </a:ln>
+          <a:effectLst/>
+        </p:spPr>
+        <p:style>
+          <a:lnRef idx="1">
+            <a:schemeClr val="accent1"/>
+          </a:lnRef>
+          <a:fillRef idx="3">
+            <a:schemeClr val="accent1"/>
+          </a:fillRef>
+          <a:effectRef idx="2">
+            <a:schemeClr val="accent1"/>
+          </a:effectRef>
+          <a:fontRef idx="minor">
+            <a:schemeClr val="lt1"/>
+          </a:fontRef>
+        </p:style>
+        <p:txBody>
+          <a:bodyPr rtlCol="0" anchor="ctr"/>
+          <a:lstStyle/>
+          <a:p>
+            <a:pPr algn="ctr"/>
+          </a:p>
+        </p:txBody>
+      </p:sp>
+      <p:sp>
+        <p:nvSpPr>
+          <p:cNvPr id="5" name="TextBox 4"/>
+          <p:cNvSpPr txBox="1"/>
+          <p:nvPr/>
+        </p:nvSpPr>
+        <p:spPr>
+          <a:xfrm>
+            <a:off x="402336" y="237744"/>
+            <a:ext cx="11338560" cy="475488"/>
+          </a:xfrm>
+          <a:prstGeom prst="rect">
+            <a:avLst/>
+          </a:prstGeom>
+          <a:noFill/>
+        </p:spPr>
+        <p:txBody>
+          <a:bodyPr wrap="square" anchor="t" tIns="0" bIns="0">
+            <a:spAutoFit/>
+          </a:bodyPr>
+          <a:lstStyle/>
+          <a:p>
+            <a:pPr algn="l"/>
+            <a:r>
+              <a:rPr sz="2400" b="1" i="0">
+                <a:solidFill>
+                  <a:srgbClr val="111110"/>
+                </a:solidFill>
+                <a:latin typeface="Oswald"/>
+              </a:rPr>
+              <a:t>{{TITLE}}</a:t>
+            </a:r>
+          </a:p>
+        </p:txBody>
+      </p:sp>
+      <p:sp>
+        <p:nvSpPr>
+          <p:cNvPr id="6" name="TextBox 5"/>
+          <p:cNvSpPr txBox="1"/>
+          <p:nvPr/>
+        </p:nvSpPr>
+        <p:spPr>
+          <a:xfrm>
+            <a:off x="402336" y="731520"/>
+            <a:ext cx="11521440" cy="310896"/>
+          </a:xfrm>
+          <a:prstGeom prst="rect">
+            <a:avLst/>
+          </a:prstGeom>
+          <a:noFill/>
+        </p:spPr>
+        <p:txBody>
+          <a:bodyPr wrap="square" anchor="t" tIns="0" bIns="0">
+            <a:spAutoFit/>
+          </a:bodyPr>
+          <a:lstStyle/>
+          <a:p>
+            <a:pPr algn="l"/>
+            <a:r>
+              <a:rPr sz="1500" b="1" i="0">
+                <a:solidFill>
+                  <a:srgbClr val="2A9D8F"/>
+                </a:solidFill>
+                <a:latin typeface="Roboto Condensed"/>
+              </a:rPr>
+              <a:t>{{SUBHEAD}}</a:t>
+            </a:r>
+          </a:p>
+        </p:txBody>
+      </p:sp>
+      <p:sp>
+        <p:nvSpPr>
+          <p:cNvPr id="7" name="Rectangle 6"/>
+          <p:cNvSpPr/>
+          <p:nvPr/>
+        </p:nvSpPr>
+        <p:spPr>
+          <a:xfrm>
+            <a:off x="0" y="6766560"/>
+            <a:ext cx="12188952" cy="91440"/>
+          </a:xfrm>
+          <a:prstGeom prst="rect">
+            <a:avLst/>
+          </a:prstGeom>
+          <a:solidFill>
+            <a:srgbClr val="2A9D8F"/>
+          </a:solidFill>
+          <a:ln>
+            <a:noFill/>
+          </a:ln>
+          <a:effectLst/>
+        </p:spPr>
+        <p:style>
+          <a:lnRef idx="1">
+            <a:schemeClr val="accent1"/>
+          </a:lnRef>
+          <a:fillRef idx="3">
+            <a:schemeClr val="accent1"/>
+          </a:fillRef>
+          <a:effectRef idx="2">
+            <a:schemeClr val="accent1"/>
+          </a:effectRef>
+          <a:fontRef idx="minor">
+            <a:schemeClr val="lt1"/>
+          </a:fontRef>
+        </p:style>
+        <p:txBody>
+          <a:bodyPr rtlCol="0" anchor="ctr"/>
+          <a:lstStyle/>
+          <a:p>
+            <a:pPr algn="ctr"/>
+          </a:p>
+        </p:txBody>
+      </p:sp>
+    </p:spTree>
+  </p:cSld>
+  <p:clrMapOvr>
+    <a:masterClrMapping/>
+  </p:clrMapOvr>
+</p:sld>
+</file>
+
+<file path=ppt/slides/slide17.xml><?xml version="1.0" encoding="utf-8"?>
+<p:sld xmlns:a="http://schemas.openxmlformats.org/drawingml/2006/main" xmlns:p="http://schemas.openxmlformats.org/presentationml/2006/main" xmlns:r="http://schemas.openxmlformats.org/officeDocument/2006/relationships">
+  <p:cSld>
+    <p:spTree>
+      <p:nvGrpSpPr>
+        <p:cNvPr id="1" name=""/>
+        <p:cNvGrpSpPr/>
+        <p:nvPr/>
+      </p:nvGrpSpPr>
+      <p:grpSpPr/>
+      <p:sp>
+        <p:nvSpPr>
+          <p:cNvPr id="2" name="Rectangle 1"/>
+          <p:cNvSpPr/>
+          <p:nvPr/>
+        </p:nvSpPr>
+        <p:spPr>
+          <a:xfrm>
+            <a:off x="0" y="0"/>
+            <a:ext cx="8129016" cy="75895"/>
+          </a:xfrm>
+          <a:prstGeom prst="rect">
+            <a:avLst/>
+          </a:prstGeom>
+          <a:solidFill>
+            <a:srgbClr val="D62839"/>
+          </a:solidFill>
+          <a:ln>
+            <a:noFill/>
+          </a:ln>
+          <a:effectLst/>
+        </p:spPr>
+        <p:style>
+          <a:lnRef idx="1">
+            <a:schemeClr val="accent1"/>
+          </a:lnRef>
+          <a:fillRef idx="3">
+            <a:schemeClr val="accent1"/>
+          </a:fillRef>
+          <a:effectRef idx="2">
+            <a:schemeClr val="accent1"/>
+          </a:effectRef>
+          <a:fontRef idx="minor">
+            <a:schemeClr val="lt1"/>
+          </a:fontRef>
+        </p:style>
+        <p:txBody>
+          <a:bodyPr rtlCol="0" anchor="ctr"/>
+          <a:lstStyle/>
+          <a:p>
+            <a:pPr algn="ctr"/>
+          </a:p>
+        </p:txBody>
+      </p:sp>
+      <p:sp>
+        <p:nvSpPr>
+          <p:cNvPr id="3" name="Rectangle 2"/>
+          <p:cNvSpPr/>
+          <p:nvPr/>
+        </p:nvSpPr>
+        <p:spPr>
+          <a:xfrm>
+            <a:off x="8129016" y="0"/>
+            <a:ext cx="4059935" cy="75895"/>
+          </a:xfrm>
+          <a:prstGeom prst="rect">
+            <a:avLst/>
+          </a:prstGeom>
+          <a:solidFill>
+            <a:srgbClr val="2A9D8F"/>
+          </a:solidFill>
+          <a:ln>
+            <a:noFill/>
+          </a:ln>
+          <a:effectLst/>
+        </p:spPr>
+        <p:style>
+          <a:lnRef idx="1">
+            <a:schemeClr val="accent1"/>
+          </a:lnRef>
+          <a:fillRef idx="3">
+            <a:schemeClr val="accent1"/>
+          </a:fillRef>
+          <a:effectRef idx="2">
+            <a:schemeClr val="accent1"/>
+          </a:effectRef>
+          <a:fontRef idx="minor">
+            <a:schemeClr val="lt1"/>
+          </a:fontRef>
+        </p:style>
+        <p:txBody>
+          <a:bodyPr rtlCol="0" anchor="ctr"/>
+          <a:lstStyle/>
+          <a:p>
+            <a:pPr algn="ctr"/>
+          </a:p>
+        </p:txBody>
+      </p:sp>
+      <p:sp>
+        <p:nvSpPr>
+          <p:cNvPr id="4" name="Rectangle 3"/>
+          <p:cNvSpPr/>
+          <p:nvPr/>
+        </p:nvSpPr>
+        <p:spPr>
+          <a:xfrm>
+            <a:off x="228600" y="274320"/>
+            <a:ext cx="59436" cy="475488"/>
+          </a:xfrm>
+          <a:prstGeom prst="rect">
+            <a:avLst/>
+          </a:prstGeom>
+          <a:solidFill>
+            <a:srgbClr val="D62839"/>
+          </a:solidFill>
+          <a:ln>
+            <a:noFill/>
+          </a:ln>
+          <a:effectLst/>
+        </p:spPr>
+        <p:style>
+          <a:lnRef idx="1">
+            <a:schemeClr val="accent1"/>
+          </a:lnRef>
+          <a:fillRef idx="3">
+            <a:schemeClr val="accent1"/>
+          </a:fillRef>
+          <a:effectRef idx="2">
+            <a:schemeClr val="accent1"/>
+          </a:effectRef>
+          <a:fontRef idx="minor">
+            <a:schemeClr val="lt1"/>
+          </a:fontRef>
+        </p:style>
+        <p:txBody>
+          <a:bodyPr rtlCol="0" anchor="ctr"/>
+          <a:lstStyle/>
+          <a:p>
+            <a:pPr algn="ctr"/>
+          </a:p>
+        </p:txBody>
+      </p:sp>
+      <p:sp>
+        <p:nvSpPr>
+          <p:cNvPr id="5" name="TextBox 4"/>
+          <p:cNvSpPr txBox="1"/>
+          <p:nvPr/>
+        </p:nvSpPr>
+        <p:spPr>
+          <a:xfrm>
+            <a:off x="402336" y="237744"/>
+            <a:ext cx="11338560" cy="475488"/>
+          </a:xfrm>
+          <a:prstGeom prst="rect">
+            <a:avLst/>
+          </a:prstGeom>
+          <a:noFill/>
+        </p:spPr>
+        <p:txBody>
+          <a:bodyPr wrap="square" anchor="t" tIns="0" bIns="0">
+            <a:spAutoFit/>
+          </a:bodyPr>
+          <a:lstStyle/>
+          <a:p>
+            <a:pPr algn="l"/>
+            <a:r>
+              <a:rPr sz="2400" b="1" i="0">
+                <a:solidFill>
+                  <a:srgbClr val="111110"/>
+                </a:solidFill>
+                <a:latin typeface="Oswald"/>
+              </a:rPr>
+              <a:t>{{TITLE}}</a:t>
+            </a:r>
+          </a:p>
+        </p:txBody>
+      </p:sp>
+      <p:sp>
+        <p:nvSpPr>
+          <p:cNvPr id="6" name="TextBox 5"/>
+          <p:cNvSpPr txBox="1"/>
+          <p:nvPr/>
+        </p:nvSpPr>
+        <p:spPr>
+          <a:xfrm>
+            <a:off x="402336" y="731520"/>
+            <a:ext cx="11521440" cy="310896"/>
+          </a:xfrm>
+          <a:prstGeom prst="rect">
+            <a:avLst/>
+          </a:prstGeom>
+          <a:noFill/>
+        </p:spPr>
+        <p:txBody>
+          <a:bodyPr wrap="square" anchor="t" tIns="0" bIns="0">
+            <a:spAutoFit/>
+          </a:bodyPr>
+          <a:lstStyle/>
+          <a:p>
+            <a:pPr algn="l"/>
+            <a:r>
+              <a:rPr sz="1500" b="1" i="0">
+                <a:solidFill>
+                  <a:srgbClr val="2A9D8F"/>
+                </a:solidFill>
+                <a:latin typeface="Roboto Condensed"/>
+              </a:rPr>
+              <a:t>{{SUBHEAD}}</a:t>
+            </a:r>
+          </a:p>
+        </p:txBody>
+      </p:sp>
+      <p:sp>
+        <p:nvSpPr>
+          <p:cNvPr id="7" name="Rectangle 6"/>
+          <p:cNvSpPr/>
+          <p:nvPr/>
+        </p:nvSpPr>
+        <p:spPr>
+          <a:xfrm>
+            <a:off x="0" y="6766560"/>
+            <a:ext cx="12188952" cy="91440"/>
+          </a:xfrm>
+          <a:prstGeom prst="rect">
+            <a:avLst/>
+          </a:prstGeom>
+          <a:solidFill>
+            <a:srgbClr val="2A9D8F"/>
+          </a:solidFill>
+          <a:ln>
+            <a:noFill/>
+          </a:ln>
+          <a:effectLst/>
+        </p:spPr>
+        <p:style>
+          <a:lnRef idx="1">
+            <a:schemeClr val="accent1"/>
+          </a:lnRef>
+          <a:fillRef idx="3">
+            <a:schemeClr val="accent1"/>
+          </a:fillRef>
+          <a:effectRef idx="2">
+            <a:schemeClr val="accent1"/>
+          </a:effectRef>
+          <a:fontRef idx="minor">
+            <a:schemeClr val="lt1"/>
+          </a:fontRef>
+        </p:style>
+        <p:txBody>
+          <a:bodyPr rtlCol="0" anchor="ctr"/>
+          <a:lstStyle/>
+          <a:p>
+            <a:pPr algn="ctr"/>
+          </a:p>
+        </p:txBody>
+      </p:sp>
+    </p:spTree>
+  </p:cSld>
+  <p:clrMapOvr>
+    <a:masterClrMapping/>
+  </p:clrMapOvr>
+</p:sld>
+</file>
+
+<file path=ppt/slides/slide18.xml><?xml version="1.0" encoding="utf-8"?>
+<p:sld xmlns:a="http://schemas.openxmlformats.org/drawingml/2006/main" xmlns:p="http://schemas.openxmlformats.org/presentationml/2006/main" xmlns:r="http://schemas.openxmlformats.org/officeDocument/2006/relationships">
+  <p:cSld>
+    <p:spTree>
+      <p:nvGrpSpPr>
+        <p:cNvPr id="1" name=""/>
+        <p:cNvGrpSpPr/>
+        <p:nvPr/>
+      </p:nvGrpSpPr>
+      <p:grpSpPr/>
+      <p:sp>
+        <p:nvSpPr>
+          <p:cNvPr id="2" name="Rectangle 1"/>
+          <p:cNvSpPr/>
+          <p:nvPr/>
+        </p:nvSpPr>
+        <p:spPr>
+          <a:xfrm>
+            <a:off x="0" y="0"/>
+            <a:ext cx="8129016" cy="75895"/>
+          </a:xfrm>
+          <a:prstGeom prst="rect">
+            <a:avLst/>
+          </a:prstGeom>
+          <a:solidFill>
+            <a:srgbClr val="D62839"/>
+          </a:solidFill>
+          <a:ln>
+            <a:noFill/>
+          </a:ln>
+          <a:effectLst/>
+        </p:spPr>
+        <p:style>
+          <a:lnRef idx="1">
+            <a:schemeClr val="accent1"/>
+          </a:lnRef>
+          <a:fillRef idx="3">
+            <a:schemeClr val="accent1"/>
+          </a:fillRef>
+          <a:effectRef idx="2">
+            <a:schemeClr val="accent1"/>
+          </a:effectRef>
+          <a:fontRef idx="minor">
+            <a:schemeClr val="lt1"/>
+          </a:fontRef>
+        </p:style>
+        <p:txBody>
+          <a:bodyPr rtlCol="0" anchor="ctr"/>
+          <a:lstStyle/>
+          <a:p>
+            <a:pPr algn="ctr"/>
+          </a:p>
+        </p:txBody>
+      </p:sp>
+      <p:sp>
+        <p:nvSpPr>
+          <p:cNvPr id="3" name="Rectangle 2"/>
+          <p:cNvSpPr/>
+          <p:nvPr/>
+        </p:nvSpPr>
+        <p:spPr>
+          <a:xfrm>
+            <a:off x="8129016" y="0"/>
+            <a:ext cx="4059935" cy="75895"/>
+          </a:xfrm>
+          <a:prstGeom prst="rect">
+            <a:avLst/>
+          </a:prstGeom>
+          <a:solidFill>
+            <a:srgbClr val="2A9D8F"/>
+          </a:solidFill>
+          <a:ln>
+            <a:noFill/>
+          </a:ln>
+          <a:effectLst/>
+        </p:spPr>
+        <p:style>
+          <a:lnRef idx="1">
+            <a:schemeClr val="accent1"/>
+          </a:lnRef>
+          <a:fillRef idx="3">
+            <a:schemeClr val="accent1"/>
+          </a:fillRef>
+          <a:effectRef idx="2">
+            <a:schemeClr val="accent1"/>
+          </a:effectRef>
+          <a:fontRef idx="minor">
+            <a:schemeClr val="lt1"/>
+          </a:fontRef>
+        </p:style>
+        <p:txBody>
+          <a:bodyPr rtlCol="0" anchor="ctr"/>
+          <a:lstStyle/>
+          <a:p>
+            <a:pPr algn="ctr"/>
+          </a:p>
+        </p:txBody>
+      </p:sp>
+      <p:sp>
+        <p:nvSpPr>
+          <p:cNvPr id="4" name="Rectangle 3"/>
+          <p:cNvSpPr/>
+          <p:nvPr/>
+        </p:nvSpPr>
+        <p:spPr>
+          <a:xfrm>
+            <a:off x="228600" y="274320"/>
+            <a:ext cx="59436" cy="475488"/>
+          </a:xfrm>
+          <a:prstGeom prst="rect">
+            <a:avLst/>
+          </a:prstGeom>
+          <a:solidFill>
+            <a:srgbClr val="D62839"/>
+          </a:solidFill>
+          <a:ln>
+            <a:noFill/>
+          </a:ln>
+          <a:effectLst/>
+        </p:spPr>
+        <p:style>
+          <a:lnRef idx="1">
+            <a:schemeClr val="accent1"/>
+          </a:lnRef>
+          <a:fillRef idx="3">
+            <a:schemeClr val="accent1"/>
+          </a:fillRef>
+          <a:effectRef idx="2">
+            <a:schemeClr val="accent1"/>
+          </a:effectRef>
+          <a:fontRef idx="minor">
+            <a:schemeClr val="lt1"/>
+          </a:fontRef>
+        </p:style>
+        <p:txBody>
+          <a:bodyPr rtlCol="0" anchor="ctr"/>
+          <a:lstStyle/>
+          <a:p>
+            <a:pPr algn="ctr"/>
+          </a:p>
+        </p:txBody>
+      </p:sp>
+      <p:sp>
+        <p:nvSpPr>
+          <p:cNvPr id="5" name="TextBox 4"/>
+          <p:cNvSpPr txBox="1"/>
+          <p:nvPr/>
+        </p:nvSpPr>
+        <p:spPr>
+          <a:xfrm>
+            <a:off x="402336" y="237744"/>
+            <a:ext cx="11338560" cy="475488"/>
+          </a:xfrm>
+          <a:prstGeom prst="rect">
+            <a:avLst/>
+          </a:prstGeom>
+          <a:noFill/>
+        </p:spPr>
+        <p:txBody>
+          <a:bodyPr wrap="square" anchor="t" tIns="0" bIns="0">
+            <a:spAutoFit/>
+          </a:bodyPr>
+          <a:lstStyle/>
+          <a:p>
+            <a:pPr algn="l"/>
+            <a:r>
+              <a:rPr sz="2400" b="1" i="0">
+                <a:solidFill>
+                  <a:srgbClr val="111110"/>
+                </a:solidFill>
+                <a:latin typeface="Oswald"/>
+              </a:rPr>
+              <a:t>{{TITLE}}</a:t>
+            </a:r>
+          </a:p>
+        </p:txBody>
+      </p:sp>
+      <p:sp>
+        <p:nvSpPr>
+          <p:cNvPr id="6" name="TextBox 5"/>
+          <p:cNvSpPr txBox="1"/>
+          <p:nvPr/>
+        </p:nvSpPr>
+        <p:spPr>
+          <a:xfrm>
+            <a:off x="402336" y="731520"/>
+            <a:ext cx="11521440" cy="310896"/>
+          </a:xfrm>
+          <a:prstGeom prst="rect">
+            <a:avLst/>
+          </a:prstGeom>
+          <a:noFill/>
+        </p:spPr>
+        <p:txBody>
+          <a:bodyPr wrap="square" anchor="t" tIns="0" bIns="0">
+            <a:spAutoFit/>
+          </a:bodyPr>
+          <a:lstStyle/>
+          <a:p>
+            <a:pPr algn="l"/>
+            <a:r>
+              <a:rPr sz="1500" b="1" i="0">
+                <a:solidFill>
+                  <a:srgbClr val="2A9D8F"/>
+                </a:solidFill>
+                <a:latin typeface="Roboto Condensed"/>
+              </a:rPr>
+              <a:t>{{SUBHEAD}}</a:t>
+            </a:r>
+          </a:p>
+        </p:txBody>
+      </p:sp>
+      <p:sp>
+        <p:nvSpPr>
+          <p:cNvPr id="7" name="Rectangle 6"/>
+          <p:cNvSpPr/>
+          <p:nvPr/>
+        </p:nvSpPr>
+        <p:spPr>
+          <a:xfrm>
+            <a:off x="0" y="6766560"/>
+            <a:ext cx="12188952" cy="91440"/>
+          </a:xfrm>
+          <a:prstGeom prst="rect">
+            <a:avLst/>
+          </a:prstGeom>
+          <a:solidFill>
+            <a:srgbClr val="2A9D8F"/>
+          </a:solidFill>
+          <a:ln>
+            <a:noFill/>
+          </a:ln>
+          <a:effectLst/>
+        </p:spPr>
+        <p:style>
+          <a:lnRef idx="1">
+            <a:schemeClr val="accent1"/>
+          </a:lnRef>
+          <a:fillRef idx="3">
+            <a:schemeClr val="accent1"/>
+          </a:fillRef>
+          <a:effectRef idx="2">
+            <a:schemeClr val="accent1"/>
+          </a:effectRef>
+          <a:fontRef idx="minor">
+            <a:schemeClr val="lt1"/>
+          </a:fontRef>
+        </p:style>
+        <p:txBody>
+          <a:bodyPr rtlCol="0" anchor="ctr"/>
+          <a:lstStyle/>
+          <a:p>
+            <a:pPr algn="ctr"/>
+          </a:p>
+        </p:txBody>
+      </p:sp>
+    </p:spTree>
+  </p:cSld>
+  <p:clrMapOvr>
+    <a:masterClrMapping/>
+  </p:clrMapOvr>
+</p:sld>
+</file>
+
+<file path=ppt/slides/slide19.xml><?xml version="1.0" encoding="utf-8"?>
+<p:sld xmlns:a="http://schemas.openxmlformats.org/drawingml/2006/main" xmlns:p="http://schemas.openxmlformats.org/presentationml/2006/main" xmlns:r="http://schemas.openxmlformats.org/officeDocument/2006/relationships">
+  <p:cSld>
+    <p:spTree>
+      <p:nvGrpSpPr>
+        <p:cNvPr id="1" name=""/>
+        <p:cNvGrpSpPr/>
+        <p:nvPr/>
+      </p:nvGrpSpPr>
+      <p:grpSpPr/>
+      <p:sp>
+        <p:nvSpPr>
+          <p:cNvPr id="2" name="Rectangle 1"/>
+          <p:cNvSpPr/>
+          <p:nvPr/>
+        </p:nvSpPr>
+        <p:spPr>
+          <a:xfrm>
+            <a:off x="0" y="0"/>
+            <a:ext cx="8129016" cy="75895"/>
+          </a:xfrm>
+          <a:prstGeom prst="rect">
+            <a:avLst/>
+          </a:prstGeom>
+          <a:solidFill>
+            <a:srgbClr val="D62839"/>
+          </a:solidFill>
+          <a:ln>
+            <a:noFill/>
+          </a:ln>
+          <a:effectLst/>
+        </p:spPr>
+        <p:style>
+          <a:lnRef idx="1">
+            <a:schemeClr val="accent1"/>
+          </a:lnRef>
+          <a:fillRef idx="3">
+            <a:schemeClr val="accent1"/>
+          </a:fillRef>
+          <a:effectRef idx="2">
+            <a:schemeClr val="accent1"/>
+          </a:effectRef>
+          <a:fontRef idx="minor">
+            <a:schemeClr val="lt1"/>
+          </a:fontRef>
+        </p:style>
+        <p:txBody>
+          <a:bodyPr rtlCol="0" anchor="ctr"/>
+          <a:lstStyle/>
+          <a:p>
+            <a:pPr algn="ctr"/>
+          </a:p>
+        </p:txBody>
+      </p:sp>
+      <p:sp>
+        <p:nvSpPr>
+          <p:cNvPr id="3" name="Rectangle 2"/>
+          <p:cNvSpPr/>
+          <p:nvPr/>
+        </p:nvSpPr>
+        <p:spPr>
+          <a:xfrm>
+            <a:off x="8129016" y="0"/>
+            <a:ext cx="4059935" cy="75895"/>
+          </a:xfrm>
+          <a:prstGeom prst="rect">
+            <a:avLst/>
+          </a:prstGeom>
+          <a:solidFill>
+            <a:srgbClr val="2A9D8F"/>
+          </a:solidFill>
+          <a:ln>
+            <a:noFill/>
+          </a:ln>
+          <a:effectLst/>
+        </p:spPr>
+        <p:style>
+          <a:lnRef idx="1">
+            <a:schemeClr val="accent1"/>
+          </a:lnRef>
+          <a:fillRef idx="3">
+            <a:schemeClr val="accent1"/>
+          </a:fillRef>
+          <a:effectRef idx="2">
+            <a:schemeClr val="accent1"/>
+          </a:effectRef>
+          <a:fontRef idx="minor">
+            <a:schemeClr val="lt1"/>
+          </a:fontRef>
+        </p:style>
+        <p:txBody>
+          <a:bodyPr rtlCol="0" anchor="ctr"/>
+          <a:lstStyle/>
+          <a:p>
+            <a:pPr algn="ctr"/>
+          </a:p>
+        </p:txBody>
+      </p:sp>
+      <p:sp>
+        <p:nvSpPr>
+          <p:cNvPr id="4" name="Rectangle 3"/>
+          <p:cNvSpPr/>
+          <p:nvPr/>
+        </p:nvSpPr>
+        <p:spPr>
+          <a:xfrm>
+            <a:off x="228600" y="274320"/>
+            <a:ext cx="59436" cy="475488"/>
+          </a:xfrm>
+          <a:prstGeom prst="rect">
+            <a:avLst/>
+          </a:prstGeom>
+          <a:solidFill>
+            <a:srgbClr val="D62839"/>
+          </a:solidFill>
+          <a:ln>
+            <a:noFill/>
+          </a:ln>
+          <a:effectLst/>
+        </p:spPr>
+        <p:style>
+          <a:lnRef idx="1">
+            <a:schemeClr val="accent1"/>
+          </a:lnRef>
+          <a:fillRef idx="3">
+            <a:schemeClr val="accent1"/>
+          </a:fillRef>
+          <a:effectRef idx="2">
+            <a:schemeClr val="accent1"/>
+          </a:effectRef>
+          <a:fontRef idx="minor">
+            <a:schemeClr val="lt1"/>
+          </a:fontRef>
+        </p:style>
+        <p:txBody>
+          <a:bodyPr rtlCol="0" anchor="ctr"/>
+          <a:lstStyle/>
+          <a:p>
+            <a:pPr algn="ctr"/>
+          </a:p>
+        </p:txBody>
+      </p:sp>
+      <p:sp>
+        <p:nvSpPr>
+          <p:cNvPr id="5" name="TextBox 4"/>
+          <p:cNvSpPr txBox="1"/>
+          <p:nvPr/>
+        </p:nvSpPr>
+        <p:spPr>
+          <a:xfrm>
+            <a:off x="402336" y="237744"/>
+            <a:ext cx="11338560" cy="475488"/>
+          </a:xfrm>
+          <a:prstGeom prst="rect">
+            <a:avLst/>
+          </a:prstGeom>
+          <a:noFill/>
+        </p:spPr>
+        <p:txBody>
+          <a:bodyPr wrap="square" anchor="t" tIns="0" bIns="0">
+            <a:spAutoFit/>
+          </a:bodyPr>
+          <a:lstStyle/>
+          <a:p>
+            <a:pPr algn="l"/>
+            <a:r>
+              <a:rPr sz="2400" b="1" i="0">
+                <a:solidFill>
+                  <a:srgbClr val="111110"/>
+                </a:solidFill>
+                <a:latin typeface="Oswald"/>
+              </a:rPr>
+              <a:t>{{TITLE}}</a:t>
+            </a:r>
+          </a:p>
+        </p:txBody>
+      </p:sp>
+      <p:sp>
+        <p:nvSpPr>
+          <p:cNvPr id="6" name="TextBox 5"/>
+          <p:cNvSpPr txBox="1"/>
+          <p:nvPr/>
+        </p:nvSpPr>
+        <p:spPr>
+          <a:xfrm>
+            <a:off x="402336" y="731520"/>
+            <a:ext cx="11521440" cy="310896"/>
+          </a:xfrm>
+          <a:prstGeom prst="rect">
+            <a:avLst/>
+          </a:prstGeom>
+          <a:noFill/>
+        </p:spPr>
+        <p:txBody>
+          <a:bodyPr wrap="square" anchor="t" tIns="0" bIns="0">
+            <a:spAutoFit/>
+          </a:bodyPr>
+          <a:lstStyle/>
+          <a:p>
+            <a:pPr algn="l"/>
+            <a:r>
+              <a:rPr sz="1500" b="1" i="0">
+                <a:solidFill>
+                  <a:srgbClr val="2A9D8F"/>
+                </a:solidFill>
+                <a:latin typeface="Roboto Condensed"/>
+              </a:rPr>
+              <a:t>{{SUBHEAD}}</a:t>
+            </a:r>
+          </a:p>
+        </p:txBody>
+      </p:sp>
+      <p:sp>
+        <p:nvSpPr>
+          <p:cNvPr id="7" name="Rectangle 6"/>
+          <p:cNvSpPr/>
+          <p:nvPr/>
+        </p:nvSpPr>
+        <p:spPr>
+          <a:xfrm>
+            <a:off x="0" y="6766560"/>
+            <a:ext cx="12188952" cy="91440"/>
+          </a:xfrm>
+          <a:prstGeom prst="rect">
+            <a:avLst/>
+          </a:prstGeom>
+          <a:solidFill>
+            <a:srgbClr val="2A9D8F"/>
+          </a:solidFill>
+          <a:ln>
+            <a:noFill/>
+          </a:ln>
+          <a:effectLst/>
+        </p:spPr>
+        <p:style>
+          <a:lnRef idx="1">
+            <a:schemeClr val="accent1"/>
+          </a:lnRef>
+          <a:fillRef idx="3">
+            <a:schemeClr val="accent1"/>
+          </a:fillRef>
+          <a:effectRef idx="2">
+            <a:schemeClr val="accent1"/>
+          </a:effectRef>
+          <a:fontRef idx="minor">
+            <a:schemeClr val="lt1"/>
+          </a:fontRef>
+        </p:style>
+        <p:txBody>
+          <a:bodyPr rtlCol="0" anchor="ctr"/>
+          <a:lstStyle/>
+          <a:p>
+            <a:pPr algn="ctr"/>
+          </a:p>
+        </p:txBody>
+      </p:sp>
+    </p:spTree>
+  </p:cSld>
+  <p:clrMapOvr>
+    <a:masterClrMapping/>
+  </p:clrMapOvr>
+</p:sld>
+</file>
+
 <file path=ppt/slides/slide2.xml><?xml version="1.0" encoding="utf-8"?>
 <p:sld xmlns:a="http://schemas.openxmlformats.org/drawingml/2006/main" xmlns:p="http://schemas.openxmlformats.org/presentationml/2006/main" xmlns:r="http://schemas.openxmlformats.org/officeDocument/2006/relationships">
   <p:cSld>
@@ -7189,6 +10011,534 @@
               </a:rPr>
               <a:t>{{CHART}}</a:t>
             </a:r>
+          </a:p>
+        </p:txBody>
+      </p:sp>
+    </p:spTree>
+  </p:cSld>
+  <p:clrMapOvr>
+    <a:masterClrMapping/>
+  </p:clrMapOvr>
+</p:sld>
+</file>
+
+<file path=ppt/slides/slide20.xml><?xml version="1.0" encoding="utf-8"?>
+<p:sld xmlns:a="http://schemas.openxmlformats.org/drawingml/2006/main" xmlns:p="http://schemas.openxmlformats.org/presentationml/2006/main" xmlns:r="http://schemas.openxmlformats.org/officeDocument/2006/relationships">
+  <p:cSld>
+    <p:spTree>
+      <p:nvGrpSpPr>
+        <p:cNvPr id="1" name=""/>
+        <p:cNvGrpSpPr/>
+        <p:nvPr/>
+      </p:nvGrpSpPr>
+      <p:grpSpPr/>
+      <p:sp>
+        <p:nvSpPr>
+          <p:cNvPr id="2" name="Rectangle 1"/>
+          <p:cNvSpPr/>
+          <p:nvPr/>
+        </p:nvSpPr>
+        <p:spPr>
+          <a:xfrm>
+            <a:off x="0" y="0"/>
+            <a:ext cx="8129016" cy="75895"/>
+          </a:xfrm>
+          <a:prstGeom prst="rect">
+            <a:avLst/>
+          </a:prstGeom>
+          <a:solidFill>
+            <a:srgbClr val="D62839"/>
+          </a:solidFill>
+          <a:ln>
+            <a:noFill/>
+          </a:ln>
+          <a:effectLst/>
+        </p:spPr>
+        <p:style>
+          <a:lnRef idx="1">
+            <a:schemeClr val="accent1"/>
+          </a:lnRef>
+          <a:fillRef idx="3">
+            <a:schemeClr val="accent1"/>
+          </a:fillRef>
+          <a:effectRef idx="2">
+            <a:schemeClr val="accent1"/>
+          </a:effectRef>
+          <a:fontRef idx="minor">
+            <a:schemeClr val="lt1"/>
+          </a:fontRef>
+        </p:style>
+        <p:txBody>
+          <a:bodyPr rtlCol="0" anchor="ctr"/>
+          <a:lstStyle/>
+          <a:p>
+            <a:pPr algn="ctr"/>
+          </a:p>
+        </p:txBody>
+      </p:sp>
+      <p:sp>
+        <p:nvSpPr>
+          <p:cNvPr id="3" name="Rectangle 2"/>
+          <p:cNvSpPr/>
+          <p:nvPr/>
+        </p:nvSpPr>
+        <p:spPr>
+          <a:xfrm>
+            <a:off x="8129016" y="0"/>
+            <a:ext cx="4059935" cy="75895"/>
+          </a:xfrm>
+          <a:prstGeom prst="rect">
+            <a:avLst/>
+          </a:prstGeom>
+          <a:solidFill>
+            <a:srgbClr val="2A9D8F"/>
+          </a:solidFill>
+          <a:ln>
+            <a:noFill/>
+          </a:ln>
+          <a:effectLst/>
+        </p:spPr>
+        <p:style>
+          <a:lnRef idx="1">
+            <a:schemeClr val="accent1"/>
+          </a:lnRef>
+          <a:fillRef idx="3">
+            <a:schemeClr val="accent1"/>
+          </a:fillRef>
+          <a:effectRef idx="2">
+            <a:schemeClr val="accent1"/>
+          </a:effectRef>
+          <a:fontRef idx="minor">
+            <a:schemeClr val="lt1"/>
+          </a:fontRef>
+        </p:style>
+        <p:txBody>
+          <a:bodyPr rtlCol="0" anchor="ctr"/>
+          <a:lstStyle/>
+          <a:p>
+            <a:pPr algn="ctr"/>
+          </a:p>
+        </p:txBody>
+      </p:sp>
+      <p:sp>
+        <p:nvSpPr>
+          <p:cNvPr id="4" name="Rectangle 3"/>
+          <p:cNvSpPr/>
+          <p:nvPr/>
+        </p:nvSpPr>
+        <p:spPr>
+          <a:xfrm>
+            <a:off x="228600" y="274320"/>
+            <a:ext cx="59436" cy="475488"/>
+          </a:xfrm>
+          <a:prstGeom prst="rect">
+            <a:avLst/>
+          </a:prstGeom>
+          <a:solidFill>
+            <a:srgbClr val="D62839"/>
+          </a:solidFill>
+          <a:ln>
+            <a:noFill/>
+          </a:ln>
+          <a:effectLst/>
+        </p:spPr>
+        <p:style>
+          <a:lnRef idx="1">
+            <a:schemeClr val="accent1"/>
+          </a:lnRef>
+          <a:fillRef idx="3">
+            <a:schemeClr val="accent1"/>
+          </a:fillRef>
+          <a:effectRef idx="2">
+            <a:schemeClr val="accent1"/>
+          </a:effectRef>
+          <a:fontRef idx="minor">
+            <a:schemeClr val="lt1"/>
+          </a:fontRef>
+        </p:style>
+        <p:txBody>
+          <a:bodyPr rtlCol="0" anchor="ctr"/>
+          <a:lstStyle/>
+          <a:p>
+            <a:pPr algn="ctr"/>
+          </a:p>
+        </p:txBody>
+      </p:sp>
+      <p:sp>
+        <p:nvSpPr>
+          <p:cNvPr id="5" name="TextBox 4"/>
+          <p:cNvSpPr txBox="1"/>
+          <p:nvPr/>
+        </p:nvSpPr>
+        <p:spPr>
+          <a:xfrm>
+            <a:off x="402336" y="237744"/>
+            <a:ext cx="11338560" cy="475488"/>
+          </a:xfrm>
+          <a:prstGeom prst="rect">
+            <a:avLst/>
+          </a:prstGeom>
+          <a:noFill/>
+        </p:spPr>
+        <p:txBody>
+          <a:bodyPr wrap="square" anchor="t" tIns="0" bIns="0">
+            <a:spAutoFit/>
+          </a:bodyPr>
+          <a:lstStyle/>
+          <a:p>
+            <a:pPr algn="l"/>
+            <a:r>
+              <a:rPr sz="2400" b="1" i="0">
+                <a:solidFill>
+                  <a:srgbClr val="111110"/>
+                </a:solidFill>
+                <a:latin typeface="Oswald"/>
+              </a:rPr>
+              <a:t>{{TITLE}}</a:t>
+            </a:r>
+          </a:p>
+        </p:txBody>
+      </p:sp>
+      <p:sp>
+        <p:nvSpPr>
+          <p:cNvPr id="6" name="TextBox 5"/>
+          <p:cNvSpPr txBox="1"/>
+          <p:nvPr/>
+        </p:nvSpPr>
+        <p:spPr>
+          <a:xfrm>
+            <a:off x="402336" y="731520"/>
+            <a:ext cx="11521440" cy="310896"/>
+          </a:xfrm>
+          <a:prstGeom prst="rect">
+            <a:avLst/>
+          </a:prstGeom>
+          <a:noFill/>
+        </p:spPr>
+        <p:txBody>
+          <a:bodyPr wrap="square" anchor="t" tIns="0" bIns="0">
+            <a:spAutoFit/>
+          </a:bodyPr>
+          <a:lstStyle/>
+          <a:p>
+            <a:pPr algn="l"/>
+            <a:r>
+              <a:rPr sz="1500" b="1" i="0">
+                <a:solidFill>
+                  <a:srgbClr val="2A9D8F"/>
+                </a:solidFill>
+                <a:latin typeface="Roboto Condensed"/>
+              </a:rPr>
+              <a:t>{{SUBHEAD}}</a:t>
+            </a:r>
+          </a:p>
+        </p:txBody>
+      </p:sp>
+      <p:sp>
+        <p:nvSpPr>
+          <p:cNvPr id="7" name="Rectangle 6"/>
+          <p:cNvSpPr/>
+          <p:nvPr/>
+        </p:nvSpPr>
+        <p:spPr>
+          <a:xfrm>
+            <a:off x="0" y="6766560"/>
+            <a:ext cx="12188952" cy="91440"/>
+          </a:xfrm>
+          <a:prstGeom prst="rect">
+            <a:avLst/>
+          </a:prstGeom>
+          <a:solidFill>
+            <a:srgbClr val="2A9D8F"/>
+          </a:solidFill>
+          <a:ln>
+            <a:noFill/>
+          </a:ln>
+          <a:effectLst/>
+        </p:spPr>
+        <p:style>
+          <a:lnRef idx="1">
+            <a:schemeClr val="accent1"/>
+          </a:lnRef>
+          <a:fillRef idx="3">
+            <a:schemeClr val="accent1"/>
+          </a:fillRef>
+          <a:effectRef idx="2">
+            <a:schemeClr val="accent1"/>
+          </a:effectRef>
+          <a:fontRef idx="minor">
+            <a:schemeClr val="lt1"/>
+          </a:fontRef>
+        </p:style>
+        <p:txBody>
+          <a:bodyPr rtlCol="0" anchor="ctr"/>
+          <a:lstStyle/>
+          <a:p>
+            <a:pPr algn="ctr"/>
+          </a:p>
+        </p:txBody>
+      </p:sp>
+    </p:spTree>
+  </p:cSld>
+  <p:clrMapOvr>
+    <a:masterClrMapping/>
+  </p:clrMapOvr>
+</p:sld>
+</file>
+
+<file path=ppt/slides/slide21.xml><?xml version="1.0" encoding="utf-8"?>
+<p:sld xmlns:a="http://schemas.openxmlformats.org/drawingml/2006/main" xmlns:p="http://schemas.openxmlformats.org/presentationml/2006/main" xmlns:r="http://schemas.openxmlformats.org/officeDocument/2006/relationships">
+  <p:cSld>
+    <p:spTree>
+      <p:nvGrpSpPr>
+        <p:cNvPr id="1" name=""/>
+        <p:cNvGrpSpPr/>
+        <p:nvPr/>
+      </p:nvGrpSpPr>
+      <p:grpSpPr/>
+      <p:sp>
+        <p:nvSpPr>
+          <p:cNvPr id="2" name="Rectangle 1"/>
+          <p:cNvSpPr/>
+          <p:nvPr/>
+        </p:nvSpPr>
+        <p:spPr>
+          <a:xfrm>
+            <a:off x="0" y="0"/>
+            <a:ext cx="8129016" cy="75895"/>
+          </a:xfrm>
+          <a:prstGeom prst="rect">
+            <a:avLst/>
+          </a:prstGeom>
+          <a:solidFill>
+            <a:srgbClr val="D62839"/>
+          </a:solidFill>
+          <a:ln>
+            <a:noFill/>
+          </a:ln>
+          <a:effectLst/>
+        </p:spPr>
+        <p:style>
+          <a:lnRef idx="1">
+            <a:schemeClr val="accent1"/>
+          </a:lnRef>
+          <a:fillRef idx="3">
+            <a:schemeClr val="accent1"/>
+          </a:fillRef>
+          <a:effectRef idx="2">
+            <a:schemeClr val="accent1"/>
+          </a:effectRef>
+          <a:fontRef idx="minor">
+            <a:schemeClr val="lt1"/>
+          </a:fontRef>
+        </p:style>
+        <p:txBody>
+          <a:bodyPr rtlCol="0" anchor="ctr"/>
+          <a:lstStyle/>
+          <a:p>
+            <a:pPr algn="ctr"/>
+          </a:p>
+        </p:txBody>
+      </p:sp>
+      <p:sp>
+        <p:nvSpPr>
+          <p:cNvPr id="3" name="Rectangle 2"/>
+          <p:cNvSpPr/>
+          <p:nvPr/>
+        </p:nvSpPr>
+        <p:spPr>
+          <a:xfrm>
+            <a:off x="8129016" y="0"/>
+            <a:ext cx="4059935" cy="75895"/>
+          </a:xfrm>
+          <a:prstGeom prst="rect">
+            <a:avLst/>
+          </a:prstGeom>
+          <a:solidFill>
+            <a:srgbClr val="2A9D8F"/>
+          </a:solidFill>
+          <a:ln>
+            <a:noFill/>
+          </a:ln>
+          <a:effectLst/>
+        </p:spPr>
+        <p:style>
+          <a:lnRef idx="1">
+            <a:schemeClr val="accent1"/>
+          </a:lnRef>
+          <a:fillRef idx="3">
+            <a:schemeClr val="accent1"/>
+          </a:fillRef>
+          <a:effectRef idx="2">
+            <a:schemeClr val="accent1"/>
+          </a:effectRef>
+          <a:fontRef idx="minor">
+            <a:schemeClr val="lt1"/>
+          </a:fontRef>
+        </p:style>
+        <p:txBody>
+          <a:bodyPr rtlCol="0" anchor="ctr"/>
+          <a:lstStyle/>
+          <a:p>
+            <a:pPr algn="ctr"/>
+          </a:p>
+        </p:txBody>
+      </p:sp>
+      <p:sp>
+        <p:nvSpPr>
+          <p:cNvPr id="4" name="Rectangle 3"/>
+          <p:cNvSpPr/>
+          <p:nvPr/>
+        </p:nvSpPr>
+        <p:spPr>
+          <a:xfrm>
+            <a:off x="228600" y="274320"/>
+            <a:ext cx="59436" cy="475488"/>
+          </a:xfrm>
+          <a:prstGeom prst="rect">
+            <a:avLst/>
+          </a:prstGeom>
+          <a:solidFill>
+            <a:srgbClr val="D62839"/>
+          </a:solidFill>
+          <a:ln>
+            <a:noFill/>
+          </a:ln>
+          <a:effectLst/>
+        </p:spPr>
+        <p:style>
+          <a:lnRef idx="1">
+            <a:schemeClr val="accent1"/>
+          </a:lnRef>
+          <a:fillRef idx="3">
+            <a:schemeClr val="accent1"/>
+          </a:fillRef>
+          <a:effectRef idx="2">
+            <a:schemeClr val="accent1"/>
+          </a:effectRef>
+          <a:fontRef idx="minor">
+            <a:schemeClr val="lt1"/>
+          </a:fontRef>
+        </p:style>
+        <p:txBody>
+          <a:bodyPr rtlCol="0" anchor="ctr"/>
+          <a:lstStyle/>
+          <a:p>
+            <a:pPr algn="ctr"/>
+          </a:p>
+        </p:txBody>
+      </p:sp>
+      <p:sp>
+        <p:nvSpPr>
+          <p:cNvPr id="5" name="TextBox 4"/>
+          <p:cNvSpPr txBox="1"/>
+          <p:nvPr/>
+        </p:nvSpPr>
+        <p:spPr>
+          <a:xfrm>
+            <a:off x="402336" y="237744"/>
+            <a:ext cx="11338560" cy="475488"/>
+          </a:xfrm>
+          <a:prstGeom prst="rect">
+            <a:avLst/>
+          </a:prstGeom>
+          <a:noFill/>
+        </p:spPr>
+        <p:txBody>
+          <a:bodyPr wrap="square" anchor="t" tIns="0" bIns="0">
+            <a:spAutoFit/>
+          </a:bodyPr>
+          <a:lstStyle/>
+          <a:p>
+            <a:pPr algn="l"/>
+            <a:r>
+              <a:rPr sz="2400" b="1" i="0">
+                <a:solidFill>
+                  <a:srgbClr val="111110"/>
+                </a:solidFill>
+                <a:latin typeface="Oswald"/>
+              </a:rPr>
+              <a:t>{{TITLE}}</a:t>
+            </a:r>
+          </a:p>
+        </p:txBody>
+      </p:sp>
+      <p:sp>
+        <p:nvSpPr>
+          <p:cNvPr id="6" name="TextBox 5"/>
+          <p:cNvSpPr txBox="1"/>
+          <p:nvPr/>
+        </p:nvSpPr>
+        <p:spPr>
+          <a:xfrm>
+            <a:off x="402336" y="731520"/>
+            <a:ext cx="11521440" cy="310896"/>
+          </a:xfrm>
+          <a:prstGeom prst="rect">
+            <a:avLst/>
+          </a:prstGeom>
+          <a:noFill/>
+        </p:spPr>
+        <p:txBody>
+          <a:bodyPr wrap="square" anchor="t" tIns="0" bIns="0">
+            <a:spAutoFit/>
+          </a:bodyPr>
+          <a:lstStyle/>
+          <a:p>
+            <a:pPr algn="l"/>
+            <a:r>
+              <a:rPr sz="1500" b="1" i="0">
+                <a:solidFill>
+                  <a:srgbClr val="2A9D8F"/>
+                </a:solidFill>
+                <a:latin typeface="Roboto Condensed"/>
+              </a:rPr>
+              <a:t>{{SUBHEAD}}</a:t>
+            </a:r>
+          </a:p>
+        </p:txBody>
+      </p:sp>
+      <p:sp>
+        <p:nvSpPr>
+          <p:cNvPr id="7" name="Rectangle 6"/>
+          <p:cNvSpPr/>
+          <p:nvPr/>
+        </p:nvSpPr>
+        <p:spPr>
+          <a:xfrm>
+            <a:off x="0" y="6766560"/>
+            <a:ext cx="12188952" cy="91440"/>
+          </a:xfrm>
+          <a:prstGeom prst="rect">
+            <a:avLst/>
+          </a:prstGeom>
+          <a:solidFill>
+            <a:srgbClr val="2A9D8F"/>
+          </a:solidFill>
+          <a:ln>
+            <a:noFill/>
+          </a:ln>
+          <a:effectLst/>
+        </p:spPr>
+        <p:style>
+          <a:lnRef idx="1">
+            <a:schemeClr val="accent1"/>
+          </a:lnRef>
+          <a:fillRef idx="3">
+            <a:schemeClr val="accent1"/>
+          </a:fillRef>
+          <a:effectRef idx="2">
+            <a:schemeClr val="accent1"/>
+          </a:effectRef>
+          <a:fontRef idx="minor">
+            <a:schemeClr val="lt1"/>
+          </a:fontRef>
+        </p:style>
+        <p:txBody>
+          <a:bodyPr rtlCol="0" anchor="ctr"/>
+          <a:lstStyle/>
+          <a:p>
+            <a:pPr algn="ctr"/>
           </a:p>
         </p:txBody>
       </p:sp>

</xml_diff>